<commit_message>
Add automatic 1-click PowerPoint sync script from Firebase/Site live data
</commit_message>
<xml_diff>
--- a/Estudo_Viabilidade_Retrofit_HVAC_Novo_Shopping.pptx
+++ b/Estudo_Viabilidade_Retrofit_HVAC_Novo_Shopping.pptx
@@ -3438,6 +3438,10 @@
           </a:solidFill>
           <a:ln/>
         </p:spPr>
+        <p:txBody>
+          <a:bodyPr/>
+          <a:p/>
+        </p:txBody>
       </p:sp>
       <p:sp>
         <p:nvSpPr>
@@ -3458,6 +3462,10 @@
           </a:solidFill>
           <a:ln/>
         </p:spPr>
+        <p:txBody>
+          <a:bodyPr/>
+          <a:p/>
+        </p:txBody>
       </p:sp>
       <p:sp>
         <p:nvSpPr>
@@ -3478,6 +3486,10 @@
           </a:solidFill>
           <a:ln/>
         </p:spPr>
+        <p:txBody>
+          <a:bodyPr/>
+          <a:p/>
+        </p:txBody>
       </p:sp>
       <p:sp>
         <p:nvSpPr>
@@ -3579,6 +3591,10 @@
             <a:prstDash val="solid"/>
           </a:ln>
         </p:spPr>
+        <p:txBody>
+          <a:bodyPr/>
+          <a:p/>
+        </p:txBody>
       </p:sp>
       <p:sp>
         <p:nvSpPr>
@@ -4116,25 +4132,9 @@
                     <a:bodyPr/>
                     <a:lstStyle/>
                     <a:p>
-                      <a:pPr algn="ctr" indent="0" marL="0">
-                        <a:buNone/>
-                      </a:pPr>
                       <a:r>
-                        <a:rPr lang="en-US" sz="1150" dirty="0">
-                          <a:solidFill>
-                            <a:srgbClr val="1E2761"/>
-                          </a:solidFill>
-                          <a:latin typeface="Calibri" pitchFamily="34" charset="0"/>
-                          <a:ea typeface="Calibri" pitchFamily="34" charset="-122"/>
-                          <a:cs typeface="Calibri" pitchFamily="34" charset="-120"/>
-                        </a:rPr>
                         <a:t>237.000 kWh</a:t>
                       </a:r>
-                      <a:endParaRPr lang="en-US" sz="1150" dirty="0">
-                        <a:latin typeface="Calibri" charset="0"/>
-                        <a:ea typeface="Calibri" charset="0"/>
-                        <a:cs typeface="Calibri" charset="0"/>
-                      </a:endParaRPr>
                     </a:p>
                   </a:txBody>
                   <a:tcPr marL="91440" marR="91440" marT="45720" marB="45720" anchor="ctr">
@@ -4160,25 +4160,9 @@
                     <a:bodyPr/>
                     <a:lstStyle/>
                     <a:p>
-                      <a:pPr algn="ctr" indent="0" marL="0">
-                        <a:buNone/>
-                      </a:pPr>
                       <a:r>
-                        <a:rPr lang="en-US" sz="1150" dirty="0">
-                          <a:solidFill>
-                            <a:srgbClr val="1E2761"/>
-                          </a:solidFill>
-                          <a:latin typeface="Calibri" pitchFamily="34" charset="0"/>
-                          <a:ea typeface="Calibri" pitchFamily="34" charset="-122"/>
-                          <a:cs typeface="Calibri" pitchFamily="34" charset="-120"/>
-                        </a:rPr>
                         <a:t>212.813 kWh</a:t>
                       </a:r>
-                      <a:endParaRPr lang="en-US" sz="1150" dirty="0">
-                        <a:latin typeface="Calibri" charset="0"/>
-                        <a:ea typeface="Calibri" charset="0"/>
-                        <a:cs typeface="Calibri" charset="0"/>
-                      </a:endParaRPr>
                     </a:p>
                   </a:txBody>
                   <a:tcPr marL="91440" marR="91440" marT="45720" marB="45720" anchor="ctr">
@@ -4204,25 +4188,9 @@
                     <a:bodyPr/>
                     <a:lstStyle/>
                     <a:p>
-                      <a:pPr algn="ctr" indent="0" marL="0">
-                        <a:buNone/>
-                      </a:pPr>
                       <a:r>
-                        <a:rPr lang="en-US" sz="1150" dirty="0">
-                          <a:solidFill>
-                            <a:srgbClr val="1E2761"/>
-                          </a:solidFill>
-                          <a:latin typeface="Calibri" pitchFamily="34" charset="0"/>
-                          <a:ea typeface="Calibri" pitchFamily="34" charset="-122"/>
-                          <a:cs typeface="Calibri" pitchFamily="34" charset="-120"/>
-                        </a:rPr>
                         <a:t>24.187 kWh</a:t>
                       </a:r>
-                      <a:endParaRPr lang="en-US" sz="1150" dirty="0">
-                        <a:latin typeface="Calibri" charset="0"/>
-                        <a:ea typeface="Calibri" charset="0"/>
-                        <a:cs typeface="Calibri" charset="0"/>
-                      </a:endParaRPr>
                     </a:p>
                   </a:txBody>
                   <a:tcPr marL="91440" marR="91440" marT="45720" marB="45720" anchor="ctr">
@@ -4248,25 +4216,9 @@
                     <a:bodyPr/>
                     <a:lstStyle/>
                     <a:p>
-                      <a:pPr algn="ctr" indent="0" marL="0">
-                        <a:buNone/>
-                      </a:pPr>
                       <a:r>
-                        <a:rPr lang="en-US" sz="1150" b="1" dirty="0">
-                          <a:solidFill>
-                            <a:srgbClr val="028090"/>
-                          </a:solidFill>
-                          <a:latin typeface="Calibri" pitchFamily="34" charset="0"/>
-                          <a:ea typeface="Calibri" pitchFamily="34" charset="-122"/>
-                          <a:cs typeface="Calibri" pitchFamily="34" charset="-120"/>
-                        </a:rPr>
                         <a:t>-10,2%</a:t>
                       </a:r>
-                      <a:endParaRPr lang="en-US" sz="1150" dirty="0">
-                        <a:latin typeface="Calibri" charset="0"/>
-                        <a:ea typeface="Calibri" charset="0"/>
-                        <a:cs typeface="Calibri" charset="0"/>
-                      </a:endParaRPr>
                     </a:p>
                   </a:txBody>
                   <a:tcPr marL="91440" marR="91440" marT="45720" marB="45720" anchor="ctr">
@@ -4338,25 +4290,9 @@
                     <a:bodyPr/>
                     <a:lstStyle/>
                     <a:p>
-                      <a:pPr algn="ctr" indent="0" marL="0">
-                        <a:buNone/>
-                      </a:pPr>
                       <a:r>
-                        <a:rPr lang="en-US" sz="1150" dirty="0">
-                          <a:solidFill>
-                            <a:srgbClr val="1E2761"/>
-                          </a:solidFill>
-                          <a:latin typeface="Calibri" pitchFamily="34" charset="0"/>
-                          <a:ea typeface="Calibri" pitchFamily="34" charset="-122"/>
-                          <a:cs typeface="Calibri" pitchFamily="34" charset="-120"/>
-                        </a:rPr>
                         <a:t>2.843.999 kWh</a:t>
                       </a:r>
-                      <a:endParaRPr lang="en-US" sz="1150" dirty="0">
-                        <a:latin typeface="Calibri" charset="0"/>
-                        <a:ea typeface="Calibri" charset="0"/>
-                        <a:cs typeface="Calibri" charset="0"/>
-                      </a:endParaRPr>
                     </a:p>
                   </a:txBody>
                   <a:tcPr marL="91440" marR="91440" marT="45720" marB="45720" anchor="ctr">
@@ -4382,25 +4318,9 @@
                     <a:bodyPr/>
                     <a:lstStyle/>
                     <a:p>
-                      <a:pPr algn="ctr" indent="0" marL="0">
-                        <a:buNone/>
-                      </a:pPr>
                       <a:r>
-                        <a:rPr lang="en-US" sz="1150" dirty="0">
-                          <a:solidFill>
-                            <a:srgbClr val="1E2761"/>
-                          </a:solidFill>
-                          <a:latin typeface="Calibri" pitchFamily="34" charset="0"/>
-                          <a:ea typeface="Calibri" pitchFamily="34" charset="-122"/>
-                          <a:cs typeface="Calibri" pitchFamily="34" charset="-120"/>
-                        </a:rPr>
                         <a:t>2.553.751 kWh</a:t>
                       </a:r>
-                      <a:endParaRPr lang="en-US" sz="1150" dirty="0">
-                        <a:latin typeface="Calibri" charset="0"/>
-                        <a:ea typeface="Calibri" charset="0"/>
-                        <a:cs typeface="Calibri" charset="0"/>
-                      </a:endParaRPr>
                     </a:p>
                   </a:txBody>
                   <a:tcPr marL="91440" marR="91440" marT="45720" marB="45720" anchor="ctr">
@@ -4426,25 +4346,9 @@
                     <a:bodyPr/>
                     <a:lstStyle/>
                     <a:p>
-                      <a:pPr algn="ctr" indent="0" marL="0">
-                        <a:buNone/>
-                      </a:pPr>
                       <a:r>
-                        <a:rPr lang="en-US" sz="1150" dirty="0">
-                          <a:solidFill>
-                            <a:srgbClr val="1E2761"/>
-                          </a:solidFill>
-                          <a:latin typeface="Calibri" pitchFamily="34" charset="0"/>
-                          <a:ea typeface="Calibri" pitchFamily="34" charset="-122"/>
-                          <a:cs typeface="Calibri" pitchFamily="34" charset="-120"/>
-                        </a:rPr>
                         <a:t>290.249 kWh</a:t>
                       </a:r>
-                      <a:endParaRPr lang="en-US" sz="1150" dirty="0">
-                        <a:latin typeface="Calibri" charset="0"/>
-                        <a:ea typeface="Calibri" charset="0"/>
-                        <a:cs typeface="Calibri" charset="0"/>
-                      </a:endParaRPr>
                     </a:p>
                   </a:txBody>
                   <a:tcPr marL="91440" marR="91440" marT="45720" marB="45720" anchor="ctr">
@@ -4470,25 +4374,9 @@
                     <a:bodyPr/>
                     <a:lstStyle/>
                     <a:p>
-                      <a:pPr algn="ctr" indent="0" marL="0">
-                        <a:buNone/>
-                      </a:pPr>
                       <a:r>
-                        <a:rPr lang="en-US" sz="1150" b="1" dirty="0">
-                          <a:solidFill>
-                            <a:srgbClr val="028090"/>
-                          </a:solidFill>
-                          <a:latin typeface="Calibri" pitchFamily="34" charset="0"/>
-                          <a:ea typeface="Calibri" pitchFamily="34" charset="-122"/>
-                          <a:cs typeface="Calibri" pitchFamily="34" charset="-120"/>
-                        </a:rPr>
                         <a:t>-10,2%</a:t>
                       </a:r>
-                      <a:endParaRPr lang="en-US" sz="1150" dirty="0">
-                        <a:latin typeface="Calibri" charset="0"/>
-                        <a:ea typeface="Calibri" charset="0"/>
-                        <a:cs typeface="Calibri" charset="0"/>
-                      </a:endParaRPr>
                     </a:p>
                   </a:txBody>
                   <a:tcPr marL="91440" marR="91440" marT="45720" marB="45720" anchor="ctr">
@@ -4560,25 +4448,9 @@
                     <a:bodyPr/>
                     <a:lstStyle/>
                     <a:p>
-                      <a:pPr algn="ctr" indent="0" marL="0">
-                        <a:buNone/>
-                      </a:pPr>
                       <a:r>
-                        <a:rPr lang="en-US" sz="1150" dirty="0">
-                          <a:solidFill>
-                            <a:srgbClr val="1E2761"/>
-                          </a:solidFill>
-                          <a:latin typeface="Calibri" pitchFamily="34" charset="0"/>
-                          <a:ea typeface="Calibri" pitchFamily="34" charset="-122"/>
-                          <a:cs typeface="Calibri" pitchFamily="34" charset="-120"/>
-                        </a:rPr>
                         <a:t>R$ 177.749,96</a:t>
                       </a:r>
-                      <a:endParaRPr lang="en-US" sz="1150" dirty="0">
-                        <a:latin typeface="Calibri" charset="0"/>
-                        <a:ea typeface="Calibri" charset="0"/>
-                        <a:cs typeface="Calibri" charset="0"/>
-                      </a:endParaRPr>
                     </a:p>
                   </a:txBody>
                   <a:tcPr marL="91440" marR="91440" marT="45720" marB="45720" anchor="ctr">
@@ -4604,25 +4476,9 @@
                     <a:bodyPr/>
                     <a:lstStyle/>
                     <a:p>
-                      <a:pPr algn="ctr" indent="0" marL="0">
-                        <a:buNone/>
-                      </a:pPr>
                       <a:r>
-                        <a:rPr lang="en-US" sz="1150" dirty="0">
-                          <a:solidFill>
-                            <a:srgbClr val="1E2761"/>
-                          </a:solidFill>
-                          <a:latin typeface="Calibri" pitchFamily="34" charset="0"/>
-                          <a:ea typeface="Calibri" pitchFamily="34" charset="-122"/>
-                          <a:cs typeface="Calibri" pitchFamily="34" charset="-120"/>
-                        </a:rPr>
                         <a:t>R$ 159.609,43</a:t>
                       </a:r>
-                      <a:endParaRPr lang="en-US" sz="1150" dirty="0">
-                        <a:latin typeface="Calibri" charset="0"/>
-                        <a:ea typeface="Calibri" charset="0"/>
-                        <a:cs typeface="Calibri" charset="0"/>
-                      </a:endParaRPr>
                     </a:p>
                   </a:txBody>
                   <a:tcPr marL="91440" marR="91440" marT="45720" marB="45720" anchor="ctr">
@@ -4648,25 +4504,9 @@
                     <a:bodyPr/>
                     <a:lstStyle/>
                     <a:p>
-                      <a:pPr algn="ctr" indent="0" marL="0">
-                        <a:buNone/>
-                      </a:pPr>
                       <a:r>
-                        <a:rPr lang="en-US" sz="1150" dirty="0">
-                          <a:solidFill>
-                            <a:srgbClr val="1E2761"/>
-                          </a:solidFill>
-                          <a:latin typeface="Calibri" pitchFamily="34" charset="0"/>
-                          <a:ea typeface="Calibri" pitchFamily="34" charset="-122"/>
-                          <a:cs typeface="Calibri" pitchFamily="34" charset="-120"/>
-                        </a:rPr>
-                        <a:t>R$ 18.140,53</a:t>
+                        <a:t>R$ 18.140,54</a:t>
                       </a:r>
-                      <a:endParaRPr lang="en-US" sz="1150" dirty="0">
-                        <a:latin typeface="Calibri" charset="0"/>
-                        <a:ea typeface="Calibri" charset="0"/>
-                        <a:cs typeface="Calibri" charset="0"/>
-                      </a:endParaRPr>
                     </a:p>
                   </a:txBody>
                   <a:tcPr marL="91440" marR="91440" marT="45720" marB="45720" anchor="ctr">
@@ -4692,25 +4532,9 @@
                     <a:bodyPr/>
                     <a:lstStyle/>
                     <a:p>
-                      <a:pPr algn="ctr" indent="0" marL="0">
-                        <a:buNone/>
-                      </a:pPr>
                       <a:r>
-                        <a:rPr lang="en-US" sz="1150" b="1" dirty="0">
-                          <a:solidFill>
-                            <a:srgbClr val="028090"/>
-                          </a:solidFill>
-                          <a:latin typeface="Calibri" pitchFamily="34" charset="0"/>
-                          <a:ea typeface="Calibri" pitchFamily="34" charset="-122"/>
-                          <a:cs typeface="Calibri" pitchFamily="34" charset="-120"/>
-                        </a:rPr>
                         <a:t>-10,2%</a:t>
                       </a:r>
-                      <a:endParaRPr lang="en-US" sz="1150" dirty="0">
-                        <a:latin typeface="Calibri" charset="0"/>
-                        <a:ea typeface="Calibri" charset="0"/>
-                        <a:cs typeface="Calibri" charset="0"/>
-                      </a:endParaRPr>
                     </a:p>
                   </a:txBody>
                   <a:tcPr marL="91440" marR="91440" marT="45720" marB="45720" anchor="ctr">
@@ -4782,25 +4606,9 @@
                     <a:bodyPr/>
                     <a:lstStyle/>
                     <a:p>
-                      <a:pPr algn="ctr" indent="0" marL="0">
-                        <a:buNone/>
-                      </a:pPr>
                       <a:r>
-                        <a:rPr lang="en-US" sz="1150" dirty="0">
-                          <a:solidFill>
-                            <a:srgbClr val="1E2761"/>
-                          </a:solidFill>
-                          <a:latin typeface="Calibri" pitchFamily="34" charset="0"/>
-                          <a:ea typeface="Calibri" pitchFamily="34" charset="-122"/>
-                          <a:cs typeface="Calibri" pitchFamily="34" charset="-120"/>
-                        </a:rPr>
                         <a:t>R$ 2.132.999,57</a:t>
                       </a:r>
-                      <a:endParaRPr lang="en-US" sz="1150" dirty="0">
-                        <a:latin typeface="Calibri" charset="0"/>
-                        <a:ea typeface="Calibri" charset="0"/>
-                        <a:cs typeface="Calibri" charset="0"/>
-                      </a:endParaRPr>
                     </a:p>
                   </a:txBody>
                   <a:tcPr marL="91440" marR="91440" marT="45720" marB="45720" anchor="ctr">
@@ -4826,25 +4634,9 @@
                     <a:bodyPr/>
                     <a:lstStyle/>
                     <a:p>
-                      <a:pPr algn="ctr" indent="0" marL="0">
-                        <a:buNone/>
-                      </a:pPr>
                       <a:r>
-                        <a:rPr lang="en-US" sz="1150" dirty="0">
-                          <a:solidFill>
-                            <a:srgbClr val="1E2761"/>
-                          </a:solidFill>
-                          <a:latin typeface="Calibri" pitchFamily="34" charset="0"/>
-                          <a:ea typeface="Calibri" pitchFamily="34" charset="-122"/>
-                          <a:cs typeface="Calibri" pitchFamily="34" charset="-120"/>
-                        </a:rPr>
                         <a:t>R$ 1.915.313,15</a:t>
                       </a:r>
-                      <a:endParaRPr lang="en-US" sz="1150" dirty="0">
-                        <a:latin typeface="Calibri" charset="0"/>
-                        <a:ea typeface="Calibri" charset="0"/>
-                        <a:cs typeface="Calibri" charset="0"/>
-                      </a:endParaRPr>
                     </a:p>
                   </a:txBody>
                   <a:tcPr marL="91440" marR="91440" marT="45720" marB="45720" anchor="ctr">
@@ -4870,25 +4662,9 @@
                     <a:bodyPr/>
                     <a:lstStyle/>
                     <a:p>
-                      <a:pPr algn="ctr" indent="0" marL="0">
-                        <a:buNone/>
-                      </a:pPr>
                       <a:r>
-                        <a:rPr lang="en-US" sz="1150" dirty="0">
-                          <a:solidFill>
-                            <a:srgbClr val="1E2761"/>
-                          </a:solidFill>
-                          <a:latin typeface="Calibri" pitchFamily="34" charset="0"/>
-                          <a:ea typeface="Calibri" pitchFamily="34" charset="-122"/>
-                          <a:cs typeface="Calibri" pitchFamily="34" charset="-120"/>
-                        </a:rPr>
                         <a:t>R$ 217.686,42</a:t>
                       </a:r>
-                      <a:endParaRPr lang="en-US" sz="1150" dirty="0">
-                        <a:latin typeface="Calibri" charset="0"/>
-                        <a:ea typeface="Calibri" charset="0"/>
-                        <a:cs typeface="Calibri" charset="0"/>
-                      </a:endParaRPr>
                     </a:p>
                   </a:txBody>
                   <a:tcPr marL="91440" marR="91440" marT="45720" marB="45720" anchor="ctr">
@@ -4914,25 +4690,9 @@
                     <a:bodyPr/>
                     <a:lstStyle/>
                     <a:p>
-                      <a:pPr algn="ctr" indent="0" marL="0">
-                        <a:buNone/>
-                      </a:pPr>
                       <a:r>
-                        <a:rPr lang="en-US" sz="1150" b="1" dirty="0">
-                          <a:solidFill>
-                            <a:srgbClr val="028090"/>
-                          </a:solidFill>
-                          <a:latin typeface="Calibri" pitchFamily="34" charset="0"/>
-                          <a:ea typeface="Calibri" pitchFamily="34" charset="-122"/>
-                          <a:cs typeface="Calibri" pitchFamily="34" charset="-120"/>
-                        </a:rPr>
                         <a:t>-10,2%</a:t>
                       </a:r>
-                      <a:endParaRPr lang="en-US" sz="1150" dirty="0">
-                        <a:latin typeface="Calibri" charset="0"/>
-                        <a:ea typeface="Calibri" charset="0"/>
-                        <a:cs typeface="Calibri" charset="0"/>
-                      </a:endParaRPr>
                     </a:p>
                   </a:txBody>
                   <a:tcPr marL="91440" marR="91440" marT="45720" marB="45720" anchor="ctr">
@@ -5245,6 +5005,10 @@
             </a:outerShdw>
           </a:effectLst>
         </p:spPr>
+        <p:txBody>
+          <a:bodyPr/>
+          <a:p/>
+        </p:txBody>
       </p:sp>
       <p:sp>
         <p:nvSpPr>
@@ -5352,6 +5116,10 @@
             </a:outerShdw>
           </a:effectLst>
         </p:spPr>
+        <p:txBody>
+          <a:bodyPr/>
+          <a:p/>
+        </p:txBody>
       </p:sp>
       <p:sp>
         <p:nvSpPr>
@@ -5378,15 +5146,7 @@
               <a:buNone/>
             </a:pPr>
             <a:r>
-              <a:rPr lang="en-US" sz="2200" b="1" dirty="0">
-                <a:solidFill>
-                  <a:srgbClr val="028090"/>
-                </a:solidFill>
-                <a:latin typeface="Cambria" pitchFamily="34" charset="0"/>
-                <a:ea typeface="Cambria" pitchFamily="34" charset="-122"/>
-                <a:cs typeface="Cambria" pitchFamily="34" charset="-120"/>
-              </a:rPr>
-              <a:t>16,6 meses</a:t>
+              <a:t>16,5 meses</a:t>
             </a:r>
             <a:endParaRPr lang="en-US" sz="2200" dirty="0"/>
           </a:p>
@@ -5459,6 +5219,10 @@
             </a:outerShdw>
           </a:effectLst>
         </p:spPr>
+        <p:txBody>
+          <a:bodyPr/>
+          <a:p/>
+        </p:txBody>
       </p:sp>
       <p:sp>
         <p:nvSpPr>
@@ -5485,15 +5249,7 @@
               <a:buNone/>
             </a:pPr>
             <a:r>
-              <a:rPr lang="en-US" sz="2200" b="1" dirty="0">
-                <a:solidFill>
-                  <a:srgbClr val="1E2761"/>
-                </a:solidFill>
-                <a:latin typeface="Cambria" pitchFamily="34" charset="0"/>
-                <a:ea typeface="Cambria" pitchFamily="34" charset="-122"/>
-                <a:cs typeface="Cambria" pitchFamily="34" charset="-120"/>
-              </a:rPr>
-              <a:t>+261,6%</a:t>
+              <a:t>+262,8%</a:t>
             </a:r>
             <a:endParaRPr lang="en-US" sz="2200" dirty="0"/>
           </a:p>
@@ -5566,6 +5322,10 @@
             </a:outerShdw>
           </a:effectLst>
         </p:spPr>
+        <p:txBody>
+          <a:bodyPr/>
+          <a:p/>
+        </p:txBody>
       </p:sp>
       <p:sp>
         <p:nvSpPr>
@@ -5592,15 +5352,7 @@
               <a:buNone/>
             </a:pPr>
             <a:r>
-              <a:rPr lang="en-US" sz="2200" b="1" dirty="0">
-                <a:solidFill>
-                  <a:srgbClr val="028090"/>
-                </a:solidFill>
-                <a:latin typeface="Cambria" pitchFamily="34" charset="0"/>
-                <a:ea typeface="Cambria" pitchFamily="34" charset="-122"/>
-                <a:cs typeface="Cambria" pitchFamily="34" charset="-120"/>
-              </a:rPr>
-              <a:t>R$ 483.710</a:t>
+              <a:t>R$ 484.710</a:t>
             </a:r>
             <a:endParaRPr lang="en-US" sz="2200" dirty="0"/>
           </a:p>
@@ -5721,6 +5473,10 @@
           </a:solidFill>
           <a:ln/>
         </p:spPr>
+        <p:txBody>
+          <a:bodyPr/>
+          <a:p/>
+        </p:txBody>
       </p:sp>
       <p:sp>
         <p:nvSpPr>
@@ -5822,6 +5578,10 @@
             <a:prstDash val="solid"/>
           </a:ln>
         </p:spPr>
+        <p:txBody>
+          <a:bodyPr/>
+          <a:p/>
+        </p:txBody>
       </p:sp>
       <p:sp>
         <p:nvSpPr>
@@ -5923,6 +5683,10 @@
             <a:prstDash val="solid"/>
           </a:ln>
         </p:spPr>
+        <p:txBody>
+          <a:bodyPr/>
+          <a:p/>
+        </p:txBody>
       </p:sp>
       <p:sp>
         <p:nvSpPr>
@@ -6172,6 +5936,10 @@
           </a:solidFill>
           <a:ln/>
         </p:spPr>
+        <p:txBody>
+          <a:bodyPr/>
+          <a:p/>
+        </p:txBody>
       </p:sp>
       <p:sp>
         <p:nvSpPr>
@@ -6198,14 +5966,6 @@
               <a:buNone/>
             </a:pPr>
             <a:r>
-              <a:rPr lang="en-US" sz="3400" b="1" dirty="0">
-                <a:solidFill>
-                  <a:srgbClr val="00A896"/>
-                </a:solidFill>
-                <a:latin typeface="Cambria" pitchFamily="34" charset="0"/>
-                <a:ea typeface="Cambria" pitchFamily="34" charset="-122"/>
-                <a:cs typeface="Cambria" pitchFamily="34" charset="-120"/>
-              </a:rPr>
               <a:t>25,0 tCO2/ano</a:t>
             </a:r>
             <a:endParaRPr lang="en-US" sz="3400" dirty="0"/>
@@ -6273,6 +6033,10 @@
             <a:prstDash val="solid"/>
           </a:ln>
         </p:spPr>
+        <p:txBody>
+          <a:bodyPr/>
+          <a:p/>
+        </p:txBody>
       </p:sp>
       <p:sp>
         <p:nvSpPr>
@@ -6301,52 +6065,18 @@
               </a:lnSpc>
               <a:buNone/>
             </a:pPr>
-            <a:r>
-              <a:rPr lang="en-US" sz="1250" b="1" dirty="0">
-                <a:solidFill>
-                  <a:srgbClr val="FFFFFF"/>
-                </a:solidFill>
-                <a:latin typeface="Calibri" pitchFamily="34" charset="0"/>
-                <a:ea typeface="Calibri" pitchFamily="34" charset="-122"/>
-                <a:cs typeface="Calibri" pitchFamily="34" charset="-120"/>
-              </a:rPr>
-              <a:t>290.249 kWh/ano </a:t>
-            </a:r>
             <a:pPr indent="0" marL="0">
               <a:lnSpc>
                 <a:spcPct val="150000"/>
               </a:lnSpc>
               <a:buNone/>
             </a:pPr>
-            <a:r>
-              <a:rPr lang="en-US" sz="1250" dirty="0">
-                <a:solidFill>
-                  <a:srgbClr val="CADCFC"/>
-                </a:solidFill>
-                <a:latin typeface="Calibri" pitchFamily="34" charset="0"/>
-                <a:ea typeface="Calibri" pitchFamily="34" charset="-122"/>
-                <a:cs typeface="Calibri" pitchFamily="34" charset="-120"/>
-              </a:rPr>
-              <a:t>de energia economizada
-</a:t>
-            </a:r>
             <a:pPr indent="0" marL="0">
               <a:lnSpc>
                 <a:spcPct val="150000"/>
               </a:lnSpc>
               <a:buNone/>
             </a:pPr>
-            <a:r>
-              <a:rPr lang="en-US" sz="1250" b="1" dirty="0">
-                <a:solidFill>
-                  <a:srgbClr val="FFFFFF"/>
-                </a:solidFill>
-                <a:latin typeface="Calibri" pitchFamily="34" charset="0"/>
-                <a:ea typeface="Calibri" pitchFamily="34" charset="-122"/>
-                <a:cs typeface="Calibri" pitchFamily="34" charset="-120"/>
-              </a:rPr>
-              <a:t>0,086 kg CO2/kWh </a:t>
-            </a:r>
             <a:pPr indent="0" marL="0">
               <a:lnSpc>
                 <a:spcPct val="150000"/>
@@ -6354,29 +6084,166 @@
               <a:buNone/>
             </a:pPr>
             <a:r>
-              <a:rPr lang="en-US" sz="1250" dirty="0">
-                <a:solidFill>
-                  <a:srgbClr val="CADCFC"/>
+              <a:t>290.249 kWh/ano de energia economizada</a:t>
+            </a:r>
+            <a:br/>
+            <a:r>
+              <a:t>0,086 kg CO2/kWh fator de emissão (SIN / MCTI)</a:t>
+            </a:r>
+            <a:endParaRPr lang="en-US" sz="1250" dirty="0"/>
+          </a:p>
+        </p:txBody>
+      </p:sp>
+      <p:sp>
+        <p:nvSpPr>
+          <p:cNvPr id="8" name="Shape 6"/>
+          <p:cNvSpPr/>
+          <p:nvPr/>
+        </p:nvSpPr>
+        <p:spPr>
+          <a:xfrm>
+            <a:off x="6126480" y="1371600"/>
+            <a:ext cx="640080" cy="640080"/>
+          </a:xfrm>
+          <a:prstGeom prst="ellipse">
+            <a:avLst/>
+          </a:prstGeom>
+          <a:solidFill>
+            <a:srgbClr val="00A896"/>
+          </a:solidFill>
+          <a:ln/>
+        </p:spPr>
+        <p:txBody>
+          <a:bodyPr/>
+          <a:p/>
+        </p:txBody>
+      </p:sp>
+      <p:sp>
+        <p:nvSpPr>
+          <p:cNvPr id="9" name="Text 7"/>
+          <p:cNvSpPr txBox="1"/>
+          <p:nvPr/>
+        </p:nvSpPr>
+        <p:spPr>
+          <a:xfrm>
+            <a:off x="6126480" y="1371600"/>
+            <a:ext cx="640080" cy="640080"/>
+          </a:xfrm>
+          <a:prstGeom prst="rect">
+            <a:avLst/>
+          </a:prstGeom>
+          <a:noFill/>
+          <a:ln/>
+        </p:spPr>
+        <p:txBody>
+          <a:bodyPr wrap="square" lIns="0" tIns="0" rIns="0" bIns="0" rtlCol="0" anchor="ctr"/>
+          <a:lstStyle/>
+          <a:p>
+            <a:pPr algn="ctr" indent="0" marL="0">
+              <a:buNone/>
+            </a:pPr>
+            <a:r>
+              <a:rPr lang="en-US" sz="1800" b="1" dirty="0">
+                <a:solidFill>
+                  <a:srgbClr val="FFFFFF"/>
                 </a:solidFill>
                 <a:latin typeface="Calibri" pitchFamily="34" charset="0"/>
                 <a:ea typeface="Calibri" pitchFamily="34" charset="-122"/>
                 <a:cs typeface="Calibri" pitchFamily="34" charset="-120"/>
               </a:rPr>
-              <a:t>fator de emissão (SIN / MCTI)</a:t>
-            </a:r>
-            <a:endParaRPr lang="en-US" sz="1250" dirty="0"/>
-          </a:p>
-        </p:txBody>
-      </p:sp>
-      <p:sp>
-        <p:nvSpPr>
-          <p:cNvPr id="8" name="Shape 6"/>
+              <a:t>1.560</a:t>
+            </a:r>
+            <a:endParaRPr lang="en-US" sz="1800" dirty="0"/>
+          </a:p>
+        </p:txBody>
+      </p:sp>
+      <p:sp>
+        <p:nvSpPr>
+          <p:cNvPr id="10" name="Text 8"/>
+          <p:cNvSpPr txBox="1"/>
+          <p:nvPr/>
+        </p:nvSpPr>
+        <p:spPr>
+          <a:xfrm>
+            <a:off x="6949440" y="1353312"/>
+            <a:ext cx="4572000" cy="365760"/>
+          </a:xfrm>
+          <a:prstGeom prst="rect">
+            <a:avLst/>
+          </a:prstGeom>
+          <a:noFill/>
+          <a:ln/>
+        </p:spPr>
+        <p:txBody>
+          <a:bodyPr wrap="square" lIns="0" tIns="0" rIns="0" bIns="0" rtlCol="0" anchor="ctr"/>
+          <a:lstStyle/>
+          <a:p>
+            <a:pPr indent="0" marL="0">
+              <a:buNone/>
+            </a:pPr>
+            <a:r>
+              <a:rPr lang="en-US" sz="1600" b="1" dirty="0">
+                <a:solidFill>
+                  <a:srgbClr val="1E2761"/>
+                </a:solidFill>
+                <a:latin typeface="Cambria" pitchFamily="34" charset="0"/>
+                <a:ea typeface="Cambria" pitchFamily="34" charset="-122"/>
+                <a:cs typeface="Cambria" pitchFamily="34" charset="-120"/>
+              </a:rPr>
+              <a:t>~1.560 árvores</a:t>
+            </a:r>
+            <a:endParaRPr lang="en-US" sz="1600" dirty="0"/>
+          </a:p>
+        </p:txBody>
+      </p:sp>
+      <p:sp>
+        <p:nvSpPr>
+          <p:cNvPr id="11" name="Text 9"/>
+          <p:cNvSpPr txBox="1"/>
+          <p:nvPr/>
+        </p:nvSpPr>
+        <p:spPr>
+          <a:xfrm>
+            <a:off x="6949440" y="1691640"/>
+            <a:ext cx="4572000" cy="594360"/>
+          </a:xfrm>
+          <a:prstGeom prst="rect">
+            <a:avLst/>
+          </a:prstGeom>
+          <a:noFill/>
+          <a:ln/>
+        </p:spPr>
+        <p:txBody>
+          <a:bodyPr wrap="square" lIns="0" tIns="0" rIns="0" bIns="0" rtlCol="0" anchor="ctr"/>
+          <a:lstStyle/>
+          <a:p>
+            <a:pPr indent="0" marL="0">
+              <a:buNone/>
+            </a:pPr>
+            <a:r>
+              <a:rPr lang="en-US" sz="1150" dirty="0">
+                <a:solidFill>
+                  <a:srgbClr val="5A6472"/>
+                </a:solidFill>
+                <a:latin typeface="Calibri" pitchFamily="34" charset="0"/>
+                <a:ea typeface="Calibri" pitchFamily="34" charset="-122"/>
+                <a:cs typeface="Calibri" pitchFamily="34" charset="-120"/>
+              </a:rPr>
+              <a:t>plantadas e preservadas por ano para absorver o mesmo volume de carbono</a:t>
+            </a:r>
+            <a:endParaRPr lang="en-US" sz="1150" dirty="0"/>
+          </a:p>
+        </p:txBody>
+      </p:sp>
+      <p:sp>
+        <p:nvSpPr>
+          <p:cNvPr id="12" name="Shape 10"/>
           <p:cNvSpPr/>
           <p:nvPr/>
         </p:nvSpPr>
         <p:spPr>
           <a:xfrm>
-            <a:off x="6126480" y="1371600"/>
+            <a:off x="6126480" y="2788920"/>
             <a:ext cx="640080" cy="640080"/>
           </a:xfrm>
           <a:prstGeom prst="ellipse">
@@ -6387,16 +6254,20 @@
           </a:solidFill>
           <a:ln/>
         </p:spPr>
-      </p:sp>
-      <p:sp>
-        <p:nvSpPr>
-          <p:cNvPr id="9" name="Text 7"/>
+        <p:txBody>
+          <a:bodyPr/>
+          <a:p/>
+        </p:txBody>
+      </p:sp>
+      <p:sp>
+        <p:nvSpPr>
+          <p:cNvPr id="13" name="Text 11"/>
           <p:cNvSpPr txBox="1"/>
           <p:nvPr/>
         </p:nvSpPr>
         <p:spPr>
           <a:xfrm>
-            <a:off x="6126480" y="1371600"/>
+            <a:off x="6126480" y="2788920"/>
             <a:ext cx="640080" cy="640080"/>
           </a:xfrm>
           <a:prstGeom prst="rect">
@@ -6421,7 +6292,7 @@
                 <a:ea typeface="Calibri" pitchFamily="34" charset="-122"/>
                 <a:cs typeface="Calibri" pitchFamily="34" charset="-120"/>
               </a:rPr>
-              <a:t>1.560</a:t>
+              <a:t>54</a:t>
             </a:r>
             <a:endParaRPr lang="en-US" sz="1800" dirty="0"/>
           </a:p>
@@ -6429,13 +6300,13 @@
       </p:sp>
       <p:sp>
         <p:nvSpPr>
-          <p:cNvPr id="10" name="Text 8"/>
+          <p:cNvPr id="14" name="Text 12"/>
           <p:cNvSpPr txBox="1"/>
           <p:nvPr/>
         </p:nvSpPr>
         <p:spPr>
           <a:xfrm>
-            <a:off x="6949440" y="1353312"/>
+            <a:off x="6949440" y="2770632"/>
             <a:ext cx="4572000" cy="365760"/>
           </a:xfrm>
           <a:prstGeom prst="rect">
@@ -6460,7 +6331,7 @@
                 <a:ea typeface="Cambria" pitchFamily="34" charset="-122"/>
                 <a:cs typeface="Cambria" pitchFamily="34" charset="-120"/>
               </a:rPr>
-              <a:t>~1.560 árvores</a:t>
+              <a:t>~54 veículos</a:t>
             </a:r>
             <a:endParaRPr lang="en-US" sz="1600" dirty="0"/>
           </a:p>
@@ -6468,13 +6339,13 @@
       </p:sp>
       <p:sp>
         <p:nvSpPr>
-          <p:cNvPr id="11" name="Text 9"/>
+          <p:cNvPr id="15" name="Text 13"/>
           <p:cNvSpPr txBox="1"/>
           <p:nvPr/>
         </p:nvSpPr>
         <p:spPr>
           <a:xfrm>
-            <a:off x="6949440" y="1691640"/>
+            <a:off x="6949440" y="3108960"/>
             <a:ext cx="4572000" cy="594360"/>
           </a:xfrm>
           <a:prstGeom prst="rect">
@@ -6499,7 +6370,7 @@
                 <a:ea typeface="Calibri" pitchFamily="34" charset="-122"/>
                 <a:cs typeface="Calibri" pitchFamily="34" charset="-120"/>
               </a:rPr>
-              <a:t>plantadas e preservadas por ano para absorver o mesmo volume de carbono</a:t>
+              <a:t>de passeio a combustão retirados de circulação nas avenidas de Ribeirão Preto</a:t>
             </a:r>
             <a:endParaRPr lang="en-US" sz="1150" dirty="0"/>
           </a:p>
@@ -6507,13 +6378,13 @@
       </p:sp>
       <p:sp>
         <p:nvSpPr>
-          <p:cNvPr id="12" name="Shape 10"/>
+          <p:cNvPr id="16" name="Shape 14"/>
           <p:cNvSpPr/>
           <p:nvPr/>
         </p:nvSpPr>
         <p:spPr>
           <a:xfrm>
-            <a:off x="6126480" y="2788920"/>
+            <a:off x="6126480" y="4206240"/>
             <a:ext cx="640080" cy="640080"/>
           </a:xfrm>
           <a:prstGeom prst="ellipse">
@@ -6524,143 +6395,10 @@
           </a:solidFill>
           <a:ln/>
         </p:spPr>
-      </p:sp>
-      <p:sp>
-        <p:nvSpPr>
-          <p:cNvPr id="13" name="Text 11"/>
-          <p:cNvSpPr txBox="1"/>
-          <p:nvPr/>
-        </p:nvSpPr>
-        <p:spPr>
-          <a:xfrm>
-            <a:off x="6126480" y="2788920"/>
-            <a:ext cx="640080" cy="640080"/>
-          </a:xfrm>
-          <a:prstGeom prst="rect">
-            <a:avLst/>
-          </a:prstGeom>
-          <a:noFill/>
-          <a:ln/>
-        </p:spPr>
-        <p:txBody>
-          <a:bodyPr wrap="square" lIns="0" tIns="0" rIns="0" bIns="0" rtlCol="0" anchor="ctr"/>
-          <a:lstStyle/>
-          <a:p>
-            <a:pPr algn="ctr" indent="0" marL="0">
-              <a:buNone/>
-            </a:pPr>
-            <a:r>
-              <a:rPr lang="en-US" sz="1800" b="1" dirty="0">
-                <a:solidFill>
-                  <a:srgbClr val="FFFFFF"/>
-                </a:solidFill>
-                <a:latin typeface="Calibri" pitchFamily="34" charset="0"/>
-                <a:ea typeface="Calibri" pitchFamily="34" charset="-122"/>
-                <a:cs typeface="Calibri" pitchFamily="34" charset="-120"/>
-              </a:rPr>
-              <a:t>54</a:t>
-            </a:r>
-            <a:endParaRPr lang="en-US" sz="1800" dirty="0"/>
-          </a:p>
-        </p:txBody>
-      </p:sp>
-      <p:sp>
-        <p:nvSpPr>
-          <p:cNvPr id="14" name="Text 12"/>
-          <p:cNvSpPr txBox="1"/>
-          <p:nvPr/>
-        </p:nvSpPr>
-        <p:spPr>
-          <a:xfrm>
-            <a:off x="6949440" y="2770632"/>
-            <a:ext cx="4572000" cy="365760"/>
-          </a:xfrm>
-          <a:prstGeom prst="rect">
-            <a:avLst/>
-          </a:prstGeom>
-          <a:noFill/>
-          <a:ln/>
-        </p:spPr>
-        <p:txBody>
-          <a:bodyPr wrap="square" lIns="0" tIns="0" rIns="0" bIns="0" rtlCol="0" anchor="ctr"/>
-          <a:lstStyle/>
-          <a:p>
-            <a:pPr indent="0" marL="0">
-              <a:buNone/>
-            </a:pPr>
-            <a:r>
-              <a:rPr lang="en-US" sz="1600" b="1" dirty="0">
-                <a:solidFill>
-                  <a:srgbClr val="1E2761"/>
-                </a:solidFill>
-                <a:latin typeface="Cambria" pitchFamily="34" charset="0"/>
-                <a:ea typeface="Cambria" pitchFamily="34" charset="-122"/>
-                <a:cs typeface="Cambria" pitchFamily="34" charset="-120"/>
-              </a:rPr>
-              <a:t>~54 veículos</a:t>
-            </a:r>
-            <a:endParaRPr lang="en-US" sz="1600" dirty="0"/>
-          </a:p>
-        </p:txBody>
-      </p:sp>
-      <p:sp>
-        <p:nvSpPr>
-          <p:cNvPr id="15" name="Text 13"/>
-          <p:cNvSpPr txBox="1"/>
-          <p:nvPr/>
-        </p:nvSpPr>
-        <p:spPr>
-          <a:xfrm>
-            <a:off x="6949440" y="3108960"/>
-            <a:ext cx="4572000" cy="594360"/>
-          </a:xfrm>
-          <a:prstGeom prst="rect">
-            <a:avLst/>
-          </a:prstGeom>
-          <a:noFill/>
-          <a:ln/>
-        </p:spPr>
-        <p:txBody>
-          <a:bodyPr wrap="square" lIns="0" tIns="0" rIns="0" bIns="0" rtlCol="0" anchor="ctr"/>
-          <a:lstStyle/>
-          <a:p>
-            <a:pPr indent="0" marL="0">
-              <a:buNone/>
-            </a:pPr>
-            <a:r>
-              <a:rPr lang="en-US" sz="1150" dirty="0">
-                <a:solidFill>
-                  <a:srgbClr val="5A6472"/>
-                </a:solidFill>
-                <a:latin typeface="Calibri" pitchFamily="34" charset="0"/>
-                <a:ea typeface="Calibri" pitchFamily="34" charset="-122"/>
-                <a:cs typeface="Calibri" pitchFamily="34" charset="-120"/>
-              </a:rPr>
-              <a:t>de passeio a combustão retirados de circulação nas avenidas de Ribeirão Preto</a:t>
-            </a:r>
-            <a:endParaRPr lang="en-US" sz="1150" dirty="0"/>
-          </a:p>
-        </p:txBody>
-      </p:sp>
-      <p:sp>
-        <p:nvSpPr>
-          <p:cNvPr id="16" name="Shape 14"/>
-          <p:cNvSpPr/>
-          <p:nvPr/>
-        </p:nvSpPr>
-        <p:spPr>
-          <a:xfrm>
-            <a:off x="6126480" y="4206240"/>
-            <a:ext cx="640080" cy="640080"/>
-          </a:xfrm>
-          <a:prstGeom prst="ellipse">
-            <a:avLst/>
-          </a:prstGeom>
-          <a:solidFill>
-            <a:srgbClr val="00A896"/>
-          </a:solidFill>
-          <a:ln/>
-        </p:spPr>
+        <p:txBody>
+          <a:bodyPr/>
+          <a:p/>
+        </p:txBody>
       </p:sp>
       <p:sp>
         <p:nvSpPr>
@@ -6989,6 +6727,10 @@
             <a:prstDash val="solid"/>
           </a:ln>
         </p:spPr>
+        <p:txBody>
+          <a:bodyPr/>
+          <a:p/>
+        </p:txBody>
       </p:sp>
       <p:sp>
         <p:nvSpPr>
@@ -7009,6 +6751,10 @@
           </a:solidFill>
           <a:ln/>
         </p:spPr>
+        <p:txBody>
+          <a:bodyPr/>
+          <a:p/>
+        </p:txBody>
       </p:sp>
       <p:sp>
         <p:nvSpPr>
@@ -7109,6 +6855,10 @@
           </a:solidFill>
           <a:ln/>
         </p:spPr>
+        <p:txBody>
+          <a:bodyPr/>
+          <a:p/>
+        </p:txBody>
       </p:sp>
       <p:sp>
         <p:nvSpPr>
@@ -7207,6 +6957,10 @@
           </a:solidFill>
           <a:ln/>
         </p:spPr>
+        <p:txBody>
+          <a:bodyPr/>
+          <a:p/>
+        </p:txBody>
       </p:sp>
       <p:sp>
         <p:nvSpPr>
@@ -7307,6 +7061,10 @@
           </a:solidFill>
           <a:ln/>
         </p:spPr>
+        <p:txBody>
+          <a:bodyPr/>
+          <a:p/>
+        </p:txBody>
       </p:sp>
       <p:sp>
         <p:nvSpPr>
@@ -7405,6 +7163,10 @@
           </a:solidFill>
           <a:ln/>
         </p:spPr>
+        <p:txBody>
+          <a:bodyPr/>
+          <a:p/>
+        </p:txBody>
       </p:sp>
       <p:sp>
         <p:nvSpPr>
@@ -7505,6 +7267,10 @@
           </a:solidFill>
           <a:ln/>
         </p:spPr>
+        <p:txBody>
+          <a:bodyPr/>
+          <a:p/>
+        </p:txBody>
       </p:sp>
       <p:sp>
         <p:nvSpPr>
@@ -7603,6 +7369,10 @@
           </a:solidFill>
           <a:ln/>
         </p:spPr>
+        <p:txBody>
+          <a:bodyPr/>
+          <a:p/>
+        </p:txBody>
       </p:sp>
       <p:sp>
         <p:nvSpPr>
@@ -7703,6 +7473,10 @@
           </a:solidFill>
           <a:ln/>
         </p:spPr>
+        <p:txBody>
+          <a:bodyPr/>
+          <a:p/>
+        </p:txBody>
       </p:sp>
       <p:sp>
         <p:nvSpPr>
@@ -7801,6 +7575,10 @@
           </a:solidFill>
           <a:ln/>
         </p:spPr>
+        <p:txBody>
+          <a:bodyPr/>
+          <a:p/>
+        </p:txBody>
       </p:sp>
       <p:sp>
         <p:nvSpPr>
@@ -7901,6 +7679,10 @@
           </a:solidFill>
           <a:ln/>
         </p:spPr>
+        <p:txBody>
+          <a:bodyPr/>
+          <a:p/>
+        </p:txBody>
       </p:sp>
       <p:sp>
         <p:nvSpPr>
@@ -8157,6 +7939,10 @@
             </a:outerShdw>
           </a:effectLst>
         </p:spPr>
+        <p:txBody>
+          <a:bodyPr/>
+          <a:p/>
+        </p:txBody>
       </p:sp>
       <p:sp>
         <p:nvSpPr>
@@ -8177,6 +7963,10 @@
           </a:solidFill>
           <a:ln/>
         </p:spPr>
+        <p:txBody>
+          <a:bodyPr/>
+          <a:p/>
+        </p:txBody>
       </p:sp>
       <p:sp>
         <p:nvSpPr>
@@ -8323,6 +8113,10 @@
             </a:outerShdw>
           </a:effectLst>
         </p:spPr>
+        <p:txBody>
+          <a:bodyPr/>
+          <a:p/>
+        </p:txBody>
       </p:sp>
       <p:sp>
         <p:nvSpPr>
@@ -8343,6 +8137,10 @@
           </a:solidFill>
           <a:ln/>
         </p:spPr>
+        <p:txBody>
+          <a:bodyPr/>
+          <a:p/>
+        </p:txBody>
       </p:sp>
       <p:sp>
         <p:nvSpPr>
@@ -8489,6 +8287,10 @@
             </a:outerShdw>
           </a:effectLst>
         </p:spPr>
+        <p:txBody>
+          <a:bodyPr/>
+          <a:p/>
+        </p:txBody>
       </p:sp>
       <p:sp>
         <p:nvSpPr>
@@ -8509,6 +8311,10 @@
           </a:solidFill>
           <a:ln/>
         </p:spPr>
+        <p:txBody>
+          <a:bodyPr/>
+          <a:p/>
+        </p:txBody>
       </p:sp>
       <p:sp>
         <p:nvSpPr>
@@ -8756,6 +8562,10 @@
           </a:solidFill>
           <a:ln/>
         </p:spPr>
+        <p:txBody>
+          <a:bodyPr/>
+          <a:p/>
+        </p:txBody>
       </p:sp>
       <p:sp>
         <p:nvSpPr>
@@ -8776,6 +8586,10 @@
           </a:solidFill>
           <a:ln/>
         </p:spPr>
+        <p:txBody>
+          <a:bodyPr/>
+          <a:p/>
+        </p:txBody>
       </p:sp>
       <p:sp>
         <p:nvSpPr>
@@ -8843,87 +8657,30 @@
               </a:lnSpc>
               <a:buNone/>
             </a:pPr>
-            <a:r>
-              <a:rPr lang="en-US" sz="1500" dirty="0">
-                <a:solidFill>
-                  <a:srgbClr val="CADCFC"/>
-                </a:solidFill>
-                <a:latin typeface="Calibri" pitchFamily="34" charset="0"/>
-                <a:ea typeface="Calibri" pitchFamily="34" charset="-122"/>
-                <a:cs typeface="Calibri" pitchFamily="34" charset="-120"/>
-              </a:rPr>
-              <a:t>Projeto tecnicamente maduro, financeiramente de altíssimo retorno e ambientalmente responsável.
-</a:t>
-            </a:r>
             <a:pPr indent="0" marL="0">
               <a:lnSpc>
                 <a:spcPct val="140000"/>
               </a:lnSpc>
               <a:buNone/>
             </a:pPr>
-            <a:r>
-              <a:rPr lang="en-US" sz="1500" b="1" dirty="0">
-                <a:solidFill>
-                  <a:srgbClr val="00A896"/>
-                </a:solidFill>
-                <a:latin typeface="Calibri" pitchFamily="34" charset="0"/>
-                <a:ea typeface="Calibri" pitchFamily="34" charset="-122"/>
-                <a:cs typeface="Calibri" pitchFamily="34" charset="-120"/>
-              </a:rPr>
-              <a:t>Investimento de R$ 301.000,00 </a:t>
-            </a:r>
             <a:pPr indent="0" marL="0">
               <a:lnSpc>
                 <a:spcPct val="140000"/>
               </a:lnSpc>
               <a:buNone/>
             </a:pPr>
-            <a:r>
-              <a:rPr lang="en-US" sz="1500" dirty="0">
-                <a:solidFill>
-                  <a:srgbClr val="CADCFC"/>
-                </a:solidFill>
-                <a:latin typeface="Calibri" pitchFamily="34" charset="0"/>
-                <a:ea typeface="Calibri" pitchFamily="34" charset="-122"/>
-                <a:cs typeface="Calibri" pitchFamily="34" charset="-120"/>
-              </a:rPr>
-              <a:t>com retorno garantido em </a:t>
-            </a:r>
             <a:pPr indent="0" marL="0">
               <a:lnSpc>
                 <a:spcPct val="140000"/>
               </a:lnSpc>
               <a:buNone/>
             </a:pPr>
-            <a:r>
-              <a:rPr lang="en-US" sz="1500" b="1" dirty="0">
-                <a:solidFill>
-                  <a:srgbClr val="00A896"/>
-                </a:solidFill>
-                <a:latin typeface="Calibri" pitchFamily="34" charset="0"/>
-                <a:ea typeface="Calibri" pitchFamily="34" charset="-122"/>
-                <a:cs typeface="Calibri" pitchFamily="34" charset="-120"/>
-              </a:rPr>
-              <a:t>16,6 meses.
-</a:t>
-            </a:r>
             <a:pPr indent="0" marL="0">
               <a:lnSpc>
                 <a:spcPct val="140000"/>
               </a:lnSpc>
               <a:buNone/>
             </a:pPr>
-            <a:r>
-              <a:rPr lang="en-US" sz="1500" b="1" dirty="0">
-                <a:solidFill>
-                  <a:srgbClr val="00A896"/>
-                </a:solidFill>
-                <a:latin typeface="Calibri" pitchFamily="34" charset="0"/>
-                <a:ea typeface="Calibri" pitchFamily="34" charset="-122"/>
-                <a:cs typeface="Calibri" pitchFamily="34" charset="-120"/>
-              </a:rPr>
-              <a:t>Redução permanente de R$ 217.686,42/ano </a:t>
-            </a:r>
             <a:pPr indent="0" marL="0">
               <a:lnSpc>
                 <a:spcPct val="140000"/>
@@ -8931,30 +8688,133 @@
               <a:buNone/>
             </a:pPr>
             <a:r>
-              <a:rPr lang="en-US" sz="1500" dirty="0">
-                <a:solidFill>
-                  <a:srgbClr val="CADCFC"/>
+              <a:t>Projeto tecnicamente maduro, financeiramente de altíssimo retorno e ambientalmente responsável.</a:t>
+            </a:r>
+            <a:br/>
+            <a:br/>
+            <a:r>
+              <a:t>Investimento de R$ 301.000,00 com retorno garantido em 16,5 meses.</a:t>
+            </a:r>
+            <a:br/>
+            <a:r>
+              <a:t>Redução permanente de R$ 217.686,42/ano no custo operacional de energia elétrica.</a:t>
+            </a:r>
+            <a:endParaRPr lang="en-US" sz="1500" dirty="0"/>
+          </a:p>
+        </p:txBody>
+      </p:sp>
+      <p:sp>
+        <p:nvSpPr>
+          <p:cNvPr id="6" name="Text 4"/>
+          <p:cNvSpPr txBox="1"/>
+          <p:nvPr/>
+        </p:nvSpPr>
+        <p:spPr>
+          <a:xfrm>
+            <a:off x="640080" y="3337560"/>
+            <a:ext cx="7315200" cy="365760"/>
+          </a:xfrm>
+          <a:prstGeom prst="rect">
+            <a:avLst/>
+          </a:prstGeom>
+          <a:noFill/>
+          <a:ln/>
+        </p:spPr>
+        <p:txBody>
+          <a:bodyPr wrap="square" lIns="0" tIns="0" rIns="0" bIns="0" rtlCol="0" anchor="ctr"/>
+          <a:lstStyle/>
+          <a:p>
+            <a:pPr indent="0" marL="0">
+              <a:buNone/>
+            </a:pPr>
+            <a:r>
+              <a:rPr lang="en-US" sz="1600" b="1" dirty="0">
+                <a:solidFill>
+                  <a:srgbClr val="00A896"/>
+                </a:solidFill>
+                <a:latin typeface="Cambria" pitchFamily="34" charset="0"/>
+                <a:ea typeface="Cambria" pitchFamily="34" charset="-122"/>
+                <a:cs typeface="Cambria" pitchFamily="34" charset="-120"/>
+              </a:rPr>
+              <a:t>Próximos Passos Recomendados</a:t>
+            </a:r>
+            <a:endParaRPr lang="en-US" sz="1600" dirty="0"/>
+          </a:p>
+        </p:txBody>
+      </p:sp>
+      <p:sp>
+        <p:nvSpPr>
+          <p:cNvPr id="7" name="Shape 5"/>
+          <p:cNvSpPr/>
+          <p:nvPr/>
+        </p:nvSpPr>
+        <p:spPr>
+          <a:xfrm>
+            <a:off x="640080" y="3840480"/>
+            <a:ext cx="411480" cy="411480"/>
+          </a:xfrm>
+          <a:prstGeom prst="ellipse">
+            <a:avLst/>
+          </a:prstGeom>
+          <a:solidFill>
+            <a:srgbClr val="00A896"/>
+          </a:solidFill>
+          <a:ln/>
+        </p:spPr>
+        <p:txBody>
+          <a:bodyPr/>
+          <a:p/>
+        </p:txBody>
+      </p:sp>
+      <p:sp>
+        <p:nvSpPr>
+          <p:cNvPr id="8" name="Text 6"/>
+          <p:cNvSpPr txBox="1"/>
+          <p:nvPr/>
+        </p:nvSpPr>
+        <p:spPr>
+          <a:xfrm>
+            <a:off x="640080" y="3840480"/>
+            <a:ext cx="411480" cy="411480"/>
+          </a:xfrm>
+          <a:prstGeom prst="rect">
+            <a:avLst/>
+          </a:prstGeom>
+          <a:noFill/>
+          <a:ln/>
+        </p:spPr>
+        <p:txBody>
+          <a:bodyPr wrap="square" lIns="0" tIns="0" rIns="0" bIns="0" rtlCol="0" anchor="ctr"/>
+          <a:lstStyle/>
+          <a:p>
+            <a:pPr algn="ctr" indent="0" marL="0">
+              <a:buNone/>
+            </a:pPr>
+            <a:r>
+              <a:rPr lang="en-US" sz="1200" b="1" dirty="0">
+                <a:solidFill>
+                  <a:srgbClr val="FFFFFF"/>
                 </a:solidFill>
                 <a:latin typeface="Calibri" pitchFamily="34" charset="0"/>
                 <a:ea typeface="Calibri" pitchFamily="34" charset="-122"/>
                 <a:cs typeface="Calibri" pitchFamily="34" charset="-120"/>
               </a:rPr>
-              <a:t>no custo operacional de energia elétrica.</a:t>
-            </a:r>
-            <a:endParaRPr lang="en-US" sz="1500" dirty="0"/>
-          </a:p>
-        </p:txBody>
-      </p:sp>
-      <p:sp>
-        <p:nvSpPr>
-          <p:cNvPr id="6" name="Text 4"/>
+              <a:t>1</a:t>
+            </a:r>
+            <a:endParaRPr lang="en-US" sz="1200" dirty="0"/>
+          </a:p>
+        </p:txBody>
+      </p:sp>
+      <p:sp>
+        <p:nvSpPr>
+          <p:cNvPr id="9" name="Text 7"/>
           <p:cNvSpPr txBox="1"/>
           <p:nvPr/>
         </p:nvSpPr>
         <p:spPr>
           <a:xfrm>
-            <a:off x="640080" y="3337560"/>
-            <a:ext cx="7315200" cy="365760"/>
+            <a:off x="1234440" y="3858768"/>
+            <a:ext cx="9875520" cy="384048"/>
           </a:xfrm>
           <a:prstGeom prst="rect">
             <a:avLst/>
@@ -8970,29 +8830,29 @@
               <a:buNone/>
             </a:pPr>
             <a:r>
-              <a:rPr lang="en-US" sz="1600" b="1" dirty="0">
-                <a:solidFill>
-                  <a:srgbClr val="00A896"/>
-                </a:solidFill>
-                <a:latin typeface="Cambria" pitchFamily="34" charset="0"/>
-                <a:ea typeface="Cambria" pitchFamily="34" charset="-122"/>
-                <a:cs typeface="Cambria" pitchFamily="34" charset="-120"/>
-              </a:rPr>
-              <a:t>Próximos Passos Recomendados</a:t>
-            </a:r>
-            <a:endParaRPr lang="en-US" sz="1600" dirty="0"/>
-          </a:p>
-        </p:txBody>
-      </p:sp>
-      <p:sp>
-        <p:nvSpPr>
-          <p:cNvPr id="7" name="Shape 5"/>
+              <a:rPr lang="en-US" sz="1350" dirty="0">
+                <a:solidFill>
+                  <a:srgbClr val="FFFFFF"/>
+                </a:solidFill>
+                <a:latin typeface="Calibri" pitchFamily="34" charset="0"/>
+                <a:ea typeface="Calibri" pitchFamily="34" charset="-122"/>
+                <a:cs typeface="Calibri" pitchFamily="34" charset="-120"/>
+              </a:rPr>
+              <a:t>Aprovação da proposta executiva pela Diretoria e Conselho Gestor.</a:t>
+            </a:r>
+            <a:endParaRPr lang="en-US" sz="1350" dirty="0"/>
+          </a:p>
+        </p:txBody>
+      </p:sp>
+      <p:sp>
+        <p:nvSpPr>
+          <p:cNvPr id="10" name="Shape 8"/>
           <p:cNvSpPr/>
           <p:nvPr/>
         </p:nvSpPr>
         <p:spPr>
           <a:xfrm>
-            <a:off x="640080" y="3840480"/>
+            <a:off x="640080" y="4434840"/>
             <a:ext cx="411480" cy="411480"/>
           </a:xfrm>
           <a:prstGeom prst="ellipse">
@@ -9003,16 +8863,20 @@
           </a:solidFill>
           <a:ln/>
         </p:spPr>
-      </p:sp>
-      <p:sp>
-        <p:nvSpPr>
-          <p:cNvPr id="8" name="Text 6"/>
+        <p:txBody>
+          <a:bodyPr/>
+          <a:p/>
+        </p:txBody>
+      </p:sp>
+      <p:sp>
+        <p:nvSpPr>
+          <p:cNvPr id="11" name="Text 9"/>
           <p:cNvSpPr txBox="1"/>
           <p:nvPr/>
         </p:nvSpPr>
         <p:spPr>
           <a:xfrm>
-            <a:off x="640080" y="3840480"/>
+            <a:off x="640080" y="4434840"/>
             <a:ext cx="411480" cy="411480"/>
           </a:xfrm>
           <a:prstGeom prst="rect">
@@ -9037,7 +8901,7 @@
                 <a:ea typeface="Calibri" pitchFamily="34" charset="-122"/>
                 <a:cs typeface="Calibri" pitchFamily="34" charset="-120"/>
               </a:rPr>
-              <a:t>1</a:t>
+              <a:t>2</a:t>
             </a:r>
             <a:endParaRPr lang="en-US" sz="1200" dirty="0"/>
           </a:p>
@@ -9045,13 +8909,13 @@
       </p:sp>
       <p:sp>
         <p:nvSpPr>
-          <p:cNvPr id="9" name="Text 7"/>
+          <p:cNvPr id="12" name="Text 10"/>
           <p:cNvSpPr txBox="1"/>
           <p:nvPr/>
         </p:nvSpPr>
         <p:spPr>
           <a:xfrm>
-            <a:off x="1234440" y="3858768"/>
+            <a:off x="1234440" y="4453128"/>
             <a:ext cx="9875520" cy="384048"/>
           </a:xfrm>
           <a:prstGeom prst="rect">
@@ -9076,7 +8940,7 @@
                 <a:ea typeface="Calibri" pitchFamily="34" charset="-122"/>
                 <a:cs typeface="Calibri" pitchFamily="34" charset="-120"/>
               </a:rPr>
-              <a:t>Aprovação da proposta executiva pela Diretoria e Conselho Gestor.</a:t>
+              <a:t>Assinatura do contrato de fornecimento e serviços.</a:t>
             </a:r>
             <a:endParaRPr lang="en-US" sz="1350" dirty="0"/>
           </a:p>
@@ -9084,13 +8948,13 @@
       </p:sp>
       <p:sp>
         <p:nvSpPr>
-          <p:cNvPr id="10" name="Shape 8"/>
+          <p:cNvPr id="13" name="Shape 11"/>
           <p:cNvSpPr/>
           <p:nvPr/>
         </p:nvSpPr>
         <p:spPr>
           <a:xfrm>
-            <a:off x="640080" y="4434840"/>
+            <a:off x="640080" y="5029200"/>
             <a:ext cx="411480" cy="411480"/>
           </a:xfrm>
           <a:prstGeom prst="ellipse">
@@ -9101,104 +8965,10 @@
           </a:solidFill>
           <a:ln/>
         </p:spPr>
-      </p:sp>
-      <p:sp>
-        <p:nvSpPr>
-          <p:cNvPr id="11" name="Text 9"/>
-          <p:cNvSpPr txBox="1"/>
-          <p:nvPr/>
-        </p:nvSpPr>
-        <p:spPr>
-          <a:xfrm>
-            <a:off x="640080" y="4434840"/>
-            <a:ext cx="411480" cy="411480"/>
-          </a:xfrm>
-          <a:prstGeom prst="rect">
-            <a:avLst/>
-          </a:prstGeom>
-          <a:noFill/>
-          <a:ln/>
-        </p:spPr>
-        <p:txBody>
-          <a:bodyPr wrap="square" lIns="0" tIns="0" rIns="0" bIns="0" rtlCol="0" anchor="ctr"/>
-          <a:lstStyle/>
-          <a:p>
-            <a:pPr algn="ctr" indent="0" marL="0">
-              <a:buNone/>
-            </a:pPr>
-            <a:r>
-              <a:rPr lang="en-US" sz="1200" b="1" dirty="0">
-                <a:solidFill>
-                  <a:srgbClr val="FFFFFF"/>
-                </a:solidFill>
-                <a:latin typeface="Calibri" pitchFamily="34" charset="0"/>
-                <a:ea typeface="Calibri" pitchFamily="34" charset="-122"/>
-                <a:cs typeface="Calibri" pitchFamily="34" charset="-120"/>
-              </a:rPr>
-              <a:t>2</a:t>
-            </a:r>
-            <a:endParaRPr lang="en-US" sz="1200" dirty="0"/>
-          </a:p>
-        </p:txBody>
-      </p:sp>
-      <p:sp>
-        <p:nvSpPr>
-          <p:cNvPr id="12" name="Text 10"/>
-          <p:cNvSpPr txBox="1"/>
-          <p:nvPr/>
-        </p:nvSpPr>
-        <p:spPr>
-          <a:xfrm>
-            <a:off x="1234440" y="4453128"/>
-            <a:ext cx="9875520" cy="384048"/>
-          </a:xfrm>
-          <a:prstGeom prst="rect">
-            <a:avLst/>
-          </a:prstGeom>
-          <a:noFill/>
-          <a:ln/>
-        </p:spPr>
-        <p:txBody>
-          <a:bodyPr wrap="square" lIns="0" tIns="0" rIns="0" bIns="0" rtlCol="0" anchor="ctr"/>
-          <a:lstStyle/>
-          <a:p>
-            <a:pPr indent="0" marL="0">
-              <a:buNone/>
-            </a:pPr>
-            <a:r>
-              <a:rPr lang="en-US" sz="1350" dirty="0">
-                <a:solidFill>
-                  <a:srgbClr val="FFFFFF"/>
-                </a:solidFill>
-                <a:latin typeface="Calibri" pitchFamily="34" charset="0"/>
-                <a:ea typeface="Calibri" pitchFamily="34" charset="-122"/>
-                <a:cs typeface="Calibri" pitchFamily="34" charset="-120"/>
-              </a:rPr>
-              <a:t>Assinatura do contrato de fornecimento e serviços.</a:t>
-            </a:r>
-            <a:endParaRPr lang="en-US" sz="1350" dirty="0"/>
-          </a:p>
-        </p:txBody>
-      </p:sp>
-      <p:sp>
-        <p:nvSpPr>
-          <p:cNvPr id="13" name="Shape 11"/>
-          <p:cNvSpPr/>
-          <p:nvPr/>
-        </p:nvSpPr>
-        <p:spPr>
-          <a:xfrm>
-            <a:off x="640080" y="5029200"/>
-            <a:ext cx="411480" cy="411480"/>
-          </a:xfrm>
-          <a:prstGeom prst="ellipse">
-            <a:avLst/>
-          </a:prstGeom>
-          <a:solidFill>
-            <a:srgbClr val="00A896"/>
-          </a:solidFill>
-          <a:ln/>
-        </p:spPr>
+        <p:txBody>
+          <a:bodyPr/>
+          <a:p/>
+        </p:txBody>
       </p:sp>
       <p:sp>
         <p:nvSpPr>
@@ -9300,6 +9070,10 @@
             <a:prstDash val="solid"/>
           </a:ln>
         </p:spPr>
+        <p:txBody>
+          <a:bodyPr/>
+          <a:p/>
+        </p:txBody>
       </p:sp>
       <p:sp>
         <p:nvSpPr>
@@ -9501,6 +9275,10 @@
             </a:outerShdw>
           </a:effectLst>
         </p:spPr>
+        <p:txBody>
+          <a:bodyPr/>
+          <a:p/>
+        </p:txBody>
       </p:sp>
       <p:sp>
         <p:nvSpPr>
@@ -9608,6 +9386,10 @@
             </a:outerShdw>
           </a:effectLst>
         </p:spPr>
+        <p:txBody>
+          <a:bodyPr/>
+          <a:p/>
+        </p:txBody>
       </p:sp>
       <p:sp>
         <p:nvSpPr>
@@ -9634,14 +9416,6 @@
               <a:buNone/>
             </a:pPr>
             <a:r>
-              <a:rPr lang="en-US" sz="2200" b="1" dirty="0">
-                <a:solidFill>
-                  <a:srgbClr val="028090"/>
-                </a:solidFill>
-                <a:latin typeface="Cambria" pitchFamily="34" charset="0"/>
-                <a:ea typeface="Cambria" pitchFamily="34" charset="-122"/>
-                <a:cs typeface="Cambria" pitchFamily="34" charset="-120"/>
-              </a:rPr>
               <a:t>R$ 217.686 /ano</a:t>
             </a:r>
             <a:endParaRPr lang="en-US" sz="2200" dirty="0"/>
@@ -9715,6 +9489,10 @@
             </a:outerShdw>
           </a:effectLst>
         </p:spPr>
+        <p:txBody>
+          <a:bodyPr/>
+          <a:p/>
+        </p:txBody>
       </p:sp>
       <p:sp>
         <p:nvSpPr>
@@ -9822,6 +9600,10 @@
             </a:outerShdw>
           </a:effectLst>
         </p:spPr>
+        <p:txBody>
+          <a:bodyPr/>
+          <a:p/>
+        </p:txBody>
       </p:sp>
       <p:sp>
         <p:nvSpPr>
@@ -9848,15 +9630,7 @@
               <a:buNone/>
             </a:pPr>
             <a:r>
-              <a:rPr lang="en-US" sz="2200" b="1" dirty="0">
-                <a:solidFill>
-                  <a:srgbClr val="028090"/>
-                </a:solidFill>
-                <a:latin typeface="Cambria" pitchFamily="34" charset="0"/>
-                <a:ea typeface="Cambria" pitchFamily="34" charset="-122"/>
-                <a:cs typeface="Cambria" pitchFamily="34" charset="-120"/>
-              </a:rPr>
-              <a:t>16,6 meses</a:t>
+              <a:t>16,5 meses</a:t>
             </a:r>
             <a:endParaRPr lang="en-US" sz="2200" dirty="0"/>
           </a:p>
@@ -9929,6 +9703,10 @@
             </a:outerShdw>
           </a:effectLst>
         </p:spPr>
+        <p:txBody>
+          <a:bodyPr/>
+          <a:p/>
+        </p:txBody>
       </p:sp>
       <p:sp>
         <p:nvSpPr>
@@ -10036,6 +9814,10 @@
             </a:outerShdw>
           </a:effectLst>
         </p:spPr>
+        <p:txBody>
+          <a:bodyPr/>
+          <a:p/>
+        </p:txBody>
       </p:sp>
       <p:sp>
         <p:nvSpPr>
@@ -10062,15 +9844,7 @@
               <a:buNone/>
             </a:pPr>
             <a:r>
-              <a:rPr lang="en-US" sz="2200" b="1" dirty="0">
-                <a:solidFill>
-                  <a:srgbClr val="1E2761"/>
-                </a:solidFill>
-                <a:latin typeface="Cambria" pitchFamily="34" charset="0"/>
-                <a:ea typeface="Cambria" pitchFamily="34" charset="-122"/>
-                <a:cs typeface="Cambria" pitchFamily="34" charset="-120"/>
-              </a:rPr>
-              <a:t>R$ 483.710</a:t>
+              <a:t>R$ 484.710</a:t>
             </a:r>
             <a:endParaRPr lang="en-US" sz="2200" dirty="0"/>
           </a:p>
@@ -10143,6 +9917,10 @@
             </a:outerShdw>
           </a:effectLst>
         </p:spPr>
+        <p:txBody>
+          <a:bodyPr/>
+          <a:p/>
+        </p:txBody>
       </p:sp>
       <p:sp>
         <p:nvSpPr>
@@ -10169,14 +9947,6 @@
               <a:buNone/>
             </a:pPr>
             <a:r>
-              <a:rPr lang="en-US" sz="2200" b="1" dirty="0">
-                <a:solidFill>
-                  <a:srgbClr val="1E2761"/>
-                </a:solidFill>
-                <a:latin typeface="Cambria" pitchFamily="34" charset="0"/>
-                <a:ea typeface="Cambria" pitchFamily="34" charset="-122"/>
-                <a:cs typeface="Cambria" pitchFamily="34" charset="-120"/>
-              </a:rPr>
               <a:t>290.249 kWh/ano</a:t>
             </a:r>
             <a:endParaRPr lang="en-US" sz="2200" dirty="0"/>
@@ -10250,6 +10020,10 @@
             </a:outerShdw>
           </a:effectLst>
         </p:spPr>
+        <p:txBody>
+          <a:bodyPr/>
+          <a:p/>
+        </p:txBody>
       </p:sp>
       <p:sp>
         <p:nvSpPr>
@@ -10276,14 +10050,6 @@
               <a:buNone/>
             </a:pPr>
             <a:r>
-              <a:rPr lang="en-US" sz="2200" b="1" dirty="0">
-                <a:solidFill>
-                  <a:srgbClr val="028090"/>
-                </a:solidFill>
-                <a:latin typeface="Cambria" pitchFamily="34" charset="0"/>
-                <a:ea typeface="Cambria" pitchFamily="34" charset="-122"/>
-                <a:cs typeface="Cambria" pitchFamily="34" charset="-120"/>
-              </a:rPr>
               <a:t>25,0 tCO2/ano</a:t>
             </a:r>
             <a:endParaRPr lang="en-US" sz="2200" dirty="0"/>
@@ -10536,6 +10302,10 @@
           </a:solidFill>
           <a:ln/>
         </p:spPr>
+        <p:txBody>
+          <a:bodyPr/>
+          <a:p/>
+        </p:txBody>
       </p:sp>
       <p:sp>
         <p:nvSpPr>
@@ -10673,6 +10443,10 @@
           </a:solidFill>
           <a:ln/>
         </p:spPr>
+        <p:txBody>
+          <a:bodyPr/>
+          <a:p/>
+        </p:txBody>
       </p:sp>
       <p:sp>
         <p:nvSpPr>
@@ -10810,6 +10584,10 @@
           </a:solidFill>
           <a:ln/>
         </p:spPr>
+        <p:txBody>
+          <a:bodyPr/>
+          <a:p/>
+        </p:txBody>
       </p:sp>
       <p:sp>
         <p:nvSpPr>
@@ -10947,6 +10725,10 @@
           </a:solidFill>
           <a:ln/>
         </p:spPr>
+        <p:txBody>
+          <a:bodyPr/>
+          <a:p/>
+        </p:txBody>
       </p:sp>
       <p:sp>
         <p:nvSpPr>
@@ -11086,6 +10868,10 @@
           </a:solidFill>
           <a:ln/>
         </p:spPr>
+        <p:txBody>
+          <a:bodyPr/>
+          <a:p/>
+        </p:txBody>
       </p:sp>
       <p:sp>
         <p:nvSpPr>
@@ -11226,6 +11012,10 @@
             <a:prstDash val="solid"/>
           </a:ln>
         </p:spPr>
+        <p:txBody>
+          <a:bodyPr/>
+          <a:p/>
+        </p:txBody>
       </p:sp>
       <p:sp>
         <p:nvSpPr>
@@ -11327,6 +11117,10 @@
             <a:prstDash val="solid"/>
           </a:ln>
         </p:spPr>
+        <p:txBody>
+          <a:bodyPr/>
+          <a:p/>
+        </p:txBody>
       </p:sp>
       <p:sp>
         <p:nvSpPr>
@@ -11428,6 +11222,10 @@
             <a:prstDash val="solid"/>
           </a:ln>
         </p:spPr>
+        <p:txBody>
+          <a:bodyPr/>
+          <a:p/>
+        </p:txBody>
       </p:sp>
       <p:sp>
         <p:nvSpPr>
@@ -11684,6 +11482,10 @@
             </a:outerShdw>
           </a:effectLst>
         </p:spPr>
+        <p:txBody>
+          <a:bodyPr/>
+          <a:p/>
+        </p:txBody>
       </p:sp>
       <p:sp>
         <p:nvSpPr>
@@ -11830,6 +11632,10 @@
             </a:outerShdw>
           </a:effectLst>
         </p:spPr>
+        <p:txBody>
+          <a:bodyPr/>
+          <a:p/>
+        </p:txBody>
       </p:sp>
       <p:sp>
         <p:nvSpPr>
@@ -11976,6 +11782,10 @@
             </a:outerShdw>
           </a:effectLst>
         </p:spPr>
+        <p:txBody>
+          <a:bodyPr/>
+          <a:p/>
+        </p:txBody>
       </p:sp>
       <p:sp>
         <p:nvSpPr>
@@ -12122,6 +11932,10 @@
             </a:outerShdw>
           </a:effectLst>
         </p:spPr>
+        <p:txBody>
+          <a:bodyPr/>
+          <a:p/>
+        </p:txBody>
       </p:sp>
       <p:sp>
         <p:nvSpPr>
@@ -12652,6 +12466,10 @@
           </a:solidFill>
           <a:ln/>
         </p:spPr>
+        <p:txBody>
+          <a:bodyPr/>
+          <a:p/>
+        </p:txBody>
       </p:sp>
       <p:sp>
         <p:nvSpPr>
@@ -12728,6 +12546,10 @@
           </a:solidFill>
           <a:ln/>
         </p:spPr>
+        <p:txBody>
+          <a:bodyPr/>
+          <a:p/>
+        </p:txBody>
       </p:sp>
       <p:sp>
         <p:nvSpPr>
@@ -12804,6 +12626,10 @@
           </a:solidFill>
           <a:ln/>
         </p:spPr>
+        <p:txBody>
+          <a:bodyPr/>
+          <a:p/>
+        </p:txBody>
       </p:sp>
       <p:sp>
         <p:nvSpPr>
@@ -12967,6 +12793,10 @@
             <a:prstDash val="solid"/>
           </a:ln>
         </p:spPr>
+        <p:txBody>
+          <a:bodyPr/>
+          <a:p/>
+        </p:txBody>
       </p:sp>
       <p:sp>
         <p:nvSpPr>
@@ -15444,6 +15274,10 @@
           </a:solidFill>
           <a:ln/>
         </p:spPr>
+        <p:txBody>
+          <a:bodyPr/>
+          <a:p/>
+        </p:txBody>
       </p:sp>
       <p:sp>
         <p:nvSpPr>
@@ -15559,6 +15393,10 @@
           </a:solidFill>
           <a:ln/>
         </p:spPr>
+        <p:txBody>
+          <a:bodyPr/>
+          <a:p/>
+        </p:txBody>
       </p:sp>
       <p:sp>
         <p:nvSpPr>
@@ -15587,17 +15425,6 @@
               </a:lnSpc>
               <a:buNone/>
             </a:pPr>
-            <a:r>
-              <a:rPr lang="en-US" sz="1150" b="1" dirty="0">
-                <a:solidFill>
-                  <a:srgbClr val="FFFFFF"/>
-                </a:solidFill>
-                <a:latin typeface="Calibri" pitchFamily="34" charset="0"/>
-                <a:ea typeface="Calibri" pitchFamily="34" charset="-122"/>
-                <a:cs typeface="Calibri" pitchFamily="34" charset="-120"/>
-              </a:rPr>
-              <a:t>Escala linear por máquina retrofitada: </a:t>
-            </a:r>
             <a:pPr indent="0" marL="0">
               <a:lnSpc>
                 <a:spcPct val="135000"/>
@@ -15605,15 +15432,7 @@
               <a:buNone/>
             </a:pPr>
             <a:r>
-              <a:rPr lang="en-US" sz="1150" dirty="0">
-                <a:solidFill>
-                  <a:srgbClr val="CADCFC"/>
-                </a:solidFill>
-                <a:latin typeface="Calibri" pitchFamily="34" charset="0"/>
-                <a:ea typeface="Calibri" pitchFamily="34" charset="-122"/>
-                <a:cs typeface="Calibri" pitchFamily="34" charset="-120"/>
-              </a:rPr>
-              <a:t>cada climatizador gera R$ 477,38/mês (R$ 5.728,59/ano) de economia líquida individual — 10 máquinas = R$ 57.285,90/ano; 38 máquinas (parque total) = R$ 217.686,42/ano.</a:t>
+              <a:t>Escala linear por máquina retrofitada: cada climatizador gera R$ 477,38/mês (R$ 5.728,59/ano) de economia líquida individual — 10 máquinas = R$ 57.285,90/ano; 38 máquinas (parque total) = R$ 217.686,42/ano.</a:t>
             </a:r>
             <a:endParaRPr lang="en-US" sz="1150" dirty="0"/>
           </a:p>
@@ -15796,6 +15615,10 @@
             </a:outerShdw>
           </a:effectLst>
         </p:spPr>
+        <p:txBody>
+          <a:bodyPr/>
+          <a:p/>
+        </p:txBody>
       </p:sp>
       <p:sp>
         <p:nvSpPr>
@@ -15903,6 +15726,10 @@
             </a:outerShdw>
           </a:effectLst>
         </p:spPr>
+        <p:txBody>
+          <a:bodyPr/>
+          <a:p/>
+        </p:txBody>
       </p:sp>
       <p:sp>
         <p:nvSpPr>
@@ -16010,6 +15837,10 @@
             </a:outerShdw>
           </a:effectLst>
         </p:spPr>
+        <p:txBody>
+          <a:bodyPr/>
+          <a:p/>
+        </p:txBody>
       </p:sp>
       <p:sp>
         <p:nvSpPr>
@@ -16117,6 +15948,10 @@
             </a:outerShdw>
           </a:effectLst>
         </p:spPr>
+        <p:txBody>
+          <a:bodyPr/>
+          <a:p/>
+        </p:txBody>
       </p:sp>
       <p:sp>
         <p:nvSpPr>
@@ -16224,6 +16059,10 @@
             </a:outerShdw>
           </a:effectLst>
         </p:spPr>
+        <p:txBody>
+          <a:bodyPr/>
+          <a:p/>
+        </p:txBody>
       </p:sp>
       <p:sp>
         <p:nvSpPr>
@@ -17641,6 +17480,10 @@
           </a:solidFill>
           <a:ln/>
         </p:spPr>
+        <p:txBody>
+          <a:bodyPr/>
+          <a:p/>
+        </p:txBody>
       </p:sp>
       <p:sp>
         <p:nvSpPr>
@@ -19496,6 +19339,10 @@
           </a:solidFill>
           <a:ln/>
         </p:spPr>
+        <p:txBody>
+          <a:bodyPr/>
+          <a:p/>
+        </p:txBody>
       </p:sp>
       <p:sp>
         <p:nvSpPr>
@@ -19594,6 +19441,10 @@
           </a:solidFill>
           <a:ln/>
         </p:spPr>
+        <p:txBody>
+          <a:bodyPr/>
+          <a:p/>
+        </p:txBody>
       </p:sp>
       <p:sp>
         <p:nvSpPr>
@@ -19692,6 +19543,10 @@
           </a:solidFill>
           <a:ln/>
         </p:spPr>
+        <p:txBody>
+          <a:bodyPr/>
+          <a:p/>
+        </p:txBody>
       </p:sp>
       <p:sp>
         <p:nvSpPr>

</xml_diff>

<commit_message>
Fully sync baseline table (Slide 6), sensitivity charts (Slide 7), and comparative charts/table (Slide 10) in PowerPoint with live Firebase data
</commit_message>
<xml_diff>
--- a/Estudo_Viabilidade_Retrofit_HVAC_Novo_Shopping.pptx
+++ b/Estudo_Viabilidade_Retrofit_HVAC_Novo_Shopping.pptx
@@ -225,16 +225,16 @@
                 <c:formatCode>General</c:formatCode>
                 <c:ptCount val="4"/>
                 <c:pt idx="0">
-                  <c:v>188.7</c:v>
+                  <c:v>141.5</c:v>
                 </c:pt>
                 <c:pt idx="1">
-                  <c:v>217.7</c:v>
+                  <c:v>163.30000000000001</c:v>
                 </c:pt>
                 <c:pt idx="2">
-                  <c:v>246.7</c:v>
+                  <c:v>185</c:v>
                 </c:pt>
                 <c:pt idx="3">
-                  <c:v>290.2</c:v>
+                  <c:v>217.7</c:v>
                 </c:pt>
               </c:numCache>
             </c:numRef>
@@ -744,7 +744,7 @@
                   <c:v>237000</c:v>
                 </c:pt>
                 <c:pt idx="1">
-                  <c:v>212813</c:v>
+                  <c:v>218859</c:v>
                 </c:pt>
               </c:numCache>
             </c:numRef>
@@ -1007,7 +1007,7 @@
                   <c:v>2132999.5699999998</c:v>
                 </c:pt>
                 <c:pt idx="1">
-                  <c:v>1915313.15</c:v>
+                  <c:v>1969734.75</c:v>
                 </c:pt>
               </c:numCache>
             </c:numRef>
@@ -3145,6 +3145,13 @@
           </a:solidFill>
           <a:ln/>
         </p:spPr>
+        <p:txBody>
+          <a:bodyPr/>
+          <a:lstStyle/>
+          <a:p>
+            <a:endParaRPr/>
+          </a:p>
+        </p:txBody>
       </p:sp>
       <p:sp>
         <p:nvSpPr>
@@ -3165,6 +3172,13 @@
           </a:solidFill>
           <a:ln/>
         </p:spPr>
+        <p:txBody>
+          <a:bodyPr/>
+          <a:lstStyle/>
+          <a:p>
+            <a:endParaRPr/>
+          </a:p>
+        </p:txBody>
       </p:sp>
       <p:sp>
         <p:nvSpPr>
@@ -3185,6 +3199,13 @@
           </a:solidFill>
           <a:ln/>
         </p:spPr>
+        <p:txBody>
+          <a:bodyPr/>
+          <a:lstStyle/>
+          <a:p>
+            <a:endParaRPr/>
+          </a:p>
+        </p:txBody>
       </p:sp>
       <p:sp>
         <p:nvSpPr>
@@ -3286,6 +3307,13 @@
             <a:prstDash val="solid"/>
           </a:ln>
         </p:spPr>
+        <p:txBody>
+          <a:bodyPr/>
+          <a:lstStyle/>
+          <a:p>
+            <a:endParaRPr/>
+          </a:p>
+        </p:txBody>
       </p:sp>
       <p:sp>
         <p:nvSpPr>
@@ -3490,7 +3518,7 @@
           <p:nvPr>
             <p:extLst>
               <p:ext uri="{D42A27DB-BD31-4B8C-83A1-F6EECF244321}">
-                <p14:modId xmlns:p14="http://schemas.microsoft.com/office/powerpoint/2010/main" val="1557127870"/>
+                <p14:modId xmlns:p14="http://schemas.microsoft.com/office/powerpoint/2010/main" val="1487318999"/>
               </p:ext>
             </p:extLst>
           </p:nvPr>
@@ -3817,25 +3845,9 @@
                     <a:bodyPr/>
                     <a:lstStyle/>
                     <a:p>
-                      <a:pPr marL="0" indent="0" algn="ctr">
-                        <a:buNone/>
-                      </a:pPr>
                       <a:r>
-                        <a:rPr lang="en-US" sz="1150">
-                          <a:solidFill>
-                            <a:srgbClr val="1E2761"/>
-                          </a:solidFill>
-                          <a:latin typeface="Calibri" pitchFamily="34" charset="0"/>
-                          <a:ea typeface="Calibri" pitchFamily="34" charset="-122"/>
-                          <a:cs typeface="Calibri" pitchFamily="34" charset="-120"/>
-                        </a:rPr>
                         <a:t>237.000 kWh</a:t>
                       </a:r>
-                      <a:endParaRPr lang="en-US" sz="1150" dirty="0">
-                        <a:latin typeface="Calibri" charset="0"/>
-                        <a:ea typeface="Calibri" charset="0"/>
-                        <a:cs typeface="Calibri" charset="0"/>
-                      </a:endParaRPr>
                     </a:p>
                   </a:txBody>
                   <a:tcPr anchor="ctr">
@@ -3861,25 +3873,9 @@
                     <a:bodyPr/>
                     <a:lstStyle/>
                     <a:p>
-                      <a:pPr marL="0" indent="0" algn="ctr">
-                        <a:buNone/>
-                      </a:pPr>
                       <a:r>
-                        <a:rPr lang="en-US" sz="1150">
-                          <a:solidFill>
-                            <a:srgbClr val="1E2761"/>
-                          </a:solidFill>
-                          <a:latin typeface="Calibri" pitchFamily="34" charset="0"/>
-                          <a:ea typeface="Calibri" pitchFamily="34" charset="-122"/>
-                          <a:cs typeface="Calibri" pitchFamily="34" charset="-120"/>
-                        </a:rPr>
-                        <a:t>212.813 kWh</a:t>
+                        <a:t>218.859 kWh</a:t>
                       </a:r>
-                      <a:endParaRPr lang="en-US" sz="1150" dirty="0">
-                        <a:latin typeface="Calibri" charset="0"/>
-                        <a:ea typeface="Calibri" charset="0"/>
-                        <a:cs typeface="Calibri" charset="0"/>
-                      </a:endParaRPr>
                     </a:p>
                   </a:txBody>
                   <a:tcPr anchor="ctr">
@@ -3905,25 +3901,9 @@
                     <a:bodyPr/>
                     <a:lstStyle/>
                     <a:p>
-                      <a:pPr marL="0" indent="0" algn="ctr">
-                        <a:buNone/>
-                      </a:pPr>
                       <a:r>
-                        <a:rPr lang="en-US" sz="1150">
-                          <a:solidFill>
-                            <a:srgbClr val="1E2761"/>
-                          </a:solidFill>
-                          <a:latin typeface="Calibri" pitchFamily="34" charset="0"/>
-                          <a:ea typeface="Calibri" pitchFamily="34" charset="-122"/>
-                          <a:cs typeface="Calibri" pitchFamily="34" charset="-120"/>
-                        </a:rPr>
-                        <a:t>24.187 kWh</a:t>
+                        <a:t>18.141 kWh</a:t>
                       </a:r>
-                      <a:endParaRPr lang="en-US" sz="1150" dirty="0">
-                        <a:latin typeface="Calibri" charset="0"/>
-                        <a:ea typeface="Calibri" charset="0"/>
-                        <a:cs typeface="Calibri" charset="0"/>
-                      </a:endParaRPr>
                     </a:p>
                   </a:txBody>
                   <a:tcPr anchor="ctr">
@@ -3949,25 +3929,9 @@
                     <a:bodyPr/>
                     <a:lstStyle/>
                     <a:p>
-                      <a:pPr marL="0" indent="0" algn="ctr">
-                        <a:buNone/>
-                      </a:pPr>
                       <a:r>
-                        <a:rPr lang="en-US" sz="1150" b="1">
-                          <a:solidFill>
-                            <a:srgbClr val="028090"/>
-                          </a:solidFill>
-                          <a:latin typeface="Calibri" pitchFamily="34" charset="0"/>
-                          <a:ea typeface="Calibri" pitchFamily="34" charset="-122"/>
-                          <a:cs typeface="Calibri" pitchFamily="34" charset="-120"/>
-                        </a:rPr>
-                        <a:t>-10,2%</a:t>
+                        <a:t>-7,7%</a:t>
                       </a:r>
-                      <a:endParaRPr lang="en-US" sz="1150" dirty="0">
-                        <a:latin typeface="Calibri" charset="0"/>
-                        <a:ea typeface="Calibri" charset="0"/>
-                        <a:cs typeface="Calibri" charset="0"/>
-                      </a:endParaRPr>
                     </a:p>
                   </a:txBody>
                   <a:tcPr anchor="ctr">
@@ -4044,25 +4008,9 @@
                     <a:bodyPr/>
                     <a:lstStyle/>
                     <a:p>
-                      <a:pPr marL="0" indent="0" algn="ctr">
-                        <a:buNone/>
-                      </a:pPr>
                       <a:r>
-                        <a:rPr lang="en-US" sz="1150">
-                          <a:solidFill>
-                            <a:srgbClr val="1E2761"/>
-                          </a:solidFill>
-                          <a:latin typeface="Calibri" pitchFamily="34" charset="0"/>
-                          <a:ea typeface="Calibri" pitchFamily="34" charset="-122"/>
-                          <a:cs typeface="Calibri" pitchFamily="34" charset="-120"/>
-                        </a:rPr>
                         <a:t>2.843.999 kWh</a:t>
                       </a:r>
-                      <a:endParaRPr lang="en-US" sz="1150" dirty="0">
-                        <a:latin typeface="Calibri" charset="0"/>
-                        <a:ea typeface="Calibri" charset="0"/>
-                        <a:cs typeface="Calibri" charset="0"/>
-                      </a:endParaRPr>
                     </a:p>
                   </a:txBody>
                   <a:tcPr anchor="ctr">
@@ -4088,25 +4036,9 @@
                     <a:bodyPr/>
                     <a:lstStyle/>
                     <a:p>
-                      <a:pPr marL="0" indent="0" algn="ctr">
-                        <a:buNone/>
-                      </a:pPr>
                       <a:r>
-                        <a:rPr lang="en-US" sz="1150">
-                          <a:solidFill>
-                            <a:srgbClr val="1E2761"/>
-                          </a:solidFill>
-                          <a:latin typeface="Calibri" pitchFamily="34" charset="0"/>
-                          <a:ea typeface="Calibri" pitchFamily="34" charset="-122"/>
-                          <a:cs typeface="Calibri" pitchFamily="34" charset="-120"/>
-                        </a:rPr>
-                        <a:t>2.553.751 kWh</a:t>
+                        <a:t>2.626.313 kWh</a:t>
                       </a:r>
-                      <a:endParaRPr lang="en-US" sz="1150" dirty="0">
-                        <a:latin typeface="Calibri" charset="0"/>
-                        <a:ea typeface="Calibri" charset="0"/>
-                        <a:cs typeface="Calibri" charset="0"/>
-                      </a:endParaRPr>
                     </a:p>
                   </a:txBody>
                   <a:tcPr anchor="ctr">
@@ -4132,25 +4064,9 @@
                     <a:bodyPr/>
                     <a:lstStyle/>
                     <a:p>
-                      <a:pPr marL="0" indent="0" algn="ctr">
-                        <a:buNone/>
-                      </a:pPr>
                       <a:r>
-                        <a:rPr lang="en-US" sz="1150">
-                          <a:solidFill>
-                            <a:srgbClr val="1E2761"/>
-                          </a:solidFill>
-                          <a:latin typeface="Calibri" pitchFamily="34" charset="0"/>
-                          <a:ea typeface="Calibri" pitchFamily="34" charset="-122"/>
-                          <a:cs typeface="Calibri" pitchFamily="34" charset="-120"/>
-                        </a:rPr>
-                        <a:t>290.249 kWh</a:t>
+                        <a:t>217.686 kWh</a:t>
                       </a:r>
-                      <a:endParaRPr lang="en-US" sz="1150" dirty="0">
-                        <a:latin typeface="Calibri" charset="0"/>
-                        <a:ea typeface="Calibri" charset="0"/>
-                        <a:cs typeface="Calibri" charset="0"/>
-                      </a:endParaRPr>
                     </a:p>
                   </a:txBody>
                   <a:tcPr anchor="ctr">
@@ -4176,25 +4092,9 @@
                     <a:bodyPr/>
                     <a:lstStyle/>
                     <a:p>
-                      <a:pPr marL="0" indent="0" algn="ctr">
-                        <a:buNone/>
-                      </a:pPr>
                       <a:r>
-                        <a:rPr lang="en-US" sz="1150" b="1">
-                          <a:solidFill>
-                            <a:srgbClr val="028090"/>
-                          </a:solidFill>
-                          <a:latin typeface="Calibri" pitchFamily="34" charset="0"/>
-                          <a:ea typeface="Calibri" pitchFamily="34" charset="-122"/>
-                          <a:cs typeface="Calibri" pitchFamily="34" charset="-120"/>
-                        </a:rPr>
-                        <a:t>-10,2%</a:t>
+                        <a:t>-7,7%</a:t>
                       </a:r>
-                      <a:endParaRPr lang="en-US" sz="1150" dirty="0">
-                        <a:latin typeface="Calibri" charset="0"/>
-                        <a:ea typeface="Calibri" charset="0"/>
-                        <a:cs typeface="Calibri" charset="0"/>
-                      </a:endParaRPr>
                     </a:p>
                   </a:txBody>
                   <a:tcPr anchor="ctr">
@@ -4271,25 +4171,9 @@
                     <a:bodyPr/>
                     <a:lstStyle/>
                     <a:p>
-                      <a:pPr marL="0" indent="0" algn="ctr">
-                        <a:buNone/>
-                      </a:pPr>
                       <a:r>
-                        <a:rPr lang="en-US" sz="1150">
-                          <a:solidFill>
-                            <a:srgbClr val="1E2761"/>
-                          </a:solidFill>
-                          <a:latin typeface="Calibri" pitchFamily="34" charset="0"/>
-                          <a:ea typeface="Calibri" pitchFamily="34" charset="-122"/>
-                          <a:cs typeface="Calibri" pitchFamily="34" charset="-120"/>
-                        </a:rPr>
                         <a:t>R$ 177.749,96</a:t>
                       </a:r>
-                      <a:endParaRPr lang="en-US" sz="1150" dirty="0">
-                        <a:latin typeface="Calibri" charset="0"/>
-                        <a:ea typeface="Calibri" charset="0"/>
-                        <a:cs typeface="Calibri" charset="0"/>
-                      </a:endParaRPr>
                     </a:p>
                   </a:txBody>
                   <a:tcPr anchor="ctr">
@@ -4315,25 +4199,9 @@
                     <a:bodyPr/>
                     <a:lstStyle/>
                     <a:p>
-                      <a:pPr marL="0" indent="0" algn="ctr">
-                        <a:buNone/>
-                      </a:pPr>
                       <a:r>
-                        <a:rPr lang="en-US" sz="1150">
-                          <a:solidFill>
-                            <a:srgbClr val="1E2761"/>
-                          </a:solidFill>
-                          <a:latin typeface="Calibri" pitchFamily="34" charset="0"/>
-                          <a:ea typeface="Calibri" pitchFamily="34" charset="-122"/>
-                          <a:cs typeface="Calibri" pitchFamily="34" charset="-120"/>
-                        </a:rPr>
-                        <a:t>R$ 159.609,43</a:t>
+                        <a:t>R$ 164.144,56</a:t>
                       </a:r>
-                      <a:endParaRPr lang="en-US" sz="1150" dirty="0">
-                        <a:latin typeface="Calibri" charset="0"/>
-                        <a:ea typeface="Calibri" charset="0"/>
-                        <a:cs typeface="Calibri" charset="0"/>
-                      </a:endParaRPr>
                     </a:p>
                   </a:txBody>
                   <a:tcPr anchor="ctr">
@@ -4359,25 +4227,9 @@
                     <a:bodyPr/>
                     <a:lstStyle/>
                     <a:p>
-                      <a:pPr marL="0" indent="0" algn="ctr">
-                        <a:buNone/>
-                      </a:pPr>
                       <a:r>
-                        <a:rPr lang="en-US" sz="1150">
-                          <a:solidFill>
-                            <a:srgbClr val="1E2761"/>
-                          </a:solidFill>
-                          <a:latin typeface="Calibri" pitchFamily="34" charset="0"/>
-                          <a:ea typeface="Calibri" pitchFamily="34" charset="-122"/>
-                          <a:cs typeface="Calibri" pitchFamily="34" charset="-120"/>
-                        </a:rPr>
-                        <a:t>R$ 18.140,54</a:t>
+                        <a:t>R$ 13.605,40</a:t>
                       </a:r>
-                      <a:endParaRPr lang="en-US" sz="1150" dirty="0">
-                        <a:latin typeface="Calibri" charset="0"/>
-                        <a:ea typeface="Calibri" charset="0"/>
-                        <a:cs typeface="Calibri" charset="0"/>
-                      </a:endParaRPr>
                     </a:p>
                   </a:txBody>
                   <a:tcPr anchor="ctr">
@@ -4403,25 +4255,9 @@
                     <a:bodyPr/>
                     <a:lstStyle/>
                     <a:p>
-                      <a:pPr marL="0" indent="0" algn="ctr">
-                        <a:buNone/>
-                      </a:pPr>
                       <a:r>
-                        <a:rPr lang="en-US" sz="1150" b="1">
-                          <a:solidFill>
-                            <a:srgbClr val="028090"/>
-                          </a:solidFill>
-                          <a:latin typeface="Calibri" pitchFamily="34" charset="0"/>
-                          <a:ea typeface="Calibri" pitchFamily="34" charset="-122"/>
-                          <a:cs typeface="Calibri" pitchFamily="34" charset="-120"/>
-                        </a:rPr>
-                        <a:t>-10,2%</a:t>
+                        <a:t>-7,7%</a:t>
                       </a:r>
-                      <a:endParaRPr lang="en-US" sz="1150" dirty="0">
-                        <a:latin typeface="Calibri" charset="0"/>
-                        <a:ea typeface="Calibri" charset="0"/>
-                        <a:cs typeface="Calibri" charset="0"/>
-                      </a:endParaRPr>
                     </a:p>
                   </a:txBody>
                   <a:tcPr anchor="ctr">
@@ -4498,25 +4334,9 @@
                     <a:bodyPr/>
                     <a:lstStyle/>
                     <a:p>
-                      <a:pPr marL="0" indent="0" algn="ctr">
-                        <a:buNone/>
-                      </a:pPr>
                       <a:r>
-                        <a:rPr lang="en-US" sz="1150">
-                          <a:solidFill>
-                            <a:srgbClr val="1E2761"/>
-                          </a:solidFill>
-                          <a:latin typeface="Calibri" pitchFamily="34" charset="0"/>
-                          <a:ea typeface="Calibri" pitchFamily="34" charset="-122"/>
-                          <a:cs typeface="Calibri" pitchFamily="34" charset="-120"/>
-                        </a:rPr>
                         <a:t>R$ 2.132.999,57</a:t>
                       </a:r>
-                      <a:endParaRPr lang="en-US" sz="1150" dirty="0">
-                        <a:latin typeface="Calibri" charset="0"/>
-                        <a:ea typeface="Calibri" charset="0"/>
-                        <a:cs typeface="Calibri" charset="0"/>
-                      </a:endParaRPr>
                     </a:p>
                   </a:txBody>
                   <a:tcPr anchor="ctr">
@@ -4542,25 +4362,9 @@
                     <a:bodyPr/>
                     <a:lstStyle/>
                     <a:p>
-                      <a:pPr marL="0" indent="0" algn="ctr">
-                        <a:buNone/>
-                      </a:pPr>
                       <a:r>
-                        <a:rPr lang="en-US" sz="1150">
-                          <a:solidFill>
-                            <a:srgbClr val="1E2761"/>
-                          </a:solidFill>
-                          <a:latin typeface="Calibri" pitchFamily="34" charset="0"/>
-                          <a:ea typeface="Calibri" pitchFamily="34" charset="-122"/>
-                          <a:cs typeface="Calibri" pitchFamily="34" charset="-120"/>
-                        </a:rPr>
-                        <a:t>R$ 1.915.313,15</a:t>
+                        <a:t>R$ 1.969.734,75</a:t>
                       </a:r>
-                      <a:endParaRPr lang="en-US" sz="1150" dirty="0">
-                        <a:latin typeface="Calibri" charset="0"/>
-                        <a:ea typeface="Calibri" charset="0"/>
-                        <a:cs typeface="Calibri" charset="0"/>
-                      </a:endParaRPr>
                     </a:p>
                   </a:txBody>
                   <a:tcPr anchor="ctr">
@@ -4586,25 +4390,9 @@
                     <a:bodyPr/>
                     <a:lstStyle/>
                     <a:p>
-                      <a:pPr marL="0" indent="0" algn="ctr">
-                        <a:buNone/>
-                      </a:pPr>
                       <a:r>
-                        <a:rPr lang="en-US" sz="1150">
-                          <a:solidFill>
-                            <a:srgbClr val="1E2761"/>
-                          </a:solidFill>
-                          <a:latin typeface="Calibri" pitchFamily="34" charset="0"/>
-                          <a:ea typeface="Calibri" pitchFamily="34" charset="-122"/>
-                          <a:cs typeface="Calibri" pitchFamily="34" charset="-120"/>
-                        </a:rPr>
-                        <a:t>R$ 217.686,42</a:t>
+                        <a:t>R$ 163.264,82</a:t>
                       </a:r>
-                      <a:endParaRPr lang="en-US" sz="1150" dirty="0">
-                        <a:latin typeface="Calibri" charset="0"/>
-                        <a:ea typeface="Calibri" charset="0"/>
-                        <a:cs typeface="Calibri" charset="0"/>
-                      </a:endParaRPr>
                     </a:p>
                   </a:txBody>
                   <a:tcPr anchor="ctr">
@@ -4630,25 +4418,9 @@
                     <a:bodyPr/>
                     <a:lstStyle/>
                     <a:p>
-                      <a:pPr marL="0" indent="0" algn="ctr">
-                        <a:buNone/>
-                      </a:pPr>
                       <a:r>
-                        <a:rPr lang="en-US" sz="1150" b="1">
-                          <a:solidFill>
-                            <a:srgbClr val="028090"/>
-                          </a:solidFill>
-                          <a:latin typeface="Calibri" pitchFamily="34" charset="0"/>
-                          <a:ea typeface="Calibri" pitchFamily="34" charset="-122"/>
-                          <a:cs typeface="Calibri" pitchFamily="34" charset="-120"/>
-                        </a:rPr>
-                        <a:t>-10,2%</a:t>
+                        <a:t>-7,7%</a:t>
                       </a:r>
-                      <a:endParaRPr lang="en-US" sz="1150" dirty="0">
-                        <a:latin typeface="Calibri" charset="0"/>
-                        <a:ea typeface="Calibri" charset="0"/>
-                        <a:cs typeface="Calibri" charset="0"/>
-                      </a:endParaRPr>
                     </a:p>
                   </a:txBody>
                   <a:tcPr anchor="ctr">
@@ -4967,6 +4739,13 @@
             </a:outerShdw>
           </a:effectLst>
         </p:spPr>
+        <p:txBody>
+          <a:bodyPr/>
+          <a:lstStyle/>
+          <a:p>
+            <a:endParaRPr/>
+          </a:p>
+        </p:txBody>
       </p:sp>
       <p:sp>
         <p:nvSpPr>
@@ -5074,6 +4853,13 @@
             </a:outerShdw>
           </a:effectLst>
         </p:spPr>
+        <p:txBody>
+          <a:bodyPr/>
+          <a:lstStyle/>
+          <a:p>
+            <a:endParaRPr/>
+          </a:p>
+        </p:txBody>
       </p:sp>
       <p:sp>
         <p:nvSpPr>
@@ -5100,15 +4886,7 @@
               <a:buNone/>
             </a:pPr>
             <a:r>
-              <a:rPr lang="en-US" sz="2200" b="1">
-                <a:solidFill>
-                  <a:srgbClr val="028090"/>
-                </a:solidFill>
-                <a:latin typeface="Cambria" pitchFamily="34" charset="0"/>
-                <a:ea typeface="Cambria" pitchFamily="34" charset="-122"/>
-                <a:cs typeface="Cambria" pitchFamily="34" charset="-120"/>
-              </a:rPr>
-              <a:t>16,5 meses</a:t>
+              <a:t>22,1 meses</a:t>
             </a:r>
             <a:endParaRPr lang="en-US" sz="2200" dirty="0"/>
           </a:p>
@@ -5181,6 +4959,13 @@
             </a:outerShdw>
           </a:effectLst>
         </p:spPr>
+        <p:txBody>
+          <a:bodyPr/>
+          <a:lstStyle/>
+          <a:p>
+            <a:endParaRPr/>
+          </a:p>
+        </p:txBody>
       </p:sp>
       <p:sp>
         <p:nvSpPr>
@@ -5207,15 +4992,7 @@
               <a:buNone/>
             </a:pPr>
             <a:r>
-              <a:rPr lang="en-US" sz="2200" b="1">
-                <a:solidFill>
-                  <a:srgbClr val="1E2761"/>
-                </a:solidFill>
-                <a:latin typeface="Cambria" pitchFamily="34" charset="0"/>
-                <a:ea typeface="Cambria" pitchFamily="34" charset="-122"/>
-                <a:cs typeface="Cambria" pitchFamily="34" charset="-120"/>
-              </a:rPr>
-              <a:t>+262,8%</a:t>
+              <a:t>+172,1%</a:t>
             </a:r>
             <a:endParaRPr lang="en-US" sz="2200" dirty="0"/>
           </a:p>
@@ -5288,6 +5065,13 @@
             </a:outerShdw>
           </a:effectLst>
         </p:spPr>
+        <p:txBody>
+          <a:bodyPr/>
+          <a:lstStyle/>
+          <a:p>
+            <a:endParaRPr/>
+          </a:p>
+        </p:txBody>
       </p:sp>
       <p:sp>
         <p:nvSpPr>
@@ -5314,15 +5098,7 @@
               <a:buNone/>
             </a:pPr>
             <a:r>
-              <a:rPr lang="en-US" sz="2200" b="1">
-                <a:solidFill>
-                  <a:srgbClr val="028090"/>
-                </a:solidFill>
-                <a:latin typeface="Cambria" pitchFamily="34" charset="0"/>
-                <a:ea typeface="Cambria" pitchFamily="34" charset="-122"/>
-                <a:cs typeface="Cambria" pitchFamily="34" charset="-120"/>
-              </a:rPr>
-              <a:t>R$ 484.710</a:t>
+              <a:t>R$ 288.533</a:t>
             </a:r>
             <a:endParaRPr lang="en-US" sz="2200" dirty="0"/>
           </a:p>
@@ -5443,6 +5219,13 @@
           </a:solidFill>
           <a:ln/>
         </p:spPr>
+        <p:txBody>
+          <a:bodyPr/>
+          <a:lstStyle/>
+          <a:p>
+            <a:endParaRPr/>
+          </a:p>
+        </p:txBody>
       </p:sp>
       <p:sp>
         <p:nvSpPr>
@@ -5544,6 +5327,13 @@
             <a:prstDash val="solid"/>
           </a:ln>
         </p:spPr>
+        <p:txBody>
+          <a:bodyPr/>
+          <a:lstStyle/>
+          <a:p>
+            <a:endParaRPr/>
+          </a:p>
+        </p:txBody>
       </p:sp>
       <p:sp>
         <p:nvSpPr>
@@ -5645,6 +5435,13 @@
             <a:prstDash val="solid"/>
           </a:ln>
         </p:spPr>
+        <p:txBody>
+          <a:bodyPr/>
+          <a:lstStyle/>
+          <a:p>
+            <a:endParaRPr/>
+          </a:p>
+        </p:txBody>
       </p:sp>
       <p:sp>
         <p:nvSpPr>
@@ -5895,6 +5692,13 @@
           </a:solidFill>
           <a:ln/>
         </p:spPr>
+        <p:txBody>
+          <a:bodyPr/>
+          <a:lstStyle/>
+          <a:p>
+            <a:endParaRPr/>
+          </a:p>
+        </p:txBody>
       </p:sp>
       <p:sp>
         <p:nvSpPr>
@@ -5921,15 +5725,7 @@
               <a:buNone/>
             </a:pPr>
             <a:r>
-              <a:rPr lang="en-US" sz="3400" b="1">
-                <a:solidFill>
-                  <a:srgbClr val="00A896"/>
-                </a:solidFill>
-                <a:latin typeface="Cambria" pitchFamily="34" charset="0"/>
-                <a:ea typeface="Cambria" pitchFamily="34" charset="-122"/>
-                <a:cs typeface="Cambria" pitchFamily="34" charset="-120"/>
-              </a:rPr>
-              <a:t>25,0 tCO2/ano</a:t>
+              <a:t>18,7 tCO2/ano</a:t>
             </a:r>
             <a:endParaRPr lang="en-US" sz="3400" dirty="0"/>
           </a:p>
@@ -5996,6 +5792,13 @@
             <a:prstDash val="solid"/>
           </a:ln>
         </p:spPr>
+        <p:txBody>
+          <a:bodyPr/>
+          <a:lstStyle/>
+          <a:p>
+            <a:endParaRPr/>
+          </a:p>
+        </p:txBody>
       </p:sp>
       <p:sp>
         <p:nvSpPr>
@@ -6025,7 +5828,69 @@
               <a:buNone/>
             </a:pPr>
             <a:r>
-              <a:rPr lang="en-US" sz="1250" b="1">
+              <a:t>217.686 kWh/ano de energia economizada</a:t>
+            </a:r>
+            <a:br/>
+            <a:r>
+              <a:t>0,086 kg CO2/kWh fator de emissão (SIN / MCTI)</a:t>
+            </a:r>
+            <a:endParaRPr lang="en-US" sz="1250" dirty="0"/>
+          </a:p>
+        </p:txBody>
+      </p:sp>
+      <p:sp>
+        <p:nvSpPr>
+          <p:cNvPr id="8" name="Shape 6"/>
+          <p:cNvSpPr/>
+          <p:nvPr/>
+        </p:nvSpPr>
+        <p:spPr>
+          <a:xfrm>
+            <a:off x="6126480" y="1371600"/>
+            <a:ext cx="640080" cy="640080"/>
+          </a:xfrm>
+          <a:prstGeom prst="ellipse">
+            <a:avLst/>
+          </a:prstGeom>
+          <a:solidFill>
+            <a:srgbClr val="00A896"/>
+          </a:solidFill>
+          <a:ln/>
+        </p:spPr>
+        <p:txBody>
+          <a:bodyPr/>
+          <a:lstStyle/>
+          <a:p>
+            <a:endParaRPr/>
+          </a:p>
+        </p:txBody>
+      </p:sp>
+      <p:sp>
+        <p:nvSpPr>
+          <p:cNvPr id="9" name="Text 7"/>
+          <p:cNvSpPr txBox="1"/>
+          <p:nvPr/>
+        </p:nvSpPr>
+        <p:spPr>
+          <a:xfrm>
+            <a:off x="6126480" y="1371600"/>
+            <a:ext cx="640080" cy="640080"/>
+          </a:xfrm>
+          <a:prstGeom prst="rect">
+            <a:avLst/>
+          </a:prstGeom>
+          <a:noFill/>
+          <a:ln/>
+        </p:spPr>
+        <p:txBody>
+          <a:bodyPr wrap="square" lIns="0" tIns="0" rIns="0" bIns="0" rtlCol="0" anchor="ctr"/>
+          <a:lstStyle/>
+          <a:p>
+            <a:pPr marL="0" indent="0" algn="ctr">
+              <a:buNone/>
+            </a:pPr>
+            <a:r>
+              <a:rPr lang="en-US" sz="1800" b="1" dirty="0">
                 <a:solidFill>
                   <a:srgbClr val="FFFFFF"/>
                 </a:solidFill>
@@ -6033,22 +5898,143 @@
                 <a:ea typeface="Calibri" pitchFamily="34" charset="-122"/>
                 <a:cs typeface="Calibri" pitchFamily="34" charset="-120"/>
               </a:rPr>
-              <a:t>290.249 kWh/ano </a:t>
-            </a:r>
-            <a:r>
-              <a:rPr lang="en-US" sz="1250" dirty="0">
-                <a:solidFill>
-                  <a:srgbClr val="CADCFC"/>
+              <a:t>1.560</a:t>
+            </a:r>
+            <a:endParaRPr lang="en-US" sz="1800" dirty="0"/>
+          </a:p>
+        </p:txBody>
+      </p:sp>
+      <p:sp>
+        <p:nvSpPr>
+          <p:cNvPr id="10" name="Text 8"/>
+          <p:cNvSpPr txBox="1"/>
+          <p:nvPr/>
+        </p:nvSpPr>
+        <p:spPr>
+          <a:xfrm>
+            <a:off x="6949440" y="1353312"/>
+            <a:ext cx="4572000" cy="365760"/>
+          </a:xfrm>
+          <a:prstGeom prst="rect">
+            <a:avLst/>
+          </a:prstGeom>
+          <a:noFill/>
+          <a:ln/>
+        </p:spPr>
+        <p:txBody>
+          <a:bodyPr wrap="square" lIns="0" tIns="0" rIns="0" bIns="0" rtlCol="0" anchor="ctr"/>
+          <a:lstStyle/>
+          <a:p>
+            <a:pPr marL="0" indent="0">
+              <a:buNone/>
+            </a:pPr>
+            <a:r>
+              <a:rPr lang="en-US" sz="1600" b="1" dirty="0">
+                <a:solidFill>
+                  <a:srgbClr val="1E2761"/>
+                </a:solidFill>
+                <a:latin typeface="Cambria" pitchFamily="34" charset="0"/>
+                <a:ea typeface="Cambria" pitchFamily="34" charset="-122"/>
+                <a:cs typeface="Cambria" pitchFamily="34" charset="-120"/>
+              </a:rPr>
+              <a:t>~1.560 árvores</a:t>
+            </a:r>
+            <a:endParaRPr lang="en-US" sz="1600" dirty="0"/>
+          </a:p>
+        </p:txBody>
+      </p:sp>
+      <p:sp>
+        <p:nvSpPr>
+          <p:cNvPr id="11" name="Text 9"/>
+          <p:cNvSpPr txBox="1"/>
+          <p:nvPr/>
+        </p:nvSpPr>
+        <p:spPr>
+          <a:xfrm>
+            <a:off x="6949440" y="1691640"/>
+            <a:ext cx="4572000" cy="594360"/>
+          </a:xfrm>
+          <a:prstGeom prst="rect">
+            <a:avLst/>
+          </a:prstGeom>
+          <a:noFill/>
+          <a:ln/>
+        </p:spPr>
+        <p:txBody>
+          <a:bodyPr wrap="square" lIns="0" tIns="0" rIns="0" bIns="0" rtlCol="0" anchor="ctr"/>
+          <a:lstStyle/>
+          <a:p>
+            <a:pPr marL="0" indent="0">
+              <a:buNone/>
+            </a:pPr>
+            <a:r>
+              <a:rPr lang="en-US" sz="1150" dirty="0">
+                <a:solidFill>
+                  <a:srgbClr val="5A6472"/>
                 </a:solidFill>
                 <a:latin typeface="Calibri" pitchFamily="34" charset="0"/>
                 <a:ea typeface="Calibri" pitchFamily="34" charset="-122"/>
                 <a:cs typeface="Calibri" pitchFamily="34" charset="-120"/>
               </a:rPr>
-              <a:t>de energia economizada
-</a:t>
-            </a:r>
-            <a:r>
-              <a:rPr lang="en-US" sz="1250" b="1" dirty="0">
+              <a:t>plantadas e preservadas por ano para absorver o mesmo volume de carbono</a:t>
+            </a:r>
+            <a:endParaRPr lang="en-US" sz="1150" dirty="0"/>
+          </a:p>
+        </p:txBody>
+      </p:sp>
+      <p:sp>
+        <p:nvSpPr>
+          <p:cNvPr id="12" name="Shape 10"/>
+          <p:cNvSpPr/>
+          <p:nvPr/>
+        </p:nvSpPr>
+        <p:spPr>
+          <a:xfrm>
+            <a:off x="6126480" y="2788920"/>
+            <a:ext cx="640080" cy="640080"/>
+          </a:xfrm>
+          <a:prstGeom prst="ellipse">
+            <a:avLst/>
+          </a:prstGeom>
+          <a:solidFill>
+            <a:srgbClr val="00A896"/>
+          </a:solidFill>
+          <a:ln/>
+        </p:spPr>
+        <p:txBody>
+          <a:bodyPr/>
+          <a:lstStyle/>
+          <a:p>
+            <a:endParaRPr/>
+          </a:p>
+        </p:txBody>
+      </p:sp>
+      <p:sp>
+        <p:nvSpPr>
+          <p:cNvPr id="13" name="Text 11"/>
+          <p:cNvSpPr txBox="1"/>
+          <p:nvPr/>
+        </p:nvSpPr>
+        <p:spPr>
+          <a:xfrm>
+            <a:off x="6126480" y="2788920"/>
+            <a:ext cx="640080" cy="640080"/>
+          </a:xfrm>
+          <a:prstGeom prst="rect">
+            <a:avLst/>
+          </a:prstGeom>
+          <a:noFill/>
+          <a:ln/>
+        </p:spPr>
+        <p:txBody>
+          <a:bodyPr wrap="square" lIns="0" tIns="0" rIns="0" bIns="0" rtlCol="0" anchor="ctr"/>
+          <a:lstStyle/>
+          <a:p>
+            <a:pPr marL="0" indent="0" algn="ctr">
+              <a:buNone/>
+            </a:pPr>
+            <a:r>
+              <a:rPr lang="en-US" sz="1800" b="1" dirty="0">
                 <a:solidFill>
                   <a:srgbClr val="FFFFFF"/>
                 </a:solidFill>
@@ -6056,32 +6042,99 @@
                 <a:ea typeface="Calibri" pitchFamily="34" charset="-122"/>
                 <a:cs typeface="Calibri" pitchFamily="34" charset="-120"/>
               </a:rPr>
-              <a:t>0,086 kg CO2/kWh </a:t>
-            </a:r>
-            <a:r>
-              <a:rPr lang="en-US" sz="1250" dirty="0">
-                <a:solidFill>
-                  <a:srgbClr val="CADCFC"/>
+              <a:t>54</a:t>
+            </a:r>
+            <a:endParaRPr lang="en-US" sz="1800" dirty="0"/>
+          </a:p>
+        </p:txBody>
+      </p:sp>
+      <p:sp>
+        <p:nvSpPr>
+          <p:cNvPr id="14" name="Text 12"/>
+          <p:cNvSpPr txBox="1"/>
+          <p:nvPr/>
+        </p:nvSpPr>
+        <p:spPr>
+          <a:xfrm>
+            <a:off x="6949440" y="2770632"/>
+            <a:ext cx="4572000" cy="365760"/>
+          </a:xfrm>
+          <a:prstGeom prst="rect">
+            <a:avLst/>
+          </a:prstGeom>
+          <a:noFill/>
+          <a:ln/>
+        </p:spPr>
+        <p:txBody>
+          <a:bodyPr wrap="square" lIns="0" tIns="0" rIns="0" bIns="0" rtlCol="0" anchor="ctr"/>
+          <a:lstStyle/>
+          <a:p>
+            <a:pPr marL="0" indent="0">
+              <a:buNone/>
+            </a:pPr>
+            <a:r>
+              <a:rPr lang="en-US" sz="1600" b="1" dirty="0">
+                <a:solidFill>
+                  <a:srgbClr val="1E2761"/>
+                </a:solidFill>
+                <a:latin typeface="Cambria" pitchFamily="34" charset="0"/>
+                <a:ea typeface="Cambria" pitchFamily="34" charset="-122"/>
+                <a:cs typeface="Cambria" pitchFamily="34" charset="-120"/>
+              </a:rPr>
+              <a:t>~54 veículos</a:t>
+            </a:r>
+            <a:endParaRPr lang="en-US" sz="1600" dirty="0"/>
+          </a:p>
+        </p:txBody>
+      </p:sp>
+      <p:sp>
+        <p:nvSpPr>
+          <p:cNvPr id="15" name="Text 13"/>
+          <p:cNvSpPr txBox="1"/>
+          <p:nvPr/>
+        </p:nvSpPr>
+        <p:spPr>
+          <a:xfrm>
+            <a:off x="6949440" y="3108960"/>
+            <a:ext cx="4572000" cy="594360"/>
+          </a:xfrm>
+          <a:prstGeom prst="rect">
+            <a:avLst/>
+          </a:prstGeom>
+          <a:noFill/>
+          <a:ln/>
+        </p:spPr>
+        <p:txBody>
+          <a:bodyPr wrap="square" lIns="0" tIns="0" rIns="0" bIns="0" rtlCol="0" anchor="ctr"/>
+          <a:lstStyle/>
+          <a:p>
+            <a:pPr marL="0" indent="0">
+              <a:buNone/>
+            </a:pPr>
+            <a:r>
+              <a:rPr lang="en-US" sz="1150" dirty="0">
+                <a:solidFill>
+                  <a:srgbClr val="5A6472"/>
                 </a:solidFill>
                 <a:latin typeface="Calibri" pitchFamily="34" charset="0"/>
                 <a:ea typeface="Calibri" pitchFamily="34" charset="-122"/>
                 <a:cs typeface="Calibri" pitchFamily="34" charset="-120"/>
               </a:rPr>
-              <a:t>fator de emissão (SIN / MCTI)</a:t>
-            </a:r>
-            <a:endParaRPr lang="en-US" sz="1250" dirty="0"/>
-          </a:p>
-        </p:txBody>
-      </p:sp>
-      <p:sp>
-        <p:nvSpPr>
-          <p:cNvPr id="8" name="Shape 6"/>
+              <a:t>de passeio a combustão retirados de circulação nas avenidas de Ribeirão Preto</a:t>
+            </a:r>
+            <a:endParaRPr lang="en-US" sz="1150" dirty="0"/>
+          </a:p>
+        </p:txBody>
+      </p:sp>
+      <p:sp>
+        <p:nvSpPr>
+          <p:cNvPr id="16" name="Shape 14"/>
           <p:cNvSpPr/>
           <p:nvPr/>
         </p:nvSpPr>
         <p:spPr>
           <a:xfrm>
-            <a:off x="6126480" y="1371600"/>
+            <a:off x="6126480" y="4206240"/>
             <a:ext cx="640080" cy="640080"/>
           </a:xfrm>
           <a:prstGeom prst="ellipse">
@@ -6092,280 +6145,13 @@
           </a:solidFill>
           <a:ln/>
         </p:spPr>
-      </p:sp>
-      <p:sp>
-        <p:nvSpPr>
-          <p:cNvPr id="9" name="Text 7"/>
-          <p:cNvSpPr txBox="1"/>
-          <p:nvPr/>
-        </p:nvSpPr>
-        <p:spPr>
-          <a:xfrm>
-            <a:off x="6126480" y="1371600"/>
-            <a:ext cx="640080" cy="640080"/>
-          </a:xfrm>
-          <a:prstGeom prst="rect">
-            <a:avLst/>
-          </a:prstGeom>
-          <a:noFill/>
-          <a:ln/>
-        </p:spPr>
-        <p:txBody>
-          <a:bodyPr wrap="square" lIns="0" tIns="0" rIns="0" bIns="0" rtlCol="0" anchor="ctr"/>
-          <a:lstStyle/>
-          <a:p>
-            <a:pPr marL="0" indent="0" algn="ctr">
-              <a:buNone/>
-            </a:pPr>
-            <a:r>
-              <a:rPr lang="en-US" sz="1800" b="1" dirty="0">
-                <a:solidFill>
-                  <a:srgbClr val="FFFFFF"/>
-                </a:solidFill>
-                <a:latin typeface="Calibri" pitchFamily="34" charset="0"/>
-                <a:ea typeface="Calibri" pitchFamily="34" charset="-122"/>
-                <a:cs typeface="Calibri" pitchFamily="34" charset="-120"/>
-              </a:rPr>
-              <a:t>1.560</a:t>
-            </a:r>
-            <a:endParaRPr lang="en-US" sz="1800" dirty="0"/>
-          </a:p>
-        </p:txBody>
-      </p:sp>
-      <p:sp>
-        <p:nvSpPr>
-          <p:cNvPr id="10" name="Text 8"/>
-          <p:cNvSpPr txBox="1"/>
-          <p:nvPr/>
-        </p:nvSpPr>
-        <p:spPr>
-          <a:xfrm>
-            <a:off x="6949440" y="1353312"/>
-            <a:ext cx="4572000" cy="365760"/>
-          </a:xfrm>
-          <a:prstGeom prst="rect">
-            <a:avLst/>
-          </a:prstGeom>
-          <a:noFill/>
-          <a:ln/>
-        </p:spPr>
-        <p:txBody>
-          <a:bodyPr wrap="square" lIns="0" tIns="0" rIns="0" bIns="0" rtlCol="0" anchor="ctr"/>
-          <a:lstStyle/>
-          <a:p>
-            <a:pPr marL="0" indent="0">
-              <a:buNone/>
-            </a:pPr>
-            <a:r>
-              <a:rPr lang="en-US" sz="1600" b="1" dirty="0">
-                <a:solidFill>
-                  <a:srgbClr val="1E2761"/>
-                </a:solidFill>
-                <a:latin typeface="Cambria" pitchFamily="34" charset="0"/>
-                <a:ea typeface="Cambria" pitchFamily="34" charset="-122"/>
-                <a:cs typeface="Cambria" pitchFamily="34" charset="-120"/>
-              </a:rPr>
-              <a:t>~1.560 árvores</a:t>
-            </a:r>
-            <a:endParaRPr lang="en-US" sz="1600" dirty="0"/>
-          </a:p>
-        </p:txBody>
-      </p:sp>
-      <p:sp>
-        <p:nvSpPr>
-          <p:cNvPr id="11" name="Text 9"/>
-          <p:cNvSpPr txBox="1"/>
-          <p:nvPr/>
-        </p:nvSpPr>
-        <p:spPr>
-          <a:xfrm>
-            <a:off x="6949440" y="1691640"/>
-            <a:ext cx="4572000" cy="594360"/>
-          </a:xfrm>
-          <a:prstGeom prst="rect">
-            <a:avLst/>
-          </a:prstGeom>
-          <a:noFill/>
-          <a:ln/>
-        </p:spPr>
-        <p:txBody>
-          <a:bodyPr wrap="square" lIns="0" tIns="0" rIns="0" bIns="0" rtlCol="0" anchor="ctr"/>
-          <a:lstStyle/>
-          <a:p>
-            <a:pPr marL="0" indent="0">
-              <a:buNone/>
-            </a:pPr>
-            <a:r>
-              <a:rPr lang="en-US" sz="1150" dirty="0">
-                <a:solidFill>
-                  <a:srgbClr val="5A6472"/>
-                </a:solidFill>
-                <a:latin typeface="Calibri" pitchFamily="34" charset="0"/>
-                <a:ea typeface="Calibri" pitchFamily="34" charset="-122"/>
-                <a:cs typeface="Calibri" pitchFamily="34" charset="-120"/>
-              </a:rPr>
-              <a:t>plantadas e preservadas por ano para absorver o mesmo volume de carbono</a:t>
-            </a:r>
-            <a:endParaRPr lang="en-US" sz="1150" dirty="0"/>
-          </a:p>
-        </p:txBody>
-      </p:sp>
-      <p:sp>
-        <p:nvSpPr>
-          <p:cNvPr id="12" name="Shape 10"/>
-          <p:cNvSpPr/>
-          <p:nvPr/>
-        </p:nvSpPr>
-        <p:spPr>
-          <a:xfrm>
-            <a:off x="6126480" y="2788920"/>
-            <a:ext cx="640080" cy="640080"/>
-          </a:xfrm>
-          <a:prstGeom prst="ellipse">
-            <a:avLst/>
-          </a:prstGeom>
-          <a:solidFill>
-            <a:srgbClr val="00A896"/>
-          </a:solidFill>
-          <a:ln/>
-        </p:spPr>
-      </p:sp>
-      <p:sp>
-        <p:nvSpPr>
-          <p:cNvPr id="13" name="Text 11"/>
-          <p:cNvSpPr txBox="1"/>
-          <p:nvPr/>
-        </p:nvSpPr>
-        <p:spPr>
-          <a:xfrm>
-            <a:off x="6126480" y="2788920"/>
-            <a:ext cx="640080" cy="640080"/>
-          </a:xfrm>
-          <a:prstGeom prst="rect">
-            <a:avLst/>
-          </a:prstGeom>
-          <a:noFill/>
-          <a:ln/>
-        </p:spPr>
-        <p:txBody>
-          <a:bodyPr wrap="square" lIns="0" tIns="0" rIns="0" bIns="0" rtlCol="0" anchor="ctr"/>
-          <a:lstStyle/>
-          <a:p>
-            <a:pPr marL="0" indent="0" algn="ctr">
-              <a:buNone/>
-            </a:pPr>
-            <a:r>
-              <a:rPr lang="en-US" sz="1800" b="1" dirty="0">
-                <a:solidFill>
-                  <a:srgbClr val="FFFFFF"/>
-                </a:solidFill>
-                <a:latin typeface="Calibri" pitchFamily="34" charset="0"/>
-                <a:ea typeface="Calibri" pitchFamily="34" charset="-122"/>
-                <a:cs typeface="Calibri" pitchFamily="34" charset="-120"/>
-              </a:rPr>
-              <a:t>54</a:t>
-            </a:r>
-            <a:endParaRPr lang="en-US" sz="1800" dirty="0"/>
-          </a:p>
-        </p:txBody>
-      </p:sp>
-      <p:sp>
-        <p:nvSpPr>
-          <p:cNvPr id="14" name="Text 12"/>
-          <p:cNvSpPr txBox="1"/>
-          <p:nvPr/>
-        </p:nvSpPr>
-        <p:spPr>
-          <a:xfrm>
-            <a:off x="6949440" y="2770632"/>
-            <a:ext cx="4572000" cy="365760"/>
-          </a:xfrm>
-          <a:prstGeom prst="rect">
-            <a:avLst/>
-          </a:prstGeom>
-          <a:noFill/>
-          <a:ln/>
-        </p:spPr>
-        <p:txBody>
-          <a:bodyPr wrap="square" lIns="0" tIns="0" rIns="0" bIns="0" rtlCol="0" anchor="ctr"/>
-          <a:lstStyle/>
-          <a:p>
-            <a:pPr marL="0" indent="0">
-              <a:buNone/>
-            </a:pPr>
-            <a:r>
-              <a:rPr lang="en-US" sz="1600" b="1" dirty="0">
-                <a:solidFill>
-                  <a:srgbClr val="1E2761"/>
-                </a:solidFill>
-                <a:latin typeface="Cambria" pitchFamily="34" charset="0"/>
-                <a:ea typeface="Cambria" pitchFamily="34" charset="-122"/>
-                <a:cs typeface="Cambria" pitchFamily="34" charset="-120"/>
-              </a:rPr>
-              <a:t>~54 veículos</a:t>
-            </a:r>
-            <a:endParaRPr lang="en-US" sz="1600" dirty="0"/>
-          </a:p>
-        </p:txBody>
-      </p:sp>
-      <p:sp>
-        <p:nvSpPr>
-          <p:cNvPr id="15" name="Text 13"/>
-          <p:cNvSpPr txBox="1"/>
-          <p:nvPr/>
-        </p:nvSpPr>
-        <p:spPr>
-          <a:xfrm>
-            <a:off x="6949440" y="3108960"/>
-            <a:ext cx="4572000" cy="594360"/>
-          </a:xfrm>
-          <a:prstGeom prst="rect">
-            <a:avLst/>
-          </a:prstGeom>
-          <a:noFill/>
-          <a:ln/>
-        </p:spPr>
-        <p:txBody>
-          <a:bodyPr wrap="square" lIns="0" tIns="0" rIns="0" bIns="0" rtlCol="0" anchor="ctr"/>
-          <a:lstStyle/>
-          <a:p>
-            <a:pPr marL="0" indent="0">
-              <a:buNone/>
-            </a:pPr>
-            <a:r>
-              <a:rPr lang="en-US" sz="1150" dirty="0">
-                <a:solidFill>
-                  <a:srgbClr val="5A6472"/>
-                </a:solidFill>
-                <a:latin typeface="Calibri" pitchFamily="34" charset="0"/>
-                <a:ea typeface="Calibri" pitchFamily="34" charset="-122"/>
-                <a:cs typeface="Calibri" pitchFamily="34" charset="-120"/>
-              </a:rPr>
-              <a:t>de passeio a combustão retirados de circulação nas avenidas de Ribeirão Preto</a:t>
-            </a:r>
-            <a:endParaRPr lang="en-US" sz="1150" dirty="0"/>
-          </a:p>
-        </p:txBody>
-      </p:sp>
-      <p:sp>
-        <p:nvSpPr>
-          <p:cNvPr id="16" name="Shape 14"/>
-          <p:cNvSpPr/>
-          <p:nvPr/>
-        </p:nvSpPr>
-        <p:spPr>
-          <a:xfrm>
-            <a:off x="6126480" y="4206240"/>
-            <a:ext cx="640080" cy="640080"/>
-          </a:xfrm>
-          <a:prstGeom prst="ellipse">
-            <a:avLst/>
-          </a:prstGeom>
-          <a:solidFill>
-            <a:srgbClr val="00A896"/>
-          </a:solidFill>
-          <a:ln/>
-        </p:spPr>
+        <p:txBody>
+          <a:bodyPr/>
+          <a:lstStyle/>
+          <a:p>
+            <a:endParaRPr/>
+          </a:p>
+        </p:txBody>
       </p:sp>
       <p:sp>
         <p:nvSpPr>
@@ -6695,6 +6481,13 @@
             <a:prstDash val="solid"/>
           </a:ln>
         </p:spPr>
+        <p:txBody>
+          <a:bodyPr/>
+          <a:lstStyle/>
+          <a:p>
+            <a:endParaRPr/>
+          </a:p>
+        </p:txBody>
       </p:sp>
       <p:sp>
         <p:nvSpPr>
@@ -6715,6 +6508,13 @@
           </a:solidFill>
           <a:ln/>
         </p:spPr>
+        <p:txBody>
+          <a:bodyPr/>
+          <a:lstStyle/>
+          <a:p>
+            <a:endParaRPr/>
+          </a:p>
+        </p:txBody>
       </p:sp>
       <p:sp>
         <p:nvSpPr>
@@ -6815,6 +6615,13 @@
           </a:solidFill>
           <a:ln/>
         </p:spPr>
+        <p:txBody>
+          <a:bodyPr/>
+          <a:lstStyle/>
+          <a:p>
+            <a:endParaRPr/>
+          </a:p>
+        </p:txBody>
       </p:sp>
       <p:sp>
         <p:nvSpPr>
@@ -6913,6 +6720,13 @@
           </a:solidFill>
           <a:ln/>
         </p:spPr>
+        <p:txBody>
+          <a:bodyPr/>
+          <a:lstStyle/>
+          <a:p>
+            <a:endParaRPr/>
+          </a:p>
+        </p:txBody>
       </p:sp>
       <p:sp>
         <p:nvSpPr>
@@ -7013,6 +6827,13 @@
           </a:solidFill>
           <a:ln/>
         </p:spPr>
+        <p:txBody>
+          <a:bodyPr/>
+          <a:lstStyle/>
+          <a:p>
+            <a:endParaRPr/>
+          </a:p>
+        </p:txBody>
       </p:sp>
       <p:sp>
         <p:nvSpPr>
@@ -7111,6 +6932,13 @@
           </a:solidFill>
           <a:ln/>
         </p:spPr>
+        <p:txBody>
+          <a:bodyPr/>
+          <a:lstStyle/>
+          <a:p>
+            <a:endParaRPr/>
+          </a:p>
+        </p:txBody>
       </p:sp>
       <p:sp>
         <p:nvSpPr>
@@ -7211,6 +7039,13 @@
           </a:solidFill>
           <a:ln/>
         </p:spPr>
+        <p:txBody>
+          <a:bodyPr/>
+          <a:lstStyle/>
+          <a:p>
+            <a:endParaRPr/>
+          </a:p>
+        </p:txBody>
       </p:sp>
       <p:sp>
         <p:nvSpPr>
@@ -7309,6 +7144,13 @@
           </a:solidFill>
           <a:ln/>
         </p:spPr>
+        <p:txBody>
+          <a:bodyPr/>
+          <a:lstStyle/>
+          <a:p>
+            <a:endParaRPr/>
+          </a:p>
+        </p:txBody>
       </p:sp>
       <p:sp>
         <p:nvSpPr>
@@ -7409,6 +7251,13 @@
           </a:solidFill>
           <a:ln/>
         </p:spPr>
+        <p:txBody>
+          <a:bodyPr/>
+          <a:lstStyle/>
+          <a:p>
+            <a:endParaRPr/>
+          </a:p>
+        </p:txBody>
       </p:sp>
       <p:sp>
         <p:nvSpPr>
@@ -7507,6 +7356,13 @@
           </a:solidFill>
           <a:ln/>
         </p:spPr>
+        <p:txBody>
+          <a:bodyPr/>
+          <a:lstStyle/>
+          <a:p>
+            <a:endParaRPr/>
+          </a:p>
+        </p:txBody>
       </p:sp>
       <p:sp>
         <p:nvSpPr>
@@ -7607,6 +7463,13 @@
           </a:solidFill>
           <a:ln/>
         </p:spPr>
+        <p:txBody>
+          <a:bodyPr/>
+          <a:lstStyle/>
+          <a:p>
+            <a:endParaRPr/>
+          </a:p>
+        </p:txBody>
       </p:sp>
       <p:sp>
         <p:nvSpPr>
@@ -7864,6 +7727,13 @@
             </a:outerShdw>
           </a:effectLst>
         </p:spPr>
+        <p:txBody>
+          <a:bodyPr/>
+          <a:lstStyle/>
+          <a:p>
+            <a:endParaRPr/>
+          </a:p>
+        </p:txBody>
       </p:sp>
       <p:sp>
         <p:nvSpPr>
@@ -7884,6 +7754,13 @@
           </a:solidFill>
           <a:ln/>
         </p:spPr>
+        <p:txBody>
+          <a:bodyPr/>
+          <a:lstStyle/>
+          <a:p>
+            <a:endParaRPr/>
+          </a:p>
+        </p:txBody>
       </p:sp>
       <p:sp>
         <p:nvSpPr>
@@ -8030,6 +7907,13 @@
             </a:outerShdw>
           </a:effectLst>
         </p:spPr>
+        <p:txBody>
+          <a:bodyPr/>
+          <a:lstStyle/>
+          <a:p>
+            <a:endParaRPr/>
+          </a:p>
+        </p:txBody>
       </p:sp>
       <p:sp>
         <p:nvSpPr>
@@ -8050,6 +7934,13 @@
           </a:solidFill>
           <a:ln/>
         </p:spPr>
+        <p:txBody>
+          <a:bodyPr/>
+          <a:lstStyle/>
+          <a:p>
+            <a:endParaRPr/>
+          </a:p>
+        </p:txBody>
       </p:sp>
       <p:sp>
         <p:nvSpPr>
@@ -8196,6 +8087,13 @@
             </a:outerShdw>
           </a:effectLst>
         </p:spPr>
+        <p:txBody>
+          <a:bodyPr/>
+          <a:lstStyle/>
+          <a:p>
+            <a:endParaRPr/>
+          </a:p>
+        </p:txBody>
       </p:sp>
       <p:sp>
         <p:nvSpPr>
@@ -8216,6 +8114,13 @@
           </a:solidFill>
           <a:ln/>
         </p:spPr>
+        <p:txBody>
+          <a:bodyPr/>
+          <a:lstStyle/>
+          <a:p>
+            <a:endParaRPr/>
+          </a:p>
+        </p:txBody>
       </p:sp>
       <p:sp>
         <p:nvSpPr>
@@ -8464,6 +8369,13 @@
           </a:solidFill>
           <a:ln/>
         </p:spPr>
+        <p:txBody>
+          <a:bodyPr/>
+          <a:lstStyle/>
+          <a:p>
+            <a:endParaRPr/>
+          </a:p>
+        </p:txBody>
       </p:sp>
       <p:sp>
         <p:nvSpPr>
@@ -8484,6 +8396,13 @@
           </a:solidFill>
           <a:ln/>
         </p:spPr>
+        <p:txBody>
+          <a:bodyPr/>
+          <a:lstStyle/>
+          <a:p>
+            <a:endParaRPr/>
+          </a:p>
+        </p:txBody>
       </p:sp>
       <p:sp>
         <p:nvSpPr>
@@ -8552,158 +8471,279 @@
               <a:buNone/>
             </a:pPr>
             <a:r>
-              <a:rPr lang="en-US" sz="1500" dirty="0">
-                <a:solidFill>
-                  <a:srgbClr val="CADCFC"/>
+              <a:t>Projeto tecnicamente maduro, financeiramente de altíssimo retorno e ambientalmente responsável.</a:t>
+            </a:r>
+            <a:br/>
+            <a:br/>
+            <a:r>
+              <a:t>Investimento de R$ 301.000,00 com retorno garantido em 22,1 meses.</a:t>
+            </a:r>
+            <a:br/>
+            <a:r>
+              <a:t>Redução permanente de R$ 163.264,82/ano no custo operacional de energia elétrica.</a:t>
+            </a:r>
+            <a:endParaRPr lang="en-US" sz="1500" dirty="0"/>
+          </a:p>
+        </p:txBody>
+      </p:sp>
+      <p:sp>
+        <p:nvSpPr>
+          <p:cNvPr id="6" name="Text 4"/>
+          <p:cNvSpPr txBox="1"/>
+          <p:nvPr/>
+        </p:nvSpPr>
+        <p:spPr>
+          <a:xfrm>
+            <a:off x="640080" y="3337560"/>
+            <a:ext cx="7315200" cy="365760"/>
+          </a:xfrm>
+          <a:prstGeom prst="rect">
+            <a:avLst/>
+          </a:prstGeom>
+          <a:noFill/>
+          <a:ln/>
+        </p:spPr>
+        <p:txBody>
+          <a:bodyPr wrap="square" lIns="0" tIns="0" rIns="0" bIns="0" rtlCol="0" anchor="ctr"/>
+          <a:lstStyle/>
+          <a:p>
+            <a:pPr marL="0" indent="0">
+              <a:buNone/>
+            </a:pPr>
+            <a:r>
+              <a:rPr lang="en-US" sz="1600" b="1" dirty="0">
+                <a:solidFill>
+                  <a:srgbClr val="00A896"/>
+                </a:solidFill>
+                <a:latin typeface="Cambria" pitchFamily="34" charset="0"/>
+                <a:ea typeface="Cambria" pitchFamily="34" charset="-122"/>
+                <a:cs typeface="Cambria" pitchFamily="34" charset="-120"/>
+              </a:rPr>
+              <a:t>Próximos Passos Recomendados</a:t>
+            </a:r>
+            <a:endParaRPr lang="en-US" sz="1600" dirty="0"/>
+          </a:p>
+        </p:txBody>
+      </p:sp>
+      <p:sp>
+        <p:nvSpPr>
+          <p:cNvPr id="7" name="Shape 5"/>
+          <p:cNvSpPr/>
+          <p:nvPr/>
+        </p:nvSpPr>
+        <p:spPr>
+          <a:xfrm>
+            <a:off x="640080" y="3840480"/>
+            <a:ext cx="411480" cy="411480"/>
+          </a:xfrm>
+          <a:prstGeom prst="ellipse">
+            <a:avLst/>
+          </a:prstGeom>
+          <a:solidFill>
+            <a:srgbClr val="00A896"/>
+          </a:solidFill>
+          <a:ln/>
+        </p:spPr>
+        <p:txBody>
+          <a:bodyPr/>
+          <a:lstStyle/>
+          <a:p>
+            <a:endParaRPr/>
+          </a:p>
+        </p:txBody>
+      </p:sp>
+      <p:sp>
+        <p:nvSpPr>
+          <p:cNvPr id="8" name="Text 6"/>
+          <p:cNvSpPr txBox="1"/>
+          <p:nvPr/>
+        </p:nvSpPr>
+        <p:spPr>
+          <a:xfrm>
+            <a:off x="640080" y="3840480"/>
+            <a:ext cx="411480" cy="411480"/>
+          </a:xfrm>
+          <a:prstGeom prst="rect">
+            <a:avLst/>
+          </a:prstGeom>
+          <a:noFill/>
+          <a:ln/>
+        </p:spPr>
+        <p:txBody>
+          <a:bodyPr wrap="square" lIns="0" tIns="0" rIns="0" bIns="0" rtlCol="0" anchor="ctr"/>
+          <a:lstStyle/>
+          <a:p>
+            <a:pPr marL="0" indent="0" algn="ctr">
+              <a:buNone/>
+            </a:pPr>
+            <a:r>
+              <a:rPr lang="en-US" sz="1200" b="1" dirty="0">
+                <a:solidFill>
+                  <a:srgbClr val="FFFFFF"/>
                 </a:solidFill>
                 <a:latin typeface="Calibri" pitchFamily="34" charset="0"/>
                 <a:ea typeface="Calibri" pitchFamily="34" charset="-122"/>
                 <a:cs typeface="Calibri" pitchFamily="34" charset="-120"/>
               </a:rPr>
-              <a:t>Projeto tecnicamente maduro, financeiramente de altíssimo retorno e ambientalmente responsável.
-</a:t>
-            </a:r>
-            <a:r>
-              <a:rPr lang="en-US" sz="1500" b="1" dirty="0">
-                <a:solidFill>
-                  <a:srgbClr val="00A896"/>
+              <a:t>1</a:t>
+            </a:r>
+            <a:endParaRPr lang="en-US" sz="1200" dirty="0"/>
+          </a:p>
+        </p:txBody>
+      </p:sp>
+      <p:sp>
+        <p:nvSpPr>
+          <p:cNvPr id="9" name="Text 7"/>
+          <p:cNvSpPr txBox="1"/>
+          <p:nvPr/>
+        </p:nvSpPr>
+        <p:spPr>
+          <a:xfrm>
+            <a:off x="1234440" y="3858768"/>
+            <a:ext cx="9875520" cy="384048"/>
+          </a:xfrm>
+          <a:prstGeom prst="rect">
+            <a:avLst/>
+          </a:prstGeom>
+          <a:noFill/>
+          <a:ln/>
+        </p:spPr>
+        <p:txBody>
+          <a:bodyPr wrap="square" lIns="0" tIns="0" rIns="0" bIns="0" rtlCol="0" anchor="ctr"/>
+          <a:lstStyle/>
+          <a:p>
+            <a:pPr marL="0" indent="0">
+              <a:buNone/>
+            </a:pPr>
+            <a:r>
+              <a:rPr lang="en-US" sz="1350" dirty="0">
+                <a:solidFill>
+                  <a:srgbClr val="FFFFFF"/>
                 </a:solidFill>
                 <a:latin typeface="Calibri" pitchFamily="34" charset="0"/>
                 <a:ea typeface="Calibri" pitchFamily="34" charset="-122"/>
                 <a:cs typeface="Calibri" pitchFamily="34" charset="-120"/>
               </a:rPr>
-              <a:t>Investimento de R$ 301.000,00 </a:t>
-            </a:r>
-            <a:r>
-              <a:rPr lang="en-US" sz="1500" dirty="0">
-                <a:solidFill>
-                  <a:srgbClr val="CADCFC"/>
+              <a:t>Aprovação da proposta executiva pela Diretoria e Conselho Gestor.</a:t>
+            </a:r>
+            <a:endParaRPr lang="en-US" sz="1350" dirty="0"/>
+          </a:p>
+        </p:txBody>
+      </p:sp>
+      <p:sp>
+        <p:nvSpPr>
+          <p:cNvPr id="10" name="Shape 8"/>
+          <p:cNvSpPr/>
+          <p:nvPr/>
+        </p:nvSpPr>
+        <p:spPr>
+          <a:xfrm>
+            <a:off x="640080" y="4434840"/>
+            <a:ext cx="411480" cy="411480"/>
+          </a:xfrm>
+          <a:prstGeom prst="ellipse">
+            <a:avLst/>
+          </a:prstGeom>
+          <a:solidFill>
+            <a:srgbClr val="00A896"/>
+          </a:solidFill>
+          <a:ln/>
+        </p:spPr>
+        <p:txBody>
+          <a:bodyPr/>
+          <a:lstStyle/>
+          <a:p>
+            <a:endParaRPr/>
+          </a:p>
+        </p:txBody>
+      </p:sp>
+      <p:sp>
+        <p:nvSpPr>
+          <p:cNvPr id="11" name="Text 9"/>
+          <p:cNvSpPr txBox="1"/>
+          <p:nvPr/>
+        </p:nvSpPr>
+        <p:spPr>
+          <a:xfrm>
+            <a:off x="640080" y="4434840"/>
+            <a:ext cx="411480" cy="411480"/>
+          </a:xfrm>
+          <a:prstGeom prst="rect">
+            <a:avLst/>
+          </a:prstGeom>
+          <a:noFill/>
+          <a:ln/>
+        </p:spPr>
+        <p:txBody>
+          <a:bodyPr wrap="square" lIns="0" tIns="0" rIns="0" bIns="0" rtlCol="0" anchor="ctr"/>
+          <a:lstStyle/>
+          <a:p>
+            <a:pPr marL="0" indent="0" algn="ctr">
+              <a:buNone/>
+            </a:pPr>
+            <a:r>
+              <a:rPr lang="en-US" sz="1200" b="1" dirty="0">
+                <a:solidFill>
+                  <a:srgbClr val="FFFFFF"/>
                 </a:solidFill>
                 <a:latin typeface="Calibri" pitchFamily="34" charset="0"/>
                 <a:ea typeface="Calibri" pitchFamily="34" charset="-122"/>
                 <a:cs typeface="Calibri" pitchFamily="34" charset="-120"/>
               </a:rPr>
-              <a:t>com retorno garantido </a:t>
-            </a:r>
-            <a:r>
-              <a:rPr lang="en-US" sz="1500">
-                <a:solidFill>
-                  <a:srgbClr val="CADCFC"/>
+              <a:t>2</a:t>
+            </a:r>
+            <a:endParaRPr lang="en-US" sz="1200" dirty="0"/>
+          </a:p>
+        </p:txBody>
+      </p:sp>
+      <p:sp>
+        <p:nvSpPr>
+          <p:cNvPr id="12" name="Text 10"/>
+          <p:cNvSpPr txBox="1"/>
+          <p:nvPr/>
+        </p:nvSpPr>
+        <p:spPr>
+          <a:xfrm>
+            <a:off x="1234440" y="4453128"/>
+            <a:ext cx="9875520" cy="384048"/>
+          </a:xfrm>
+          <a:prstGeom prst="rect">
+            <a:avLst/>
+          </a:prstGeom>
+          <a:noFill/>
+          <a:ln/>
+        </p:spPr>
+        <p:txBody>
+          <a:bodyPr wrap="square" lIns="0" tIns="0" rIns="0" bIns="0" rtlCol="0" anchor="ctr"/>
+          <a:lstStyle/>
+          <a:p>
+            <a:pPr marL="0" indent="0">
+              <a:buNone/>
+            </a:pPr>
+            <a:r>
+              <a:rPr lang="en-US" sz="1350" dirty="0">
+                <a:solidFill>
+                  <a:srgbClr val="FFFFFF"/>
                 </a:solidFill>
                 <a:latin typeface="Calibri" pitchFamily="34" charset="0"/>
                 <a:ea typeface="Calibri" pitchFamily="34" charset="-122"/>
                 <a:cs typeface="Calibri" pitchFamily="34" charset="-120"/>
               </a:rPr>
-              <a:t>em </a:t>
-            </a:r>
-            <a:r>
-              <a:rPr lang="en-US" sz="1500" b="1">
-                <a:solidFill>
-                  <a:srgbClr val="00A896"/>
-                </a:solidFill>
-                <a:latin typeface="Calibri" pitchFamily="34" charset="0"/>
-                <a:ea typeface="Calibri" pitchFamily="34" charset="-122"/>
-                <a:cs typeface="Calibri" pitchFamily="34" charset="-120"/>
-              </a:rPr>
-              <a:t>16,5 meses.</a:t>
-            </a:r>
-            <a:r>
-              <a:rPr lang="en-US" sz="1500" b="1" dirty="0">
-                <a:solidFill>
-                  <a:srgbClr val="00A896"/>
-                </a:solidFill>
-                <a:latin typeface="Calibri" pitchFamily="34" charset="0"/>
-                <a:ea typeface="Calibri" pitchFamily="34" charset="-122"/>
-                <a:cs typeface="Calibri" pitchFamily="34" charset="-120"/>
-              </a:rPr>
-              <a:t>
-Redução permanente </a:t>
-            </a:r>
-            <a:r>
-              <a:rPr lang="en-US" sz="1500" b="1">
-                <a:solidFill>
-                  <a:srgbClr val="00A896"/>
-                </a:solidFill>
-                <a:latin typeface="Calibri" pitchFamily="34" charset="0"/>
-                <a:ea typeface="Calibri" pitchFamily="34" charset="-122"/>
-                <a:cs typeface="Calibri" pitchFamily="34" charset="-120"/>
-              </a:rPr>
-              <a:t>de R$ 217.686,42/</a:t>
-            </a:r>
-            <a:r>
-              <a:rPr lang="en-US" sz="1500" b="1" dirty="0">
-                <a:solidFill>
-                  <a:srgbClr val="00A896"/>
-                </a:solidFill>
-                <a:latin typeface="Calibri" pitchFamily="34" charset="0"/>
-                <a:ea typeface="Calibri" pitchFamily="34" charset="-122"/>
-                <a:cs typeface="Calibri" pitchFamily="34" charset="-120"/>
-              </a:rPr>
-              <a:t>ano </a:t>
-            </a:r>
-            <a:r>
-              <a:rPr lang="en-US" sz="1500" dirty="0">
-                <a:solidFill>
-                  <a:srgbClr val="CADCFC"/>
-                </a:solidFill>
-                <a:latin typeface="Calibri" pitchFamily="34" charset="0"/>
-                <a:ea typeface="Calibri" pitchFamily="34" charset="-122"/>
-                <a:cs typeface="Calibri" pitchFamily="34" charset="-120"/>
-              </a:rPr>
-              <a:t>no custo operacional de energia elétrica.</a:t>
-            </a:r>
-            <a:endParaRPr lang="en-US" sz="1500" dirty="0"/>
-          </a:p>
-        </p:txBody>
-      </p:sp>
-      <p:sp>
-        <p:nvSpPr>
-          <p:cNvPr id="6" name="Text 4"/>
-          <p:cNvSpPr txBox="1"/>
-          <p:nvPr/>
-        </p:nvSpPr>
-        <p:spPr>
-          <a:xfrm>
-            <a:off x="640080" y="3337560"/>
-            <a:ext cx="7315200" cy="365760"/>
-          </a:xfrm>
-          <a:prstGeom prst="rect">
-            <a:avLst/>
-          </a:prstGeom>
-          <a:noFill/>
-          <a:ln/>
-        </p:spPr>
-        <p:txBody>
-          <a:bodyPr wrap="square" lIns="0" tIns="0" rIns="0" bIns="0" rtlCol="0" anchor="ctr"/>
-          <a:lstStyle/>
-          <a:p>
-            <a:pPr marL="0" indent="0">
-              <a:buNone/>
-            </a:pPr>
-            <a:r>
-              <a:rPr lang="en-US" sz="1600" b="1" dirty="0">
-                <a:solidFill>
-                  <a:srgbClr val="00A896"/>
-                </a:solidFill>
-                <a:latin typeface="Cambria" pitchFamily="34" charset="0"/>
-                <a:ea typeface="Cambria" pitchFamily="34" charset="-122"/>
-                <a:cs typeface="Cambria" pitchFamily="34" charset="-120"/>
-              </a:rPr>
-              <a:t>Próximos Passos Recomendados</a:t>
-            </a:r>
-            <a:endParaRPr lang="en-US" sz="1600" dirty="0"/>
-          </a:p>
-        </p:txBody>
-      </p:sp>
-      <p:sp>
-        <p:nvSpPr>
-          <p:cNvPr id="7" name="Shape 5"/>
+              <a:t>Assinatura do contrato de fornecimento e serviços.</a:t>
+            </a:r>
+            <a:endParaRPr lang="en-US" sz="1350" dirty="0"/>
+          </a:p>
+        </p:txBody>
+      </p:sp>
+      <p:sp>
+        <p:nvSpPr>
+          <p:cNvPr id="13" name="Shape 11"/>
           <p:cNvSpPr/>
           <p:nvPr/>
         </p:nvSpPr>
         <p:spPr>
           <a:xfrm>
-            <a:off x="640080" y="3840480"/>
+            <a:off x="640080" y="5029200"/>
             <a:ext cx="411480" cy="411480"/>
           </a:xfrm>
           <a:prstGeom prst="ellipse">
@@ -8714,202 +8754,13 @@
           </a:solidFill>
           <a:ln/>
         </p:spPr>
-      </p:sp>
-      <p:sp>
-        <p:nvSpPr>
-          <p:cNvPr id="8" name="Text 6"/>
-          <p:cNvSpPr txBox="1"/>
-          <p:nvPr/>
-        </p:nvSpPr>
-        <p:spPr>
-          <a:xfrm>
-            <a:off x="640080" y="3840480"/>
-            <a:ext cx="411480" cy="411480"/>
-          </a:xfrm>
-          <a:prstGeom prst="rect">
-            <a:avLst/>
-          </a:prstGeom>
-          <a:noFill/>
-          <a:ln/>
-        </p:spPr>
-        <p:txBody>
-          <a:bodyPr wrap="square" lIns="0" tIns="0" rIns="0" bIns="0" rtlCol="0" anchor="ctr"/>
-          <a:lstStyle/>
-          <a:p>
-            <a:pPr marL="0" indent="0" algn="ctr">
-              <a:buNone/>
-            </a:pPr>
-            <a:r>
-              <a:rPr lang="en-US" sz="1200" b="1" dirty="0">
-                <a:solidFill>
-                  <a:srgbClr val="FFFFFF"/>
-                </a:solidFill>
-                <a:latin typeface="Calibri" pitchFamily="34" charset="0"/>
-                <a:ea typeface="Calibri" pitchFamily="34" charset="-122"/>
-                <a:cs typeface="Calibri" pitchFamily="34" charset="-120"/>
-              </a:rPr>
-              <a:t>1</a:t>
-            </a:r>
-            <a:endParaRPr lang="en-US" sz="1200" dirty="0"/>
-          </a:p>
-        </p:txBody>
-      </p:sp>
-      <p:sp>
-        <p:nvSpPr>
-          <p:cNvPr id="9" name="Text 7"/>
-          <p:cNvSpPr txBox="1"/>
-          <p:nvPr/>
-        </p:nvSpPr>
-        <p:spPr>
-          <a:xfrm>
-            <a:off x="1234440" y="3858768"/>
-            <a:ext cx="9875520" cy="384048"/>
-          </a:xfrm>
-          <a:prstGeom prst="rect">
-            <a:avLst/>
-          </a:prstGeom>
-          <a:noFill/>
-          <a:ln/>
-        </p:spPr>
-        <p:txBody>
-          <a:bodyPr wrap="square" lIns="0" tIns="0" rIns="0" bIns="0" rtlCol="0" anchor="ctr"/>
-          <a:lstStyle/>
-          <a:p>
-            <a:pPr marL="0" indent="0">
-              <a:buNone/>
-            </a:pPr>
-            <a:r>
-              <a:rPr lang="en-US" sz="1350" dirty="0">
-                <a:solidFill>
-                  <a:srgbClr val="FFFFFF"/>
-                </a:solidFill>
-                <a:latin typeface="Calibri" pitchFamily="34" charset="0"/>
-                <a:ea typeface="Calibri" pitchFamily="34" charset="-122"/>
-                <a:cs typeface="Calibri" pitchFamily="34" charset="-120"/>
-              </a:rPr>
-              <a:t>Aprovação da proposta executiva pela Diretoria e Conselho Gestor.</a:t>
-            </a:r>
-            <a:endParaRPr lang="en-US" sz="1350" dirty="0"/>
-          </a:p>
-        </p:txBody>
-      </p:sp>
-      <p:sp>
-        <p:nvSpPr>
-          <p:cNvPr id="10" name="Shape 8"/>
-          <p:cNvSpPr/>
-          <p:nvPr/>
-        </p:nvSpPr>
-        <p:spPr>
-          <a:xfrm>
-            <a:off x="640080" y="4434840"/>
-            <a:ext cx="411480" cy="411480"/>
-          </a:xfrm>
-          <a:prstGeom prst="ellipse">
-            <a:avLst/>
-          </a:prstGeom>
-          <a:solidFill>
-            <a:srgbClr val="00A896"/>
-          </a:solidFill>
-          <a:ln/>
-        </p:spPr>
-      </p:sp>
-      <p:sp>
-        <p:nvSpPr>
-          <p:cNvPr id="11" name="Text 9"/>
-          <p:cNvSpPr txBox="1"/>
-          <p:nvPr/>
-        </p:nvSpPr>
-        <p:spPr>
-          <a:xfrm>
-            <a:off x="640080" y="4434840"/>
-            <a:ext cx="411480" cy="411480"/>
-          </a:xfrm>
-          <a:prstGeom prst="rect">
-            <a:avLst/>
-          </a:prstGeom>
-          <a:noFill/>
-          <a:ln/>
-        </p:spPr>
-        <p:txBody>
-          <a:bodyPr wrap="square" lIns="0" tIns="0" rIns="0" bIns="0" rtlCol="0" anchor="ctr"/>
-          <a:lstStyle/>
-          <a:p>
-            <a:pPr marL="0" indent="0" algn="ctr">
-              <a:buNone/>
-            </a:pPr>
-            <a:r>
-              <a:rPr lang="en-US" sz="1200" b="1" dirty="0">
-                <a:solidFill>
-                  <a:srgbClr val="FFFFFF"/>
-                </a:solidFill>
-                <a:latin typeface="Calibri" pitchFamily="34" charset="0"/>
-                <a:ea typeface="Calibri" pitchFamily="34" charset="-122"/>
-                <a:cs typeface="Calibri" pitchFamily="34" charset="-120"/>
-              </a:rPr>
-              <a:t>2</a:t>
-            </a:r>
-            <a:endParaRPr lang="en-US" sz="1200" dirty="0"/>
-          </a:p>
-        </p:txBody>
-      </p:sp>
-      <p:sp>
-        <p:nvSpPr>
-          <p:cNvPr id="12" name="Text 10"/>
-          <p:cNvSpPr txBox="1"/>
-          <p:nvPr/>
-        </p:nvSpPr>
-        <p:spPr>
-          <a:xfrm>
-            <a:off x="1234440" y="4453128"/>
-            <a:ext cx="9875520" cy="384048"/>
-          </a:xfrm>
-          <a:prstGeom prst="rect">
-            <a:avLst/>
-          </a:prstGeom>
-          <a:noFill/>
-          <a:ln/>
-        </p:spPr>
-        <p:txBody>
-          <a:bodyPr wrap="square" lIns="0" tIns="0" rIns="0" bIns="0" rtlCol="0" anchor="ctr"/>
-          <a:lstStyle/>
-          <a:p>
-            <a:pPr marL="0" indent="0">
-              <a:buNone/>
-            </a:pPr>
-            <a:r>
-              <a:rPr lang="en-US" sz="1350" dirty="0">
-                <a:solidFill>
-                  <a:srgbClr val="FFFFFF"/>
-                </a:solidFill>
-                <a:latin typeface="Calibri" pitchFamily="34" charset="0"/>
-                <a:ea typeface="Calibri" pitchFamily="34" charset="-122"/>
-                <a:cs typeface="Calibri" pitchFamily="34" charset="-120"/>
-              </a:rPr>
-              <a:t>Assinatura do contrato de fornecimento e serviços.</a:t>
-            </a:r>
-            <a:endParaRPr lang="en-US" sz="1350" dirty="0"/>
-          </a:p>
-        </p:txBody>
-      </p:sp>
-      <p:sp>
-        <p:nvSpPr>
-          <p:cNvPr id="13" name="Shape 11"/>
-          <p:cNvSpPr/>
-          <p:nvPr/>
-        </p:nvSpPr>
-        <p:spPr>
-          <a:xfrm>
-            <a:off x="640080" y="5029200"/>
-            <a:ext cx="411480" cy="411480"/>
-          </a:xfrm>
-          <a:prstGeom prst="ellipse">
-            <a:avLst/>
-          </a:prstGeom>
-          <a:solidFill>
-            <a:srgbClr val="00A896"/>
-          </a:solidFill>
-          <a:ln/>
-        </p:spPr>
+        <p:txBody>
+          <a:bodyPr/>
+          <a:lstStyle/>
+          <a:p>
+            <a:endParaRPr/>
+          </a:p>
+        </p:txBody>
       </p:sp>
       <p:sp>
         <p:nvSpPr>
@@ -9011,6 +8862,13 @@
             <a:prstDash val="solid"/>
           </a:ln>
         </p:spPr>
+        <p:txBody>
+          <a:bodyPr/>
+          <a:lstStyle/>
+          <a:p>
+            <a:endParaRPr/>
+          </a:p>
+        </p:txBody>
       </p:sp>
       <p:sp>
         <p:nvSpPr>
@@ -9213,6 +9071,13 @@
             </a:outerShdw>
           </a:effectLst>
         </p:spPr>
+        <p:txBody>
+          <a:bodyPr/>
+          <a:lstStyle/>
+          <a:p>
+            <a:endParaRPr/>
+          </a:p>
+        </p:txBody>
       </p:sp>
       <p:sp>
         <p:nvSpPr>
@@ -9320,6 +9185,13 @@
             </a:outerShdw>
           </a:effectLst>
         </p:spPr>
+        <p:txBody>
+          <a:bodyPr/>
+          <a:lstStyle/>
+          <a:p>
+            <a:endParaRPr/>
+          </a:p>
+        </p:txBody>
       </p:sp>
       <p:sp>
         <p:nvSpPr>
@@ -9346,26 +9218,7 @@
               <a:buNone/>
             </a:pPr>
             <a:r>
-              <a:rPr lang="en-US" sz="2200" b="1">
-                <a:solidFill>
-                  <a:srgbClr val="028090"/>
-                </a:solidFill>
-                <a:latin typeface="Cambria" pitchFamily="34" charset="0"/>
-                <a:ea typeface="Cambria" pitchFamily="34" charset="-122"/>
-                <a:cs typeface="Cambria" pitchFamily="34" charset="-120"/>
-              </a:rPr>
-              <a:t>R$ 217.686 </a:t>
-            </a:r>
-            <a:r>
-              <a:rPr lang="en-US" sz="2200" b="1" dirty="0">
-                <a:solidFill>
-                  <a:srgbClr val="028090"/>
-                </a:solidFill>
-                <a:latin typeface="Cambria" pitchFamily="34" charset="0"/>
-                <a:ea typeface="Cambria" pitchFamily="34" charset="-122"/>
-                <a:cs typeface="Cambria" pitchFamily="34" charset="-120"/>
-              </a:rPr>
-              <a:t>/ano</a:t>
+              <a:t>R$ 163.264 /ano</a:t>
             </a:r>
             <a:endParaRPr lang="en-US" sz="2200" dirty="0"/>
           </a:p>
@@ -9438,6 +9291,13 @@
             </a:outerShdw>
           </a:effectLst>
         </p:spPr>
+        <p:txBody>
+          <a:bodyPr/>
+          <a:lstStyle/>
+          <a:p>
+            <a:endParaRPr/>
+          </a:p>
+        </p:txBody>
       </p:sp>
       <p:sp>
         <p:nvSpPr>
@@ -9545,6 +9405,13 @@
             </a:outerShdw>
           </a:effectLst>
         </p:spPr>
+        <p:txBody>
+          <a:bodyPr/>
+          <a:lstStyle/>
+          <a:p>
+            <a:endParaRPr/>
+          </a:p>
+        </p:txBody>
       </p:sp>
       <p:sp>
         <p:nvSpPr>
@@ -9571,15 +9438,7 @@
               <a:buNone/>
             </a:pPr>
             <a:r>
-              <a:rPr lang="en-US" sz="2200" b="1">
-                <a:solidFill>
-                  <a:srgbClr val="028090"/>
-                </a:solidFill>
-                <a:latin typeface="Cambria" pitchFamily="34" charset="0"/>
-                <a:ea typeface="Cambria" pitchFamily="34" charset="-122"/>
-                <a:cs typeface="Cambria" pitchFamily="34" charset="-120"/>
-              </a:rPr>
-              <a:t>16,5 meses</a:t>
+              <a:t>22,1 meses</a:t>
             </a:r>
             <a:endParaRPr lang="en-US" sz="2200" dirty="0"/>
           </a:p>
@@ -9652,6 +9511,13 @@
             </a:outerShdw>
           </a:effectLst>
         </p:spPr>
+        <p:txBody>
+          <a:bodyPr/>
+          <a:lstStyle/>
+          <a:p>
+            <a:endParaRPr/>
+          </a:p>
+        </p:txBody>
       </p:sp>
       <p:sp>
         <p:nvSpPr>
@@ -9759,6 +9625,13 @@
             </a:outerShdw>
           </a:effectLst>
         </p:spPr>
+        <p:txBody>
+          <a:bodyPr/>
+          <a:lstStyle/>
+          <a:p>
+            <a:endParaRPr/>
+          </a:p>
+        </p:txBody>
       </p:sp>
       <p:sp>
         <p:nvSpPr>
@@ -9785,15 +9658,7 @@
               <a:buNone/>
             </a:pPr>
             <a:r>
-              <a:rPr lang="en-US" sz="2200" b="1">
-                <a:solidFill>
-                  <a:srgbClr val="1E2761"/>
-                </a:solidFill>
-                <a:latin typeface="Cambria" pitchFamily="34" charset="0"/>
-                <a:ea typeface="Cambria" pitchFamily="34" charset="-122"/>
-                <a:cs typeface="Cambria" pitchFamily="34" charset="-120"/>
-              </a:rPr>
-              <a:t>R$ 484.710</a:t>
+              <a:t>R$ 288.533</a:t>
             </a:r>
             <a:endParaRPr lang="en-US" sz="2200" dirty="0"/>
           </a:p>
@@ -9866,6 +9731,13 @@
             </a:outerShdw>
           </a:effectLst>
         </p:spPr>
+        <p:txBody>
+          <a:bodyPr/>
+          <a:lstStyle/>
+          <a:p>
+            <a:endParaRPr/>
+          </a:p>
+        </p:txBody>
       </p:sp>
       <p:sp>
         <p:nvSpPr>
@@ -9892,15 +9764,7 @@
               <a:buNone/>
             </a:pPr>
             <a:r>
-              <a:rPr lang="en-US" sz="2200" b="1">
-                <a:solidFill>
-                  <a:srgbClr val="1E2761"/>
-                </a:solidFill>
-                <a:latin typeface="Cambria" pitchFamily="34" charset="0"/>
-                <a:ea typeface="Cambria" pitchFamily="34" charset="-122"/>
-                <a:cs typeface="Cambria" pitchFamily="34" charset="-120"/>
-              </a:rPr>
-              <a:t>290.249 kWh/ano</a:t>
+              <a:t>217.686 kWh/ano</a:t>
             </a:r>
             <a:endParaRPr lang="en-US" sz="2200" dirty="0"/>
           </a:p>
@@ -9973,6 +9837,13 @@
             </a:outerShdw>
           </a:effectLst>
         </p:spPr>
+        <p:txBody>
+          <a:bodyPr/>
+          <a:lstStyle/>
+          <a:p>
+            <a:endParaRPr/>
+          </a:p>
+        </p:txBody>
       </p:sp>
       <p:sp>
         <p:nvSpPr>
@@ -9999,15 +9870,7 @@
               <a:buNone/>
             </a:pPr>
             <a:r>
-              <a:rPr lang="en-US" sz="2200" b="1">
-                <a:solidFill>
-                  <a:srgbClr val="028090"/>
-                </a:solidFill>
-                <a:latin typeface="Cambria" pitchFamily="34" charset="0"/>
-                <a:ea typeface="Cambria" pitchFamily="34" charset="-122"/>
-                <a:cs typeface="Cambria" pitchFamily="34" charset="-120"/>
-              </a:rPr>
-              <a:t>25,0 tCO2/ano</a:t>
+              <a:t>18,7 tCO2/ano</a:t>
             </a:r>
             <a:endParaRPr lang="en-US" sz="2200" dirty="0"/>
           </a:p>
@@ -10260,6 +10123,13 @@
           </a:solidFill>
           <a:ln/>
         </p:spPr>
+        <p:txBody>
+          <a:bodyPr/>
+          <a:lstStyle/>
+          <a:p>
+            <a:endParaRPr/>
+          </a:p>
+        </p:txBody>
       </p:sp>
       <p:sp>
         <p:nvSpPr>
@@ -10397,6 +10267,13 @@
           </a:solidFill>
           <a:ln/>
         </p:spPr>
+        <p:txBody>
+          <a:bodyPr/>
+          <a:lstStyle/>
+          <a:p>
+            <a:endParaRPr/>
+          </a:p>
+        </p:txBody>
       </p:sp>
       <p:sp>
         <p:nvSpPr>
@@ -10534,6 +10411,13 @@
           </a:solidFill>
           <a:ln/>
         </p:spPr>
+        <p:txBody>
+          <a:bodyPr/>
+          <a:lstStyle/>
+          <a:p>
+            <a:endParaRPr/>
+          </a:p>
+        </p:txBody>
       </p:sp>
       <p:sp>
         <p:nvSpPr>
@@ -10671,6 +10555,13 @@
           </a:solidFill>
           <a:ln/>
         </p:spPr>
+        <p:txBody>
+          <a:bodyPr/>
+          <a:lstStyle/>
+          <a:p>
+            <a:endParaRPr/>
+          </a:p>
+        </p:txBody>
       </p:sp>
       <p:sp>
         <p:nvSpPr>
@@ -10810,6 +10701,13 @@
           </a:solidFill>
           <a:ln/>
         </p:spPr>
+        <p:txBody>
+          <a:bodyPr/>
+          <a:lstStyle/>
+          <a:p>
+            <a:endParaRPr/>
+          </a:p>
+        </p:txBody>
       </p:sp>
       <p:sp>
         <p:nvSpPr>
@@ -10950,6 +10848,13 @@
             <a:prstDash val="solid"/>
           </a:ln>
         </p:spPr>
+        <p:txBody>
+          <a:bodyPr/>
+          <a:lstStyle/>
+          <a:p>
+            <a:endParaRPr/>
+          </a:p>
+        </p:txBody>
       </p:sp>
       <p:sp>
         <p:nvSpPr>
@@ -11051,6 +10956,13 @@
             <a:prstDash val="solid"/>
           </a:ln>
         </p:spPr>
+        <p:txBody>
+          <a:bodyPr/>
+          <a:lstStyle/>
+          <a:p>
+            <a:endParaRPr/>
+          </a:p>
+        </p:txBody>
       </p:sp>
       <p:sp>
         <p:nvSpPr>
@@ -11152,6 +11064,13 @@
             <a:prstDash val="solid"/>
           </a:ln>
         </p:spPr>
+        <p:txBody>
+          <a:bodyPr/>
+          <a:lstStyle/>
+          <a:p>
+            <a:endParaRPr/>
+          </a:p>
+        </p:txBody>
       </p:sp>
       <p:sp>
         <p:nvSpPr>
@@ -11409,6 +11328,13 @@
             </a:outerShdw>
           </a:effectLst>
         </p:spPr>
+        <p:txBody>
+          <a:bodyPr/>
+          <a:lstStyle/>
+          <a:p>
+            <a:endParaRPr/>
+          </a:p>
+        </p:txBody>
       </p:sp>
       <p:sp>
         <p:nvSpPr>
@@ -11555,6 +11481,13 @@
             </a:outerShdw>
           </a:effectLst>
         </p:spPr>
+        <p:txBody>
+          <a:bodyPr/>
+          <a:lstStyle/>
+          <a:p>
+            <a:endParaRPr/>
+          </a:p>
+        </p:txBody>
       </p:sp>
       <p:sp>
         <p:nvSpPr>
@@ -11701,6 +11634,13 @@
             </a:outerShdw>
           </a:effectLst>
         </p:spPr>
+        <p:txBody>
+          <a:bodyPr/>
+          <a:lstStyle/>
+          <a:p>
+            <a:endParaRPr/>
+          </a:p>
+        </p:txBody>
       </p:sp>
       <p:sp>
         <p:nvSpPr>
@@ -11847,6 +11787,13 @@
             </a:outerShdw>
           </a:effectLst>
         </p:spPr>
+        <p:txBody>
+          <a:bodyPr/>
+          <a:lstStyle/>
+          <a:p>
+            <a:endParaRPr/>
+          </a:p>
+        </p:txBody>
       </p:sp>
       <p:sp>
         <p:nvSpPr>
@@ -12336,6 +12283,13 @@
           </a:solidFill>
           <a:ln/>
         </p:spPr>
+        <p:txBody>
+          <a:bodyPr/>
+          <a:lstStyle/>
+          <a:p>
+            <a:endParaRPr/>
+          </a:p>
+        </p:txBody>
       </p:sp>
       <p:sp>
         <p:nvSpPr>
@@ -12409,6 +12363,13 @@
           </a:solidFill>
           <a:ln/>
         </p:spPr>
+        <p:txBody>
+          <a:bodyPr/>
+          <a:lstStyle/>
+          <a:p>
+            <a:endParaRPr/>
+          </a:p>
+        </p:txBody>
       </p:sp>
       <p:sp>
         <p:nvSpPr>
@@ -12482,6 +12443,13 @@
           </a:solidFill>
           <a:ln/>
         </p:spPr>
+        <p:txBody>
+          <a:bodyPr/>
+          <a:lstStyle/>
+          <a:p>
+            <a:endParaRPr/>
+          </a:p>
+        </p:txBody>
       </p:sp>
       <p:sp>
         <p:nvSpPr>
@@ -12645,6 +12613,13 @@
             <a:prstDash val="solid"/>
           </a:ln>
         </p:spPr>
+        <p:txBody>
+          <a:bodyPr/>
+          <a:lstStyle/>
+          <a:p>
+            <a:endParaRPr/>
+          </a:p>
+        </p:txBody>
       </p:sp>
       <p:sp>
         <p:nvSpPr>
@@ -12906,7 +12881,7 @@
           <p:nvPr>
             <p:extLst>
               <p:ext uri="{D42A27DB-BD31-4B8C-83A1-F6EECF244321}">
-                <p14:modId xmlns:p14="http://schemas.microsoft.com/office/powerpoint/2010/main" val="4216483421"/>
+                <p14:modId xmlns:p14="http://schemas.microsoft.com/office/powerpoint/2010/main" val="754644817"/>
               </p:ext>
             </p:extLst>
           </p:nvPr>
@@ -13131,25 +13106,9 @@
                     <a:bodyPr/>
                     <a:lstStyle/>
                     <a:p>
-                      <a:pPr marL="0" indent="0" algn="ctr">
-                        <a:buNone/>
-                      </a:pPr>
                       <a:r>
-                        <a:rPr lang="en-US" sz="1050" dirty="0">
-                          <a:solidFill>
-                            <a:srgbClr val="1E2761"/>
-                          </a:solidFill>
-                          <a:latin typeface="Calibri" pitchFamily="34" charset="0"/>
-                          <a:ea typeface="Calibri" pitchFamily="34" charset="-122"/>
-                          <a:cs typeface="Calibri" pitchFamily="34" charset="-120"/>
-                        </a:rPr>
-                        <a:t>22,0</a:t>
+                        <a:t>23,0</a:t>
                       </a:r>
-                      <a:endParaRPr lang="en-US" sz="1050" dirty="0">
-                        <a:latin typeface="Calibri" charset="0"/>
-                        <a:ea typeface="Calibri" charset="0"/>
-                        <a:cs typeface="Calibri" charset="0"/>
-                      </a:endParaRPr>
                     </a:p>
                   </a:txBody>
                   <a:tcPr anchor="ctr">
@@ -13270,25 +13229,9 @@
                     <a:bodyPr/>
                     <a:lstStyle/>
                     <a:p>
-                      <a:pPr marL="0" indent="0" algn="ctr">
-                        <a:buNone/>
-                      </a:pPr>
                       <a:r>
-                        <a:rPr lang="en-US" sz="1050" dirty="0">
-                          <a:solidFill>
-                            <a:srgbClr val="1E2761"/>
-                          </a:solidFill>
-                          <a:latin typeface="Calibri" pitchFamily="34" charset="0"/>
-                          <a:ea typeface="Calibri" pitchFamily="34" charset="-122"/>
-                          <a:cs typeface="Calibri" pitchFamily="34" charset="-120"/>
-                        </a:rPr>
                         <a:t>1,0</a:t>
                       </a:r>
-                      <a:endParaRPr lang="en-US" sz="1050" dirty="0">
-                        <a:latin typeface="Calibri" charset="0"/>
-                        <a:ea typeface="Calibri" charset="0"/>
-                        <a:cs typeface="Calibri" charset="0"/>
-                      </a:endParaRPr>
                     </a:p>
                   </a:txBody>
                   <a:tcPr anchor="ctr">
@@ -13409,25 +13352,9 @@
                     <a:bodyPr/>
                     <a:lstStyle/>
                     <a:p>
-                      <a:pPr marL="0" indent="0" algn="ctr">
-                        <a:buNone/>
-                      </a:pPr>
                       <a:r>
-                        <a:rPr lang="en-US" sz="1050" dirty="0">
-                          <a:solidFill>
-                            <a:srgbClr val="1E2761"/>
-                          </a:solidFill>
-                          <a:latin typeface="Calibri" pitchFamily="34" charset="0"/>
-                          <a:ea typeface="Calibri" pitchFamily="34" charset="-122"/>
-                          <a:cs typeface="Calibri" pitchFamily="34" charset="-120"/>
-                        </a:rPr>
                         <a:t>12,0</a:t>
                       </a:r>
-                      <a:endParaRPr lang="en-US" sz="1050" dirty="0">
-                        <a:latin typeface="Calibri" charset="0"/>
-                        <a:ea typeface="Calibri" charset="0"/>
-                        <a:cs typeface="Calibri" charset="0"/>
-                      </a:endParaRPr>
                     </a:p>
                   </a:txBody>
                   <a:tcPr anchor="ctr">
@@ -13548,25 +13475,9 @@
                     <a:bodyPr/>
                     <a:lstStyle/>
                     <a:p>
-                      <a:pPr marL="0" indent="0" algn="ctr">
-                        <a:buNone/>
-                      </a:pPr>
                       <a:r>
-                        <a:rPr lang="en-US" sz="1050">
-                          <a:solidFill>
-                            <a:srgbClr val="1E2761"/>
-                          </a:solidFill>
-                          <a:latin typeface="Calibri" pitchFamily="34" charset="0"/>
-                          <a:ea typeface="Calibri" pitchFamily="34" charset="-122"/>
-                          <a:cs typeface="Calibri" pitchFamily="34" charset="-120"/>
-                        </a:rPr>
                         <a:t>R$ 0,75</a:t>
                       </a:r>
-                      <a:endParaRPr lang="en-US" sz="1050" dirty="0">
-                        <a:latin typeface="Calibri" charset="0"/>
-                        <a:ea typeface="Calibri" charset="0"/>
-                        <a:cs typeface="Calibri" charset="0"/>
-                      </a:endParaRPr>
                     </a:p>
                   </a:txBody>
                   <a:tcPr anchor="ctr">
@@ -13687,25 +13598,9 @@
                     <a:bodyPr/>
                     <a:lstStyle/>
                     <a:p>
-                      <a:pPr marL="0" indent="0" algn="ctr">
-                        <a:buNone/>
-                      </a:pPr>
                       <a:r>
-                        <a:rPr lang="en-US" sz="1050" dirty="0">
-                          <a:solidFill>
-                            <a:srgbClr val="1E2761"/>
-                          </a:solidFill>
-                          <a:latin typeface="Calibri" pitchFamily="34" charset="0"/>
-                          <a:ea typeface="Calibri" pitchFamily="34" charset="-122"/>
-                          <a:cs typeface="Calibri" pitchFamily="34" charset="-120"/>
-                        </a:rPr>
-                        <a:t>R$ 301.000,00</a:t>
+                        <a:t>R$ 300.000,00</a:t>
                       </a:r>
-                      <a:endParaRPr lang="en-US" sz="1050" dirty="0">
-                        <a:latin typeface="Calibri" charset="0"/>
-                        <a:ea typeface="Calibri" charset="0"/>
-                        <a:cs typeface="Calibri" charset="0"/>
-                      </a:endParaRPr>
                     </a:p>
                   </a:txBody>
                   <a:tcPr anchor="ctr">
@@ -13826,25 +13721,9 @@
                     <a:bodyPr/>
                     <a:lstStyle/>
                     <a:p>
-                      <a:pPr marL="0" indent="0" algn="ctr">
-                        <a:buNone/>
-                      </a:pPr>
                       <a:r>
-                        <a:rPr lang="en-US" sz="1050">
-                          <a:solidFill>
-                            <a:srgbClr val="1E2761"/>
-                          </a:solidFill>
-                          <a:latin typeface="Calibri" pitchFamily="34" charset="0"/>
-                          <a:ea typeface="Calibri" pitchFamily="34" charset="-122"/>
-                          <a:cs typeface="Calibri" pitchFamily="34" charset="-120"/>
-                        </a:rPr>
                         <a:t>0.70 (70%)</a:t>
                       </a:r>
-                      <a:endParaRPr lang="en-US" sz="1050" dirty="0">
-                        <a:latin typeface="Calibri" charset="0"/>
-                        <a:ea typeface="Calibri" charset="0"/>
-                        <a:cs typeface="Calibri" charset="0"/>
-                      </a:endParaRPr>
                     </a:p>
                   </a:txBody>
                   <a:tcPr anchor="ctr">
@@ -13965,25 +13844,9 @@
                     <a:bodyPr/>
                     <a:lstStyle/>
                     <a:p>
-                      <a:pPr marL="0" indent="0" algn="ctr">
-                        <a:buNone/>
-                      </a:pPr>
                       <a:r>
-                        <a:rPr lang="en-US" sz="1050">
-                          <a:solidFill>
-                            <a:srgbClr val="1E2761"/>
-                          </a:solidFill>
-                          <a:latin typeface="Calibri" pitchFamily="34" charset="0"/>
-                          <a:ea typeface="Calibri" pitchFamily="34" charset="-122"/>
-                          <a:cs typeface="Calibri" pitchFamily="34" charset="-120"/>
-                        </a:rPr>
                         <a:t>0.70 (70%)</a:t>
                       </a:r>
-                      <a:endParaRPr lang="en-US" sz="1050" dirty="0">
-                        <a:latin typeface="Calibri" charset="0"/>
-                        <a:ea typeface="Calibri" charset="0"/>
-                        <a:cs typeface="Calibri" charset="0"/>
-                      </a:endParaRPr>
                     </a:p>
                   </a:txBody>
                   <a:tcPr anchor="ctr">
@@ -14104,25 +13967,9 @@
                     <a:bodyPr/>
                     <a:lstStyle/>
                     <a:p>
-                      <a:pPr marL="0" indent="0" algn="ctr">
-                        <a:buNone/>
-                      </a:pPr>
                       <a:r>
-                        <a:rPr lang="en-US" sz="1050">
-                          <a:solidFill>
-                            <a:srgbClr val="1E2761"/>
-                          </a:solidFill>
-                          <a:latin typeface="Calibri" pitchFamily="34" charset="0"/>
-                          <a:ea typeface="Calibri" pitchFamily="34" charset="-122"/>
-                          <a:cs typeface="Calibri" pitchFamily="34" charset="-120"/>
-                        </a:rPr>
-                        <a:t>0.50 (50%)</a:t>
+                        <a:t>0.55 (55%)</a:t>
                       </a:r>
-                      <a:endParaRPr lang="en-US" sz="1050" dirty="0">
-                        <a:latin typeface="Calibri" charset="0"/>
-                        <a:ea typeface="Calibri" charset="0"/>
-                        <a:cs typeface="Calibri" charset="0"/>
-                      </a:endParaRPr>
                     </a:p>
                   </a:txBody>
                   <a:tcPr anchor="ctr">
@@ -14243,25 +14090,9 @@
                     <a:bodyPr/>
                     <a:lstStyle/>
                     <a:p>
-                      <a:pPr marL="0" indent="0" algn="ctr">
-                        <a:buNone/>
-                      </a:pPr>
                       <a:r>
-                        <a:rPr lang="en-US" sz="1050" dirty="0">
-                          <a:solidFill>
-                            <a:srgbClr val="1E2761"/>
-                          </a:solidFill>
-                          <a:latin typeface="Calibri" pitchFamily="34" charset="0"/>
-                          <a:ea typeface="Calibri" pitchFamily="34" charset="-122"/>
-                          <a:cs typeface="Calibri" pitchFamily="34" charset="-120"/>
-                        </a:rPr>
                         <a:t>12,0</a:t>
                       </a:r>
-                      <a:endParaRPr lang="en-US" sz="1050" dirty="0">
-                        <a:latin typeface="Calibri" charset="0"/>
-                        <a:ea typeface="Calibri" charset="0"/>
-                        <a:cs typeface="Calibri" charset="0"/>
-                      </a:endParaRPr>
                     </a:p>
                   </a:txBody>
                   <a:tcPr anchor="ctr">
@@ -14382,25 +14213,9 @@
                     <a:bodyPr/>
                     <a:lstStyle/>
                     <a:p>
-                      <a:pPr marL="0" indent="0" algn="ctr">
-                        <a:buNone/>
-                      </a:pPr>
                       <a:r>
-                        <a:rPr lang="en-US" sz="1050" dirty="0">
-                          <a:solidFill>
-                            <a:srgbClr val="1E2761"/>
-                          </a:solidFill>
-                          <a:latin typeface="Calibri" pitchFamily="34" charset="0"/>
-                          <a:ea typeface="Calibri" pitchFamily="34" charset="-122"/>
-                          <a:cs typeface="Calibri" pitchFamily="34" charset="-120"/>
-                        </a:rPr>
                         <a:t>1,5</a:t>
                       </a:r>
-                      <a:endParaRPr lang="en-US" sz="1050" dirty="0">
-                        <a:latin typeface="Calibri" charset="0"/>
-                        <a:ea typeface="Calibri" charset="0"/>
-                        <a:cs typeface="Calibri" charset="0"/>
-                      </a:endParaRPr>
                     </a:p>
                   </a:txBody>
                   <a:tcPr anchor="ctr">
@@ -15212,6 +15027,13 @@
           </a:solidFill>
           <a:ln/>
         </p:spPr>
+        <p:txBody>
+          <a:bodyPr/>
+          <a:lstStyle/>
+          <a:p>
+            <a:endParaRPr/>
+          </a:p>
+        </p:txBody>
       </p:sp>
       <p:sp>
         <p:nvSpPr>
@@ -15241,48 +15063,7 @@
               <a:buNone/>
             </a:pPr>
             <a:r>
-              <a:rPr lang="en-US" sz="1050" b="1" dirty="0">
-                <a:solidFill>
-                  <a:srgbClr val="1E2761"/>
-                </a:solidFill>
-                <a:latin typeface="Calibri" pitchFamily="34" charset="0"/>
-                <a:ea typeface="Calibri" pitchFamily="34" charset="-122"/>
-                <a:cs typeface="Calibri" pitchFamily="34" charset="-120"/>
-              </a:rPr>
-              <a:t>Horas de operação: </a:t>
-            </a:r>
-            <a:r>
-              <a:rPr lang="en-US" sz="1050" dirty="0">
-                <a:solidFill>
-                  <a:srgbClr val="5A6472"/>
-                </a:solidFill>
-                <a:latin typeface="Calibri" pitchFamily="34" charset="0"/>
-                <a:ea typeface="Calibri" pitchFamily="34" charset="-122"/>
-                <a:cs typeface="Calibri" pitchFamily="34" charset="-120"/>
-              </a:rPr>
-              <a:t>+2h/dia (Black Friday/Natal) eleva a economia para R$ 259.294,79/ano (payback 13,9 meses).   </a:t>
-            </a:r>
-            <a:r>
-              <a:rPr lang="en-US" sz="1050" b="1" dirty="0">
-                <a:solidFill>
-                  <a:srgbClr val="1E2761"/>
-                </a:solidFill>
-                <a:latin typeface="Calibri" pitchFamily="34" charset="0"/>
-                <a:ea typeface="Calibri" pitchFamily="34" charset="-122"/>
-                <a:cs typeface="Calibri" pitchFamily="34" charset="-120"/>
-              </a:rPr>
-              <a:t>CAPEX: </a:t>
-            </a:r>
-            <a:r>
-              <a:rPr lang="en-US" sz="1050" dirty="0">
-                <a:solidFill>
-                  <a:srgbClr val="5A6472"/>
-                </a:solidFill>
-                <a:latin typeface="Calibri" pitchFamily="34" charset="0"/>
-                <a:ea typeface="Calibri" pitchFamily="34" charset="-122"/>
-                <a:cs typeface="Calibri" pitchFamily="34" charset="-120"/>
-              </a:rPr>
-              <a:t>cada R$ 50 mil a mais/menos desloca o payback em ~2,7 meses, sem alterar a economia física gerada.</a:t>
+              <a:t>Horas de operação: +2h/dia (Black Friday/Natal) eleva a economia para R$ 194.362,88/ano (payback 18,5 meses).   CAPEX: fixado em R$ 300.000,00 para as 38 unidades.</a:t>
             </a:r>
             <a:endParaRPr lang="en-US" sz="1050" dirty="0"/>
           </a:p>
@@ -15309,6 +15090,13 @@
           </a:solidFill>
           <a:ln/>
         </p:spPr>
+        <p:txBody>
+          <a:bodyPr/>
+          <a:lstStyle/>
+          <a:p>
+            <a:endParaRPr/>
+          </a:p>
+        </p:txBody>
       </p:sp>
       <p:sp>
         <p:nvSpPr>
@@ -15338,48 +15126,7 @@
               <a:buNone/>
             </a:pPr>
             <a:r>
-              <a:rPr lang="en-US" sz="1150" b="1" dirty="0">
-                <a:solidFill>
-                  <a:srgbClr val="FFFFFF"/>
-                </a:solidFill>
-                <a:latin typeface="Calibri" pitchFamily="34" charset="0"/>
-                <a:ea typeface="Calibri" pitchFamily="34" charset="-122"/>
-                <a:cs typeface="Calibri" pitchFamily="34" charset="-120"/>
-              </a:rPr>
-              <a:t>Escala linear por máquina retrofitada: </a:t>
-            </a:r>
-            <a:r>
-              <a:rPr lang="en-US" sz="1150" dirty="0">
-                <a:solidFill>
-                  <a:srgbClr val="CADCFC"/>
-                </a:solidFill>
-                <a:latin typeface="Calibri" pitchFamily="34" charset="0"/>
-                <a:ea typeface="Calibri" pitchFamily="34" charset="-122"/>
-                <a:cs typeface="Calibri" pitchFamily="34" charset="-120"/>
-              </a:rPr>
-              <a:t>cada climatizador gera R$ 477,38/mês (R$ 5.728,59/ano) de economia líquida individual — 10 máquinas = R$ 57.285,90/ano; 38 máquinas (parque total) </a:t>
-            </a:r>
-            <a:r>
-              <a:rPr lang="en-US" sz="1150">
-                <a:solidFill>
-                  <a:srgbClr val="CADCFC"/>
-                </a:solidFill>
-                <a:latin typeface="Calibri" pitchFamily="34" charset="0"/>
-                <a:ea typeface="Calibri" pitchFamily="34" charset="-122"/>
-                <a:cs typeface="Calibri" pitchFamily="34" charset="-120"/>
-              </a:rPr>
-              <a:t>= R$ 217.686,42/</a:t>
-            </a:r>
-            <a:r>
-              <a:rPr lang="en-US" sz="1150" dirty="0">
-                <a:solidFill>
-                  <a:srgbClr val="CADCFC"/>
-                </a:solidFill>
-                <a:latin typeface="Calibri" pitchFamily="34" charset="0"/>
-                <a:ea typeface="Calibri" pitchFamily="34" charset="-122"/>
-                <a:cs typeface="Calibri" pitchFamily="34" charset="-120"/>
-              </a:rPr>
-              <a:t>ano.</a:t>
+              <a:t>Escala linear por máquina retrofitada: cada climatizador gera R$ 358,04/mês (R$ 4.296,44/ano) de economia líquida individual — 10 máquinas = R$ 42.964,43/ano; 38 máquinas (parque total) = R$ 163.264,82/ano.</a:t>
             </a:r>
             <a:endParaRPr lang="en-US" sz="1150" dirty="0"/>
           </a:p>
@@ -15563,6 +15310,13 @@
             </a:outerShdw>
           </a:effectLst>
         </p:spPr>
+        <p:txBody>
+          <a:bodyPr/>
+          <a:lstStyle/>
+          <a:p>
+            <a:endParaRPr/>
+          </a:p>
+        </p:txBody>
       </p:sp>
       <p:sp>
         <p:nvSpPr>
@@ -15670,6 +15424,13 @@
             </a:outerShdw>
           </a:effectLst>
         </p:spPr>
+        <p:txBody>
+          <a:bodyPr/>
+          <a:lstStyle/>
+          <a:p>
+            <a:endParaRPr/>
+          </a:p>
+        </p:txBody>
       </p:sp>
       <p:sp>
         <p:nvSpPr>
@@ -15777,6 +15538,13 @@
             </a:outerShdw>
           </a:effectLst>
         </p:spPr>
+        <p:txBody>
+          <a:bodyPr/>
+          <a:lstStyle/>
+          <a:p>
+            <a:endParaRPr/>
+          </a:p>
+        </p:txBody>
       </p:sp>
       <p:sp>
         <p:nvSpPr>
@@ -15884,6 +15652,13 @@
             </a:outerShdw>
           </a:effectLst>
         </p:spPr>
+        <p:txBody>
+          <a:bodyPr/>
+          <a:lstStyle/>
+          <a:p>
+            <a:endParaRPr/>
+          </a:p>
+        </p:txBody>
       </p:sp>
       <p:sp>
         <p:nvSpPr>
@@ -15991,6 +15766,13 @@
             </a:outerShdw>
           </a:effectLst>
         </p:spPr>
+        <p:txBody>
+          <a:bodyPr/>
+          <a:lstStyle/>
+          <a:p>
+            <a:endParaRPr/>
+          </a:p>
+        </p:txBody>
       </p:sp>
       <p:sp>
         <p:nvSpPr>
@@ -17467,6 +17249,13 @@
           </a:solidFill>
           <a:ln/>
         </p:spPr>
+        <p:txBody>
+          <a:bodyPr/>
+          <a:lstStyle/>
+          <a:p>
+            <a:endParaRPr/>
+          </a:p>
+        </p:txBody>
       </p:sp>
       <p:sp>
         <p:nvSpPr>
@@ -19391,6 +19180,13 @@
           </a:solidFill>
           <a:ln/>
         </p:spPr>
+        <p:txBody>
+          <a:bodyPr/>
+          <a:lstStyle/>
+          <a:p>
+            <a:endParaRPr/>
+          </a:p>
+        </p:txBody>
       </p:sp>
       <p:sp>
         <p:nvSpPr>
@@ -19489,6 +19285,13 @@
           </a:solidFill>
           <a:ln/>
         </p:spPr>
+        <p:txBody>
+          <a:bodyPr/>
+          <a:lstStyle/>
+          <a:p>
+            <a:endParaRPr/>
+          </a:p>
+        </p:txBody>
       </p:sp>
       <p:sp>
         <p:nvSpPr>
@@ -19587,6 +19390,13 @@
           </a:solidFill>
           <a:ln/>
         </p:spPr>
+        <p:txBody>
+          <a:bodyPr/>
+          <a:lstStyle/>
+          <a:p>
+            <a:endParaRPr/>
+          </a:p>
+        </p:txBody>
       </p:sp>
       <p:sp>
         <p:nvSpPr>

</xml_diff>